<commit_message>
Javi data training update
</commit_message>
<xml_diff>
--- a/docs/new_model_updated.pptx
+++ b/docs/new_model_updated.pptx
@@ -16,6 +16,9 @@
     <p:sldId id="264" r:id="rId10"/>
     <p:sldId id="265" r:id="rId11"/>
     <p:sldId id="266" r:id="rId12"/>
+    <p:sldId id="268" r:id="rId13"/>
+    <p:sldId id="267" r:id="rId14"/>
+    <p:sldId id="269" r:id="rId15"/>
   </p:sldIdLst>
   <p:sldSz cx="12192000" cy="6858000"/>
   <p:notesSz cx="6858000" cy="9144000"/>
@@ -114,6 +117,11 @@
       </a:defRPr>
     </a:lvl9pPr>
   </p:defaultTextStyle>
+  <p:extLst>
+    <p:ext uri="{EFAFB233-063F-42B5-8137-9DF3F51BA10A}">
+      <p15:sldGuideLst xmlns:p15="http://schemas.microsoft.com/office/powerpoint/2012/main"/>
+    </p:ext>
+  </p:extLst>
 </p:presentation>
 </file>
 
@@ -264,7 +272,7 @@
           <a:p>
             <a:fld id="{645DE4A9-078E-D646-AE8E-B01AC47AB6EA}" type="datetimeFigureOut">
               <a:rPr lang="en-US" smtClean="0"/>
-              <a:t>1/23/26</a:t>
+              <a:t>2/9/26</a:t>
             </a:fld>
             <a:endParaRPr lang="en-US"/>
           </a:p>
@@ -462,7 +470,7 @@
           <a:p>
             <a:fld id="{645DE4A9-078E-D646-AE8E-B01AC47AB6EA}" type="datetimeFigureOut">
               <a:rPr lang="en-US" smtClean="0"/>
-              <a:t>1/23/26</a:t>
+              <a:t>2/9/26</a:t>
             </a:fld>
             <a:endParaRPr lang="en-US"/>
           </a:p>
@@ -670,7 +678,7 @@
           <a:p>
             <a:fld id="{645DE4A9-078E-D646-AE8E-B01AC47AB6EA}" type="datetimeFigureOut">
               <a:rPr lang="en-US" smtClean="0"/>
-              <a:t>1/23/26</a:t>
+              <a:t>2/9/26</a:t>
             </a:fld>
             <a:endParaRPr lang="en-US"/>
           </a:p>
@@ -868,7 +876,7 @@
           <a:p>
             <a:fld id="{645DE4A9-078E-D646-AE8E-B01AC47AB6EA}" type="datetimeFigureOut">
               <a:rPr lang="en-US" smtClean="0"/>
-              <a:t>1/23/26</a:t>
+              <a:t>2/9/26</a:t>
             </a:fld>
             <a:endParaRPr lang="en-US"/>
           </a:p>
@@ -1143,7 +1151,7 @@
           <a:p>
             <a:fld id="{645DE4A9-078E-D646-AE8E-B01AC47AB6EA}" type="datetimeFigureOut">
               <a:rPr lang="en-US" smtClean="0"/>
-              <a:t>1/23/26</a:t>
+              <a:t>2/9/26</a:t>
             </a:fld>
             <a:endParaRPr lang="en-US"/>
           </a:p>
@@ -1408,7 +1416,7 @@
           <a:p>
             <a:fld id="{645DE4A9-078E-D646-AE8E-B01AC47AB6EA}" type="datetimeFigureOut">
               <a:rPr lang="en-US" smtClean="0"/>
-              <a:t>1/23/26</a:t>
+              <a:t>2/9/26</a:t>
             </a:fld>
             <a:endParaRPr lang="en-US"/>
           </a:p>
@@ -1820,7 +1828,7 @@
           <a:p>
             <a:fld id="{645DE4A9-078E-D646-AE8E-B01AC47AB6EA}" type="datetimeFigureOut">
               <a:rPr lang="en-US" smtClean="0"/>
-              <a:t>1/23/26</a:t>
+              <a:t>2/9/26</a:t>
             </a:fld>
             <a:endParaRPr lang="en-US"/>
           </a:p>
@@ -1961,7 +1969,7 @@
           <a:p>
             <a:fld id="{645DE4A9-078E-D646-AE8E-B01AC47AB6EA}" type="datetimeFigureOut">
               <a:rPr lang="en-US" smtClean="0"/>
-              <a:t>1/23/26</a:t>
+              <a:t>2/9/26</a:t>
             </a:fld>
             <a:endParaRPr lang="en-US"/>
           </a:p>
@@ -2074,7 +2082,7 @@
           <a:p>
             <a:fld id="{645DE4A9-078E-D646-AE8E-B01AC47AB6EA}" type="datetimeFigureOut">
               <a:rPr lang="en-US" smtClean="0"/>
-              <a:t>1/23/26</a:t>
+              <a:t>2/9/26</a:t>
             </a:fld>
             <a:endParaRPr lang="en-US"/>
           </a:p>
@@ -2385,7 +2393,7 @@
           <a:p>
             <a:fld id="{645DE4A9-078E-D646-AE8E-B01AC47AB6EA}" type="datetimeFigureOut">
               <a:rPr lang="en-US" smtClean="0"/>
-              <a:t>1/23/26</a:t>
+              <a:t>2/9/26</a:t>
             </a:fld>
             <a:endParaRPr lang="en-US"/>
           </a:p>
@@ -2673,7 +2681,7 @@
           <a:p>
             <a:fld id="{645DE4A9-078E-D646-AE8E-B01AC47AB6EA}" type="datetimeFigureOut">
               <a:rPr lang="en-US" smtClean="0"/>
-              <a:t>1/23/26</a:t>
+              <a:t>2/9/26</a:t>
             </a:fld>
             <a:endParaRPr lang="en-US"/>
           </a:p>
@@ -2914,7 +2922,7 @@
           <a:p>
             <a:fld id="{645DE4A9-078E-D646-AE8E-B01AC47AB6EA}" type="datetimeFigureOut">
               <a:rPr lang="en-US" smtClean="0"/>
-              <a:t>1/23/26</a:t>
+              <a:t>2/9/26</a:t>
             </a:fld>
             <a:endParaRPr lang="en-US"/>
           </a:p>
@@ -3568,6 +3576,647 @@
     <p:extLst>
       <p:ext uri="{BB962C8B-B14F-4D97-AF65-F5344CB8AC3E}">
         <p14:creationId xmlns:p14="http://schemas.microsoft.com/office/powerpoint/2010/main" val="2053766637"/>
+      </p:ext>
+    </p:extLst>
+  </p:cSld>
+  <p:clrMapOvr>
+    <a:masterClrMapping/>
+  </p:clrMapOvr>
+</p:sld>
+</file>
+
+<file path=ppt/slides/slide12.xml><?xml version="1.0" encoding="utf-8"?>
+<p:sld xmlns:a="http://schemas.openxmlformats.org/drawingml/2006/main" xmlns:r="http://schemas.openxmlformats.org/officeDocument/2006/relationships" xmlns:p="http://schemas.openxmlformats.org/presentationml/2006/main">
+  <p:cSld>
+    <p:spTree>
+      <p:nvGrpSpPr>
+        <p:cNvPr id="1" name=""/>
+        <p:cNvGrpSpPr/>
+        <p:nvPr/>
+      </p:nvGrpSpPr>
+      <p:grpSpPr>
+        <a:xfrm>
+          <a:off x="0" y="0"/>
+          <a:ext cx="0" cy="0"/>
+          <a:chOff x="0" y="0"/>
+          <a:chExt cx="0" cy="0"/>
+        </a:xfrm>
+      </p:grpSpPr>
+      <p:sp>
+        <p:nvSpPr>
+          <p:cNvPr id="2" name="Title 1">
+            <a:extLst>
+              <a:ext uri="{FF2B5EF4-FFF2-40B4-BE49-F238E27FC236}">
+                <a16:creationId xmlns:a16="http://schemas.microsoft.com/office/drawing/2014/main" id="{22A3A70F-91F6-3294-8810-A1D92119C80C}"/>
+              </a:ext>
+            </a:extLst>
+          </p:cNvPr>
+          <p:cNvSpPr>
+            <a:spLocks noGrp="1"/>
+          </p:cNvSpPr>
+          <p:nvPr>
+            <p:ph type="title"/>
+          </p:nvPr>
+        </p:nvSpPr>
+        <p:spPr/>
+        <p:txBody>
+          <a:bodyPr/>
+          <a:lstStyle/>
+          <a:p>
+            <a:r>
+              <a:rPr lang="en-US" dirty="0"/>
+              <a:t>Update Feb 9th</a:t>
+            </a:r>
+          </a:p>
+        </p:txBody>
+      </p:sp>
+      <p:sp>
+        <p:nvSpPr>
+          <p:cNvPr id="3" name="Text Placeholder 2">
+            <a:extLst>
+              <a:ext uri="{FF2B5EF4-FFF2-40B4-BE49-F238E27FC236}">
+                <a16:creationId xmlns:a16="http://schemas.microsoft.com/office/drawing/2014/main" id="{6B9D71F0-8B82-205B-FBD4-21072A57A1B3}"/>
+              </a:ext>
+            </a:extLst>
+          </p:cNvPr>
+          <p:cNvSpPr>
+            <a:spLocks noGrp="1"/>
+          </p:cNvSpPr>
+          <p:nvPr>
+            <p:ph type="body" idx="1"/>
+          </p:nvPr>
+        </p:nvSpPr>
+        <p:spPr/>
+        <p:txBody>
+          <a:bodyPr/>
+          <a:lstStyle/>
+          <a:p>
+            <a:endParaRPr lang="en-US"/>
+          </a:p>
+        </p:txBody>
+      </p:sp>
+    </p:spTree>
+    <p:extLst>
+      <p:ext uri="{BB962C8B-B14F-4D97-AF65-F5344CB8AC3E}">
+        <p14:creationId xmlns:p14="http://schemas.microsoft.com/office/powerpoint/2010/main" val="3668987643"/>
+      </p:ext>
+    </p:extLst>
+  </p:cSld>
+  <p:clrMapOvr>
+    <a:masterClrMapping/>
+  </p:clrMapOvr>
+</p:sld>
+</file>
+
+<file path=ppt/slides/slide13.xml><?xml version="1.0" encoding="utf-8"?>
+<p:sld xmlns:a="http://schemas.openxmlformats.org/drawingml/2006/main" xmlns:r="http://schemas.openxmlformats.org/officeDocument/2006/relationships" xmlns:p="http://schemas.openxmlformats.org/presentationml/2006/main">
+  <p:cSld>
+    <p:spTree>
+      <p:nvGrpSpPr>
+        <p:cNvPr id="1" name=""/>
+        <p:cNvGrpSpPr/>
+        <p:nvPr/>
+      </p:nvGrpSpPr>
+      <p:grpSpPr>
+        <a:xfrm>
+          <a:off x="0" y="0"/>
+          <a:ext cx="0" cy="0"/>
+          <a:chOff x="0" y="0"/>
+          <a:chExt cx="0" cy="0"/>
+        </a:xfrm>
+      </p:grpSpPr>
+      <p:sp>
+        <p:nvSpPr>
+          <p:cNvPr id="2" name="Title 1">
+            <a:extLst>
+              <a:ext uri="{FF2B5EF4-FFF2-40B4-BE49-F238E27FC236}">
+                <a16:creationId xmlns:a16="http://schemas.microsoft.com/office/drawing/2014/main" id="{00B36930-E61C-054D-56C3-9E3E0A45A0C7}"/>
+              </a:ext>
+            </a:extLst>
+          </p:cNvPr>
+          <p:cNvSpPr>
+            <a:spLocks noGrp="1"/>
+          </p:cNvSpPr>
+          <p:nvPr>
+            <p:ph type="title"/>
+          </p:nvPr>
+        </p:nvSpPr>
+        <p:spPr/>
+        <p:txBody>
+          <a:bodyPr/>
+          <a:lstStyle/>
+          <a:p>
+            <a:r>
+              <a:rPr lang="en-US" dirty="0"/>
+              <a:t>Model Evaluation</a:t>
+            </a:r>
+          </a:p>
+        </p:txBody>
+      </p:sp>
+      <p:pic>
+        <p:nvPicPr>
+          <p:cNvPr id="4" name="Content Placeholder 3">
+            <a:extLst>
+              <a:ext uri="{FF2B5EF4-FFF2-40B4-BE49-F238E27FC236}">
+                <a16:creationId xmlns:a16="http://schemas.microsoft.com/office/drawing/2014/main" id="{52187A2D-B3EF-1295-F79E-897A90E08254}"/>
+              </a:ext>
+            </a:extLst>
+          </p:cNvPr>
+          <p:cNvPicPr>
+            <a:picLocks noGrp="1" noChangeAspect="1"/>
+          </p:cNvPicPr>
+          <p:nvPr>
+            <p:ph idx="1"/>
+          </p:nvPr>
+        </p:nvPicPr>
+        <p:blipFill>
+          <a:blip r:embed="rId2"/>
+          <a:stretch>
+            <a:fillRect/>
+          </a:stretch>
+        </p:blipFill>
+        <p:spPr>
+          <a:xfrm>
+            <a:off x="838200" y="3055940"/>
+            <a:ext cx="10515600" cy="1890707"/>
+          </a:xfrm>
+          <a:prstGeom prst="rect">
+            <a:avLst/>
+          </a:prstGeom>
+        </p:spPr>
+      </p:pic>
+    </p:spTree>
+    <p:extLst>
+      <p:ext uri="{BB962C8B-B14F-4D97-AF65-F5344CB8AC3E}">
+        <p14:creationId xmlns:p14="http://schemas.microsoft.com/office/powerpoint/2010/main" val="2744923997"/>
+      </p:ext>
+    </p:extLst>
+  </p:cSld>
+  <p:clrMapOvr>
+    <a:masterClrMapping/>
+  </p:clrMapOvr>
+</p:sld>
+</file>
+
+<file path=ppt/slides/slide14.xml><?xml version="1.0" encoding="utf-8"?>
+<p:sld xmlns:a="http://schemas.openxmlformats.org/drawingml/2006/main" xmlns:r="http://schemas.openxmlformats.org/officeDocument/2006/relationships" xmlns:p="http://schemas.openxmlformats.org/presentationml/2006/main">
+  <p:cSld>
+    <p:bg>
+      <p:bgPr>
+        <a:solidFill>
+          <a:schemeClr val="bg1"/>
+        </a:solidFill>
+        <a:effectLst/>
+      </p:bgPr>
+    </p:bg>
+    <p:spTree>
+      <p:nvGrpSpPr>
+        <p:cNvPr id="1" name=""/>
+        <p:cNvGrpSpPr/>
+        <p:nvPr/>
+      </p:nvGrpSpPr>
+      <p:grpSpPr>
+        <a:xfrm>
+          <a:off x="0" y="0"/>
+          <a:ext cx="0" cy="0"/>
+          <a:chOff x="0" y="0"/>
+          <a:chExt cx="0" cy="0"/>
+        </a:xfrm>
+      </p:grpSpPr>
+      <p:sp useBgFill="1">
+        <p:nvSpPr>
+          <p:cNvPr id="11" name="Rectangle 10">
+            <a:extLst>
+              <a:ext uri="{FF2B5EF4-FFF2-40B4-BE49-F238E27FC236}">
+                <a16:creationId xmlns:a16="http://schemas.microsoft.com/office/drawing/2014/main" id="{2B97F24A-32CE-4C1C-A50D-3016B394DCFB}"/>
+              </a:ext>
+              <a:ext uri="{C183D7F6-B498-43B3-948B-1728B52AA6E4}">
+                <adec:decorative xmlns:adec="http://schemas.microsoft.com/office/drawing/2017/decorative" val="1"/>
+              </a:ext>
+            </a:extLst>
+          </p:cNvPr>
+          <p:cNvSpPr>
+            <a:spLocks noGrp="1" noRot="1" noChangeAspect="1" noMove="1" noResize="1" noEditPoints="1" noAdjustHandles="1" noChangeArrowheads="1" noChangeShapeType="1" noTextEdit="1"/>
+          </p:cNvSpPr>
+          <p:nvPr>
+            <p:extLst>
+              <p:ext uri="{386F3935-93C4-4BCD-93E2-E3B085C9AB24}">
+                <p16:designElem xmlns:p16="http://schemas.microsoft.com/office/powerpoint/2015/main" val="1"/>
+              </p:ext>
+            </p:extLst>
+          </p:nvPr>
+        </p:nvSpPr>
+        <p:spPr>
+          <a:xfrm>
+            <a:off x="0" y="0"/>
+            <a:ext cx="12192000" cy="6858000"/>
+          </a:xfrm>
+          <a:prstGeom prst="rect">
+            <a:avLst/>
+          </a:prstGeom>
+          <a:ln>
+            <a:noFill/>
+          </a:ln>
+        </p:spPr>
+        <p:style>
+          <a:lnRef idx="2">
+            <a:schemeClr val="accent1">
+              <a:shade val="50000"/>
+            </a:schemeClr>
+          </a:lnRef>
+          <a:fillRef idx="1">
+            <a:schemeClr val="accent1"/>
+          </a:fillRef>
+          <a:effectRef idx="0">
+            <a:schemeClr val="accent1"/>
+          </a:effectRef>
+          <a:fontRef idx="minor">
+            <a:schemeClr val="lt1"/>
+          </a:fontRef>
+        </p:style>
+        <p:txBody>
+          <a:bodyPr rtlCol="0" anchor="ctr"/>
+          <a:lstStyle/>
+          <a:p>
+            <a:pPr algn="ctr"/>
+            <a:endParaRPr lang="en-US"/>
+          </a:p>
+        </p:txBody>
+      </p:sp>
+      <p:sp>
+        <p:nvSpPr>
+          <p:cNvPr id="2" name="Title 1">
+            <a:extLst>
+              <a:ext uri="{FF2B5EF4-FFF2-40B4-BE49-F238E27FC236}">
+                <a16:creationId xmlns:a16="http://schemas.microsoft.com/office/drawing/2014/main" id="{58868281-61EE-0710-07E9-35EC45FD42C1}"/>
+              </a:ext>
+            </a:extLst>
+          </p:cNvPr>
+          <p:cNvSpPr>
+            <a:spLocks noGrp="1"/>
+          </p:cNvSpPr>
+          <p:nvPr>
+            <p:ph type="title"/>
+          </p:nvPr>
+        </p:nvSpPr>
+        <p:spPr>
+          <a:xfrm>
+            <a:off x="630936" y="639520"/>
+            <a:ext cx="3429000" cy="1719072"/>
+          </a:xfrm>
+        </p:spPr>
+        <p:txBody>
+          <a:bodyPr anchor="b">
+            <a:normAutofit/>
+          </a:bodyPr>
+          <a:lstStyle/>
+          <a:p>
+            <a:r>
+              <a:rPr lang="en-US" sz="3800"/>
+              <a:t>Most Important Features</a:t>
+            </a:r>
+          </a:p>
+        </p:txBody>
+      </p:sp>
+      <p:sp>
+        <p:nvSpPr>
+          <p:cNvPr id="13" name="sketch line">
+            <a:extLst>
+              <a:ext uri="{FF2B5EF4-FFF2-40B4-BE49-F238E27FC236}">
+                <a16:creationId xmlns:a16="http://schemas.microsoft.com/office/drawing/2014/main" id="{6357EC4F-235E-4222-A36F-C7878ACE37F2}"/>
+              </a:ext>
+              <a:ext uri="{C183D7F6-B498-43B3-948B-1728B52AA6E4}">
+                <adec:decorative xmlns:adec="http://schemas.microsoft.com/office/drawing/2017/decorative" val="1"/>
+              </a:ext>
+            </a:extLst>
+          </p:cNvPr>
+          <p:cNvSpPr>
+            <a:spLocks noGrp="1" noRot="1" noChangeAspect="1" noMove="1" noResize="1" noEditPoints="1" noAdjustHandles="1" noChangeArrowheads="1" noChangeShapeType="1" noTextEdit="1"/>
+          </p:cNvSpPr>
+          <p:nvPr>
+            <p:extLst>
+              <p:ext uri="{386F3935-93C4-4BCD-93E2-E3B085C9AB24}">
+                <p16:designElem xmlns:p16="http://schemas.microsoft.com/office/powerpoint/2015/main" val="1"/>
+              </p:ext>
+            </p:extLst>
+          </p:nvPr>
+        </p:nvSpPr>
+        <p:spPr>
+          <a:xfrm>
+            <a:off x="643278" y="2573756"/>
+            <a:ext cx="3255095" cy="18288"/>
+          </a:xfrm>
+          <a:custGeom>
+            <a:avLst/>
+            <a:gdLst>
+              <a:gd name="csX0" fmla="*/ 0 w 3255095"/>
+              <a:gd name="csY0" fmla="*/ 0 h 18288"/>
+              <a:gd name="csX1" fmla="*/ 618468 w 3255095"/>
+              <a:gd name="csY1" fmla="*/ 0 h 18288"/>
+              <a:gd name="csX2" fmla="*/ 1269487 w 3255095"/>
+              <a:gd name="csY2" fmla="*/ 0 h 18288"/>
+              <a:gd name="csX3" fmla="*/ 1953057 w 3255095"/>
+              <a:gd name="csY3" fmla="*/ 0 h 18288"/>
+              <a:gd name="csX4" fmla="*/ 2636627 w 3255095"/>
+              <a:gd name="csY4" fmla="*/ 0 h 18288"/>
+              <a:gd name="csX5" fmla="*/ 3255095 w 3255095"/>
+              <a:gd name="csY5" fmla="*/ 0 h 18288"/>
+              <a:gd name="csX6" fmla="*/ 3255095 w 3255095"/>
+              <a:gd name="csY6" fmla="*/ 18288 h 18288"/>
+              <a:gd name="csX7" fmla="*/ 2538974 w 3255095"/>
+              <a:gd name="csY7" fmla="*/ 18288 h 18288"/>
+              <a:gd name="csX8" fmla="*/ 1822853 w 3255095"/>
+              <a:gd name="csY8" fmla="*/ 18288 h 18288"/>
+              <a:gd name="csX9" fmla="*/ 1171834 w 3255095"/>
+              <a:gd name="csY9" fmla="*/ 18288 h 18288"/>
+              <a:gd name="csX10" fmla="*/ 0 w 3255095"/>
+              <a:gd name="csY10" fmla="*/ 18288 h 18288"/>
+              <a:gd name="csX11" fmla="*/ 0 w 3255095"/>
+              <a:gd name="csY11" fmla="*/ 0 h 18288"/>
+            </a:gdLst>
+            <a:ahLst/>
+            <a:cxnLst>
+              <a:cxn ang="0">
+                <a:pos x="csX0" y="csY0"/>
+              </a:cxn>
+              <a:cxn ang="0">
+                <a:pos x="csX1" y="csY1"/>
+              </a:cxn>
+              <a:cxn ang="0">
+                <a:pos x="csX2" y="csY2"/>
+              </a:cxn>
+              <a:cxn ang="0">
+                <a:pos x="csX3" y="csY3"/>
+              </a:cxn>
+              <a:cxn ang="0">
+                <a:pos x="csX4" y="csY4"/>
+              </a:cxn>
+              <a:cxn ang="0">
+                <a:pos x="csX5" y="csY5"/>
+              </a:cxn>
+              <a:cxn ang="0">
+                <a:pos x="csX6" y="csY6"/>
+              </a:cxn>
+              <a:cxn ang="0">
+                <a:pos x="csX7" y="csY7"/>
+              </a:cxn>
+              <a:cxn ang="0">
+                <a:pos x="csX8" y="csY8"/>
+              </a:cxn>
+              <a:cxn ang="0">
+                <a:pos x="csX9" y="csY9"/>
+              </a:cxn>
+              <a:cxn ang="0">
+                <a:pos x="csX10" y="csY10"/>
+              </a:cxn>
+              <a:cxn ang="0">
+                <a:pos x="csX11" y="csY11"/>
+              </a:cxn>
+            </a:cxnLst>
+            <a:rect l="l" t="t" r="r" b="b"/>
+            <a:pathLst>
+              <a:path w="3255095" h="18288" fill="none" extrusionOk="0">
+                <a:moveTo>
+                  <a:pt x="0" y="0"/>
+                </a:moveTo>
+                <a:cubicBezTo>
+                  <a:pt x="240201" y="-22123"/>
+                  <a:pt x="462021" y="-19623"/>
+                  <a:pt x="618468" y="0"/>
+                </a:cubicBezTo>
+                <a:cubicBezTo>
+                  <a:pt x="774915" y="19623"/>
+                  <a:pt x="974734" y="2035"/>
+                  <a:pt x="1269487" y="0"/>
+                </a:cubicBezTo>
+                <a:cubicBezTo>
+                  <a:pt x="1564240" y="-2035"/>
+                  <a:pt x="1733579" y="10639"/>
+                  <a:pt x="1953057" y="0"/>
+                </a:cubicBezTo>
+                <a:cubicBezTo>
+                  <a:pt x="2172535" y="-10639"/>
+                  <a:pt x="2453962" y="14018"/>
+                  <a:pt x="2636627" y="0"/>
+                </a:cubicBezTo>
+                <a:cubicBezTo>
+                  <a:pt x="2819292" y="-14018"/>
+                  <a:pt x="3121375" y="5399"/>
+                  <a:pt x="3255095" y="0"/>
+                </a:cubicBezTo>
+                <a:cubicBezTo>
+                  <a:pt x="3254386" y="8157"/>
+                  <a:pt x="3254682" y="12125"/>
+                  <a:pt x="3255095" y="18288"/>
+                </a:cubicBezTo>
+                <a:cubicBezTo>
+                  <a:pt x="3088545" y="23203"/>
+                  <a:pt x="2687475" y="7419"/>
+                  <a:pt x="2538974" y="18288"/>
+                </a:cubicBezTo>
+                <a:cubicBezTo>
+                  <a:pt x="2390473" y="29157"/>
+                  <a:pt x="2137381" y="-8959"/>
+                  <a:pt x="1822853" y="18288"/>
+                </a:cubicBezTo>
+                <a:cubicBezTo>
+                  <a:pt x="1508325" y="45535"/>
+                  <a:pt x="1466437" y="20385"/>
+                  <a:pt x="1171834" y="18288"/>
+                </a:cubicBezTo>
+                <a:cubicBezTo>
+                  <a:pt x="877231" y="16191"/>
+                  <a:pt x="561097" y="37643"/>
+                  <a:pt x="0" y="18288"/>
+                </a:cubicBezTo>
+                <a:cubicBezTo>
+                  <a:pt x="-46" y="12483"/>
+                  <a:pt x="-203" y="6491"/>
+                  <a:pt x="0" y="0"/>
+                </a:cubicBezTo>
+                <a:close/>
+              </a:path>
+              <a:path w="3255095" h="18288" stroke="0" extrusionOk="0">
+                <a:moveTo>
+                  <a:pt x="0" y="0"/>
+                </a:moveTo>
+                <a:cubicBezTo>
+                  <a:pt x="291965" y="19429"/>
+                  <a:pt x="363155" y="8568"/>
+                  <a:pt x="618468" y="0"/>
+                </a:cubicBezTo>
+                <a:cubicBezTo>
+                  <a:pt x="873781" y="-8568"/>
+                  <a:pt x="904459" y="-19505"/>
+                  <a:pt x="1171834" y="0"/>
+                </a:cubicBezTo>
+                <a:cubicBezTo>
+                  <a:pt x="1439209" y="19505"/>
+                  <a:pt x="1744369" y="9790"/>
+                  <a:pt x="1887955" y="0"/>
+                </a:cubicBezTo>
+                <a:cubicBezTo>
+                  <a:pt x="2031541" y="-9790"/>
+                  <a:pt x="2346378" y="21240"/>
+                  <a:pt x="2506423" y="0"/>
+                </a:cubicBezTo>
+                <a:cubicBezTo>
+                  <a:pt x="2666468" y="-21240"/>
+                  <a:pt x="2990257" y="30414"/>
+                  <a:pt x="3255095" y="0"/>
+                </a:cubicBezTo>
+                <a:cubicBezTo>
+                  <a:pt x="3254831" y="4493"/>
+                  <a:pt x="3255479" y="9472"/>
+                  <a:pt x="3255095" y="18288"/>
+                </a:cubicBezTo>
+                <a:cubicBezTo>
+                  <a:pt x="3120743" y="16690"/>
+                  <a:pt x="2759628" y="42462"/>
+                  <a:pt x="2604076" y="18288"/>
+                </a:cubicBezTo>
+                <a:cubicBezTo>
+                  <a:pt x="2448524" y="-5886"/>
+                  <a:pt x="2184336" y="19599"/>
+                  <a:pt x="1887955" y="18288"/>
+                </a:cubicBezTo>
+                <a:cubicBezTo>
+                  <a:pt x="1591574" y="16977"/>
+                  <a:pt x="1548845" y="6870"/>
+                  <a:pt x="1334589" y="18288"/>
+                </a:cubicBezTo>
+                <a:cubicBezTo>
+                  <a:pt x="1120333" y="29706"/>
+                  <a:pt x="996014" y="9662"/>
+                  <a:pt x="683570" y="18288"/>
+                </a:cubicBezTo>
+                <a:cubicBezTo>
+                  <a:pt x="371126" y="26914"/>
+                  <a:pt x="198687" y="16167"/>
+                  <a:pt x="0" y="18288"/>
+                </a:cubicBezTo>
+                <a:cubicBezTo>
+                  <a:pt x="843" y="9577"/>
+                  <a:pt x="371" y="6900"/>
+                  <a:pt x="0" y="0"/>
+                </a:cubicBezTo>
+                <a:close/>
+              </a:path>
+            </a:pathLst>
+          </a:custGeom>
+          <a:solidFill>
+            <a:schemeClr val="accent2"/>
+          </a:solidFill>
+          <a:ln w="38100" cap="rnd">
+            <a:solidFill>
+              <a:schemeClr val="accent2"/>
+            </a:solidFill>
+            <a:round/>
+            <a:extLst>
+              <a:ext uri="{C807C97D-BFC1-408E-A445-0C87EB9F89A2}">
+                <ask:lineSketchStyleProps xmlns:ask="http://schemas.microsoft.com/office/drawing/2018/sketchyshapes" sd="1219033472">
+                  <a:prstGeom prst="rect">
+                    <a:avLst/>
+                  </a:prstGeom>
+                  <ask:type>
+                    <ask:lineSketchFreehand/>
+                  </ask:type>
+                </ask:lineSketchStyleProps>
+              </a:ext>
+            </a:extLst>
+          </a:ln>
+        </p:spPr>
+        <p:style>
+          <a:lnRef idx="2">
+            <a:schemeClr val="accent1">
+              <a:shade val="50000"/>
+            </a:schemeClr>
+          </a:lnRef>
+          <a:fillRef idx="1">
+            <a:schemeClr val="accent1"/>
+          </a:fillRef>
+          <a:effectRef idx="0">
+            <a:schemeClr val="accent1"/>
+          </a:effectRef>
+          <a:fontRef idx="minor">
+            <a:schemeClr val="lt1"/>
+          </a:fontRef>
+        </p:style>
+        <p:txBody>
+          <a:bodyPr rtlCol="0" anchor="ctr"/>
+          <a:lstStyle/>
+          <a:p>
+            <a:pPr algn="ctr"/>
+            <a:endParaRPr lang="en-US"/>
+          </a:p>
+        </p:txBody>
+      </p:sp>
+      <p:sp>
+        <p:nvSpPr>
+          <p:cNvPr id="8" name="Content Placeholder 7">
+            <a:extLst>
+              <a:ext uri="{FF2B5EF4-FFF2-40B4-BE49-F238E27FC236}">
+                <a16:creationId xmlns:a16="http://schemas.microsoft.com/office/drawing/2014/main" id="{02617C02-693C-19FB-DF18-C6E0639B003D}"/>
+              </a:ext>
+            </a:extLst>
+          </p:cNvPr>
+          <p:cNvSpPr>
+            <a:spLocks noGrp="1"/>
+          </p:cNvSpPr>
+          <p:nvPr>
+            <p:ph idx="1"/>
+          </p:nvPr>
+        </p:nvSpPr>
+        <p:spPr>
+          <a:xfrm>
+            <a:off x="630936" y="2807208"/>
+            <a:ext cx="3429000" cy="3410712"/>
+          </a:xfrm>
+        </p:spPr>
+        <p:txBody>
+          <a:bodyPr anchor="t">
+            <a:normAutofit/>
+          </a:bodyPr>
+          <a:lstStyle/>
+          <a:p>
+            <a:endParaRPr lang="en-US" sz="2200"/>
+          </a:p>
+        </p:txBody>
+      </p:sp>
+      <p:pic>
+        <p:nvPicPr>
+          <p:cNvPr id="4" name="Content Placeholder 3">
+            <a:extLst>
+              <a:ext uri="{FF2B5EF4-FFF2-40B4-BE49-F238E27FC236}">
+                <a16:creationId xmlns:a16="http://schemas.microsoft.com/office/drawing/2014/main" id="{8F64A1D3-3D5B-8622-2363-07E01A376486}"/>
+              </a:ext>
+            </a:extLst>
+          </p:cNvPr>
+          <p:cNvPicPr>
+            <a:picLocks noChangeAspect="1"/>
+          </p:cNvPicPr>
+          <p:nvPr/>
+        </p:nvPicPr>
+        <p:blipFill>
+          <a:blip r:embed="rId2"/>
+          <a:stretch>
+            <a:fillRect/>
+          </a:stretch>
+        </p:blipFill>
+        <p:spPr>
+          <a:xfrm>
+            <a:off x="5317236" y="640080"/>
+            <a:ext cx="5577840" cy="5577840"/>
+          </a:xfrm>
+          <a:prstGeom prst="rect">
+            <a:avLst/>
+          </a:prstGeom>
+        </p:spPr>
+      </p:pic>
+    </p:spTree>
+    <p:extLst>
+      <p:ext uri="{BB962C8B-B14F-4D97-AF65-F5344CB8AC3E}">
+        <p14:creationId xmlns:p14="http://schemas.microsoft.com/office/powerpoint/2010/main" val="3723066038"/>
       </p:ext>
     </p:extLst>
   </p:cSld>

</xml_diff>

<commit_message>
update git ignore and model presentation
</commit_message>
<xml_diff>
--- a/docs/new_model_updated.pptx
+++ b/docs/new_model_updated.pptx
@@ -4,6 +4,9 @@
   <p:sldMasterIdLst>
     <p:sldMasterId id="2147483648" r:id="rId1"/>
   </p:sldMasterIdLst>
+  <p:notesMasterIdLst>
+    <p:notesMasterId r:id="rId39"/>
+  </p:notesMasterIdLst>
   <p:sldIdLst>
     <p:sldId id="256" r:id="rId2"/>
     <p:sldId id="260" r:id="rId3"/>
@@ -19,6 +22,29 @@
     <p:sldId id="268" r:id="rId13"/>
     <p:sldId id="267" r:id="rId14"/>
     <p:sldId id="269" r:id="rId15"/>
+    <p:sldId id="274" r:id="rId16"/>
+    <p:sldId id="270" r:id="rId17"/>
+    <p:sldId id="271" r:id="rId18"/>
+    <p:sldId id="272" r:id="rId19"/>
+    <p:sldId id="273" r:id="rId20"/>
+    <p:sldId id="275" r:id="rId21"/>
+    <p:sldId id="276" r:id="rId22"/>
+    <p:sldId id="277" r:id="rId23"/>
+    <p:sldId id="278" r:id="rId24"/>
+    <p:sldId id="283" r:id="rId25"/>
+    <p:sldId id="279" r:id="rId26"/>
+    <p:sldId id="280" r:id="rId27"/>
+    <p:sldId id="285" r:id="rId28"/>
+    <p:sldId id="284" r:id="rId29"/>
+    <p:sldId id="287" r:id="rId30"/>
+    <p:sldId id="292" r:id="rId31"/>
+    <p:sldId id="294" r:id="rId32"/>
+    <p:sldId id="289" r:id="rId33"/>
+    <p:sldId id="290" r:id="rId34"/>
+    <p:sldId id="301" r:id="rId35"/>
+    <p:sldId id="303" r:id="rId36"/>
+    <p:sldId id="304" r:id="rId37"/>
+    <p:sldId id="305" r:id="rId38"/>
   </p:sldIdLst>
   <p:sldSz cx="12192000" cy="6858000"/>
   <p:notesSz cx="6858000" cy="9144000"/>
@@ -125,6 +151,498 @@
 </p:presentation>
 </file>
 
+<file path=ppt/ink/ink1.xml><?xml version="1.0" encoding="utf-8"?>
+<inkml:ink xmlns:inkml="http://www.w3.org/2003/InkML">
+  <inkml:definitions>
+    <inkml:context xml:id="ctx0">
+      <inkml:inkSource xml:id="inkSrc0">
+        <inkml:traceFormat>
+          <inkml:channel name="X" type="integer" min="-2.14748E9" max="2.14748E9" units="cm"/>
+          <inkml:channel name="Y" type="integer" min="-2.14748E9" max="2.14748E9" units="cm"/>
+          <inkml:channel name="F" type="integer" max="32767" units="dev"/>
+        </inkml:traceFormat>
+        <inkml:channelProperties>
+          <inkml:channelProperty channel="X" name="resolution" value="1000" units="1/cm"/>
+          <inkml:channelProperty channel="Y" name="resolution" value="1000" units="1/cm"/>
+          <inkml:channelProperty channel="F" name="resolution" value="0" units="1/dev"/>
+        </inkml:channelProperties>
+      </inkml:inkSource>
+      <inkml:timestamp xml:id="ts0" timeString="2026-02-18T20:49:17.062"/>
+    </inkml:context>
+    <inkml:brush xml:id="br0">
+      <inkml:brushProperty name="width" value="0.035" units="cm"/>
+      <inkml:brushProperty name="height" value="0.035" units="cm"/>
+      <inkml:brushProperty name="color" value="#E71224"/>
+    </inkml:brush>
+  </inkml:definitions>
+  <inkml:trace contextRef="#ctx0" brushRef="#br0">1 16 24575,'7'2'0,"0"1"0,-2-3 0,2 0 0,0 2 0,3-2 0,10 6 0,-4-5 0,17 7 0,1-7 0,9 2 0,14-3 0,-13 0 0,12 0 0,-21 0 0,7 4 0,-1-3 0,2 3 0,14-4 0,23 4 0,-22-3 0,9 4 0,-46-5 0,-6 0 0,-8 0 0,0 0 0,6 0 0,9 0 0,5 0 0,0 0 0,5 0 0,-12 0 0,13 0 0,1 0 0,9 0 0,14 0 0,9 0 0,1 0 0,-1 0 0,-16 0 0,-16 0 0,-9 0 0,-7 0 0,1 0 0,-5 0 0,-3 0 0,-4 0 0,0 0 0,-1 0 0,7 0 0,6 4 0,36-3-6784,15 2 6784,13-3 0,-3 5 0,-35-4 0,1 4 0,-12-5 0,9 0 0,-11 0 0,7 0 6784,-9 0-6784,6 0 0,12 0 0,-23 0 0,20 0 0,-13 0 0,0 0 0,21 0 0,-37 0 0,36-4 0,-38 3 0,17-4 0,-22 3 0,2 2 0,-7-5 0,1 5 0,2-2 0,0-1 0,3 3 0,0-2 0,3-1 0,9 2 0,12-6 0,17 6 0,5 1 0,17-4 0,-12 3 0,0 2 0,12-1 0,2 0 0,14 0 0,-6 0 0,-1 0 0,-16-5 0,-24 4 0,-15-3 0,-19 1 0,-3 3 0,-5-4 0,4 3 0,-1-1 0,0 0 0,1 1 0,-1-1 0,1 0 0,3 1 0,-1-1 0,-2 0 0,1 2 0,-1-3 0,2 3 0,1 0 0,-5-2 0,2 2 0,-3-2 0,1 2 0</inkml:trace>
+</inkml:ink>
+</file>
+
+<file path=ppt/ink/ink2.xml><?xml version="1.0" encoding="utf-8"?>
+<inkml:ink xmlns:inkml="http://www.w3.org/2003/InkML">
+  <inkml:definitions>
+    <inkml:context xml:id="ctx0">
+      <inkml:inkSource xml:id="inkSrc0">
+        <inkml:traceFormat>
+          <inkml:channel name="X" type="integer" min="-2.14748E9" max="2.14748E9" units="cm"/>
+          <inkml:channel name="Y" type="integer" min="-2.14748E9" max="2.14748E9" units="cm"/>
+          <inkml:channel name="F" type="integer" max="32767" units="dev"/>
+        </inkml:traceFormat>
+        <inkml:channelProperties>
+          <inkml:channelProperty channel="X" name="resolution" value="1000" units="1/cm"/>
+          <inkml:channelProperty channel="Y" name="resolution" value="1000" units="1/cm"/>
+          <inkml:channelProperty channel="F" name="resolution" value="0" units="1/dev"/>
+        </inkml:channelProperties>
+      </inkml:inkSource>
+      <inkml:timestamp xml:id="ts0" timeString="2026-02-18T20:49:25.214"/>
+    </inkml:context>
+    <inkml:brush xml:id="br0">
+      <inkml:brushProperty name="width" value="0.035" units="cm"/>
+      <inkml:brushProperty name="height" value="0.035" units="cm"/>
+      <inkml:brushProperty name="color" value="#E71224"/>
+    </inkml:brush>
+  </inkml:definitions>
+  <inkml:trace contextRef="#ctx0" brushRef="#br0">0 52 24575,'78'-5'0,"-40"4"0,19-1 0,6 0 0,21 2 0,-4 0 0,-20 0 0,1 0 0,19 0 0,11 0 0,1 0 0,-44 4 0,15-3 0,-15 7 0,-18-7 0,24 4 0,-36-5 0,9 0 0,-6 0 0,2 0 0,0 0 0,1 0 0,-15 0 0,2 0 0,-4-2 0,-2 2 0,2-3 0,-2 3 0,1 0 0,0-2 0,1 2 0,3-5 0,3 4 0,5-2 0,7 0 0,16 2 0,4-3 0,19 4 0,-12 0 0,-3 0 0,-7 0 0,-8 0 0,-7 0 0,5 0 0,-5 0 0,0 0 0,6 0 0,-17 0 0,2 0 0,-11 0 0,0 0 0,-2 0 0,4-2 0,-3 1 0,0-1 0,-1 2 0,0 0 0,0-2 0,5 1 0,-1-3 0,15 0 0,6 1 0,22-5 0,-1 7 0,8-3 0,-17 4 0,-7 0 0,-10 0 0,-11 0 0,0 0 0,-7 0 0,0 0 0,0 0 0,6 0 0,16 0 0,-6 0 0,3 0 0,-17 0 0,-3 0 0,2 0 0,-1 0 0,0 0 0,0 0 0,-2 0 0,2 0 0,-2 0 0,2 0 0,-4-2 0,3 1 0,-3-1 0,2 2 0,0 0 0,1 0 0,27 0 0,15 0 0,33 6 0,-4-5 0,10 5 0,-5-6 0,8 5 0,8-4 0,-22 9 0,-11-9 0,-17 4 0,-25-5 0,1 0 0,-19 0 0,0 0 0,0 0 0,-1 0 0,1 0 0,0 0 0,0 0 0,-1 0 0,1 0 0,0 0 0,0 0 0,-1 0 0,1 0 0,0 0 0,13-4 0,-8 3 0,10-3 0,29 4 0,-18 0 0,52 0 0,-44 0 0,24 0 0,-6 0 0,10 0 0,22 5 0,-5-3 0,-16 3 0,-13-5 0,-34-2 0,-3 2 0,-16-3 0,0 3 0</inkml:trace>
+</inkml:ink>
+</file>
+
+<file path=ppt/notesMasters/notesMaster1.xml><?xml version="1.0" encoding="utf-8"?>
+<p:notesMaster xmlns:a="http://schemas.openxmlformats.org/drawingml/2006/main" xmlns:r="http://schemas.openxmlformats.org/officeDocument/2006/relationships" xmlns:p="http://schemas.openxmlformats.org/presentationml/2006/main">
+  <p:cSld>
+    <p:bg>
+      <p:bgRef idx="1001">
+        <a:schemeClr val="bg1"/>
+      </p:bgRef>
+    </p:bg>
+    <p:spTree>
+      <p:nvGrpSpPr>
+        <p:cNvPr id="1" name=""/>
+        <p:cNvGrpSpPr/>
+        <p:nvPr/>
+      </p:nvGrpSpPr>
+      <p:grpSpPr>
+        <a:xfrm>
+          <a:off x="0" y="0"/>
+          <a:ext cx="0" cy="0"/>
+          <a:chOff x="0" y="0"/>
+          <a:chExt cx="0" cy="0"/>
+        </a:xfrm>
+      </p:grpSpPr>
+      <p:sp>
+        <p:nvSpPr>
+          <p:cNvPr id="2" name="Header Placeholder 1"/>
+          <p:cNvSpPr>
+            <a:spLocks noGrp="1"/>
+          </p:cNvSpPr>
+          <p:nvPr>
+            <p:ph type="hdr" sz="quarter"/>
+          </p:nvPr>
+        </p:nvSpPr>
+        <p:spPr>
+          <a:xfrm>
+            <a:off x="0" y="0"/>
+            <a:ext cx="2971800" cy="458788"/>
+          </a:xfrm>
+          <a:prstGeom prst="rect">
+            <a:avLst/>
+          </a:prstGeom>
+        </p:spPr>
+        <p:txBody>
+          <a:bodyPr vert="horz" lIns="91440" tIns="45720" rIns="91440" bIns="45720" rtlCol="0"/>
+          <a:lstStyle>
+            <a:lvl1pPr algn="l">
+              <a:defRPr sz="1200"/>
+            </a:lvl1pPr>
+          </a:lstStyle>
+          <a:p>
+            <a:endParaRPr lang="en-US"/>
+          </a:p>
+        </p:txBody>
+      </p:sp>
+      <p:sp>
+        <p:nvSpPr>
+          <p:cNvPr id="3" name="Date Placeholder 2"/>
+          <p:cNvSpPr>
+            <a:spLocks noGrp="1"/>
+          </p:cNvSpPr>
+          <p:nvPr>
+            <p:ph type="dt" idx="1"/>
+          </p:nvPr>
+        </p:nvSpPr>
+        <p:spPr>
+          <a:xfrm>
+            <a:off x="3884613" y="0"/>
+            <a:ext cx="2971800" cy="458788"/>
+          </a:xfrm>
+          <a:prstGeom prst="rect">
+            <a:avLst/>
+          </a:prstGeom>
+        </p:spPr>
+        <p:txBody>
+          <a:bodyPr vert="horz" lIns="91440" tIns="45720" rIns="91440" bIns="45720" rtlCol="0"/>
+          <a:lstStyle>
+            <a:lvl1pPr algn="r">
+              <a:defRPr sz="1200"/>
+            </a:lvl1pPr>
+          </a:lstStyle>
+          <a:p>
+            <a:fld id="{CF701E17-2E66-5240-A955-5B04D468A4E8}" type="datetimeFigureOut">
+              <a:rPr lang="en-US" smtClean="0"/>
+              <a:t>3/9/26</a:t>
+            </a:fld>
+            <a:endParaRPr lang="en-US"/>
+          </a:p>
+        </p:txBody>
+      </p:sp>
+      <p:sp>
+        <p:nvSpPr>
+          <p:cNvPr id="4" name="Slide Image Placeholder 3"/>
+          <p:cNvSpPr>
+            <a:spLocks noGrp="1" noRot="1" noChangeAspect="1"/>
+          </p:cNvSpPr>
+          <p:nvPr>
+            <p:ph type="sldImg" idx="2"/>
+          </p:nvPr>
+        </p:nvSpPr>
+        <p:spPr>
+          <a:xfrm>
+            <a:off x="685800" y="1143000"/>
+            <a:ext cx="5486400" cy="3086100"/>
+          </a:xfrm>
+          <a:prstGeom prst="rect">
+            <a:avLst/>
+          </a:prstGeom>
+          <a:noFill/>
+          <a:ln w="12700">
+            <a:solidFill>
+              <a:prstClr val="black"/>
+            </a:solidFill>
+          </a:ln>
+        </p:spPr>
+        <p:txBody>
+          <a:bodyPr vert="horz" lIns="91440" tIns="45720" rIns="91440" bIns="45720" rtlCol="0" anchor="ctr"/>
+          <a:lstStyle/>
+          <a:p>
+            <a:endParaRPr lang="en-US"/>
+          </a:p>
+        </p:txBody>
+      </p:sp>
+      <p:sp>
+        <p:nvSpPr>
+          <p:cNvPr id="5" name="Notes Placeholder 4"/>
+          <p:cNvSpPr>
+            <a:spLocks noGrp="1"/>
+          </p:cNvSpPr>
+          <p:nvPr>
+            <p:ph type="body" sz="quarter" idx="3"/>
+          </p:nvPr>
+        </p:nvSpPr>
+        <p:spPr>
+          <a:xfrm>
+            <a:off x="685800" y="4400550"/>
+            <a:ext cx="5486400" cy="3600450"/>
+          </a:xfrm>
+          <a:prstGeom prst="rect">
+            <a:avLst/>
+          </a:prstGeom>
+        </p:spPr>
+        <p:txBody>
+          <a:bodyPr vert="horz" lIns="91440" tIns="45720" rIns="91440" bIns="45720" rtlCol="0"/>
+          <a:lstStyle/>
+          <a:p>
+            <a:pPr lvl="0"/>
+            <a:r>
+              <a:rPr lang="en-US"/>
+              <a:t>Click to edit Master text styles</a:t>
+            </a:r>
+          </a:p>
+          <a:p>
+            <a:pPr lvl="1"/>
+            <a:r>
+              <a:rPr lang="en-US"/>
+              <a:t>Second level</a:t>
+            </a:r>
+          </a:p>
+          <a:p>
+            <a:pPr lvl="2"/>
+            <a:r>
+              <a:rPr lang="en-US"/>
+              <a:t>Third level</a:t>
+            </a:r>
+          </a:p>
+          <a:p>
+            <a:pPr lvl="3"/>
+            <a:r>
+              <a:rPr lang="en-US"/>
+              <a:t>Fourth level</a:t>
+            </a:r>
+          </a:p>
+          <a:p>
+            <a:pPr lvl="4"/>
+            <a:r>
+              <a:rPr lang="en-US"/>
+              <a:t>Fifth level</a:t>
+            </a:r>
+          </a:p>
+        </p:txBody>
+      </p:sp>
+      <p:sp>
+        <p:nvSpPr>
+          <p:cNvPr id="6" name="Footer Placeholder 5"/>
+          <p:cNvSpPr>
+            <a:spLocks noGrp="1"/>
+          </p:cNvSpPr>
+          <p:nvPr>
+            <p:ph type="ftr" sz="quarter" idx="4"/>
+          </p:nvPr>
+        </p:nvSpPr>
+        <p:spPr>
+          <a:xfrm>
+            <a:off x="0" y="8685213"/>
+            <a:ext cx="2971800" cy="458787"/>
+          </a:xfrm>
+          <a:prstGeom prst="rect">
+            <a:avLst/>
+          </a:prstGeom>
+        </p:spPr>
+        <p:txBody>
+          <a:bodyPr vert="horz" lIns="91440" tIns="45720" rIns="91440" bIns="45720" rtlCol="0" anchor="b"/>
+          <a:lstStyle>
+            <a:lvl1pPr algn="l">
+              <a:defRPr sz="1200"/>
+            </a:lvl1pPr>
+          </a:lstStyle>
+          <a:p>
+            <a:endParaRPr lang="en-US"/>
+          </a:p>
+        </p:txBody>
+      </p:sp>
+      <p:sp>
+        <p:nvSpPr>
+          <p:cNvPr id="7" name="Slide Number Placeholder 6"/>
+          <p:cNvSpPr>
+            <a:spLocks noGrp="1"/>
+          </p:cNvSpPr>
+          <p:nvPr>
+            <p:ph type="sldNum" sz="quarter" idx="5"/>
+          </p:nvPr>
+        </p:nvSpPr>
+        <p:spPr>
+          <a:xfrm>
+            <a:off x="3884613" y="8685213"/>
+            <a:ext cx="2971800" cy="458787"/>
+          </a:xfrm>
+          <a:prstGeom prst="rect">
+            <a:avLst/>
+          </a:prstGeom>
+        </p:spPr>
+        <p:txBody>
+          <a:bodyPr vert="horz" lIns="91440" tIns="45720" rIns="91440" bIns="45720" rtlCol="0" anchor="b"/>
+          <a:lstStyle>
+            <a:lvl1pPr algn="r">
+              <a:defRPr sz="1200"/>
+            </a:lvl1pPr>
+          </a:lstStyle>
+          <a:p>
+            <a:fld id="{F10F7202-B1F8-AE49-82BB-5054280ED757}" type="slidenum">
+              <a:rPr lang="en-US" smtClean="0"/>
+              <a:t>‹#›</a:t>
+            </a:fld>
+            <a:endParaRPr lang="en-US"/>
+          </a:p>
+        </p:txBody>
+      </p:sp>
+    </p:spTree>
+    <p:extLst>
+      <p:ext uri="{BB962C8B-B14F-4D97-AF65-F5344CB8AC3E}">
+        <p14:creationId xmlns:p14="http://schemas.microsoft.com/office/powerpoint/2010/main" val="4081320595"/>
+      </p:ext>
+    </p:extLst>
+  </p:cSld>
+  <p:clrMap bg1="lt1" tx1="dk1" bg2="lt2" tx2="dk2" accent1="accent1" accent2="accent2" accent3="accent3" accent4="accent4" accent5="accent5" accent6="accent6" hlink="hlink" folHlink="folHlink"/>
+  <p:notesStyle>
+    <a:lvl1pPr marL="0" algn="l" defTabSz="914400" rtl="0" eaLnBrk="1" latinLnBrk="0" hangingPunct="1">
+      <a:defRPr sz="1200" kern="1200">
+        <a:solidFill>
+          <a:schemeClr val="tx1"/>
+        </a:solidFill>
+        <a:latin typeface="+mn-lt"/>
+        <a:ea typeface="+mn-ea"/>
+        <a:cs typeface="+mn-cs"/>
+      </a:defRPr>
+    </a:lvl1pPr>
+    <a:lvl2pPr marL="457200" algn="l" defTabSz="914400" rtl="0" eaLnBrk="1" latinLnBrk="0" hangingPunct="1">
+      <a:defRPr sz="1200" kern="1200">
+        <a:solidFill>
+          <a:schemeClr val="tx1"/>
+        </a:solidFill>
+        <a:latin typeface="+mn-lt"/>
+        <a:ea typeface="+mn-ea"/>
+        <a:cs typeface="+mn-cs"/>
+      </a:defRPr>
+    </a:lvl2pPr>
+    <a:lvl3pPr marL="914400" algn="l" defTabSz="914400" rtl="0" eaLnBrk="1" latinLnBrk="0" hangingPunct="1">
+      <a:defRPr sz="1200" kern="1200">
+        <a:solidFill>
+          <a:schemeClr val="tx1"/>
+        </a:solidFill>
+        <a:latin typeface="+mn-lt"/>
+        <a:ea typeface="+mn-ea"/>
+        <a:cs typeface="+mn-cs"/>
+      </a:defRPr>
+    </a:lvl3pPr>
+    <a:lvl4pPr marL="1371600" algn="l" defTabSz="914400" rtl="0" eaLnBrk="1" latinLnBrk="0" hangingPunct="1">
+      <a:defRPr sz="1200" kern="1200">
+        <a:solidFill>
+          <a:schemeClr val="tx1"/>
+        </a:solidFill>
+        <a:latin typeface="+mn-lt"/>
+        <a:ea typeface="+mn-ea"/>
+        <a:cs typeface="+mn-cs"/>
+      </a:defRPr>
+    </a:lvl4pPr>
+    <a:lvl5pPr marL="1828800" algn="l" defTabSz="914400" rtl="0" eaLnBrk="1" latinLnBrk="0" hangingPunct="1">
+      <a:defRPr sz="1200" kern="1200">
+        <a:solidFill>
+          <a:schemeClr val="tx1"/>
+        </a:solidFill>
+        <a:latin typeface="+mn-lt"/>
+        <a:ea typeface="+mn-ea"/>
+        <a:cs typeface="+mn-cs"/>
+      </a:defRPr>
+    </a:lvl5pPr>
+    <a:lvl6pPr marL="2286000" algn="l" defTabSz="914400" rtl="0" eaLnBrk="1" latinLnBrk="0" hangingPunct="1">
+      <a:defRPr sz="1200" kern="1200">
+        <a:solidFill>
+          <a:schemeClr val="tx1"/>
+        </a:solidFill>
+        <a:latin typeface="+mn-lt"/>
+        <a:ea typeface="+mn-ea"/>
+        <a:cs typeface="+mn-cs"/>
+      </a:defRPr>
+    </a:lvl6pPr>
+    <a:lvl7pPr marL="2743200" algn="l" defTabSz="914400" rtl="0" eaLnBrk="1" latinLnBrk="0" hangingPunct="1">
+      <a:defRPr sz="1200" kern="1200">
+        <a:solidFill>
+          <a:schemeClr val="tx1"/>
+        </a:solidFill>
+        <a:latin typeface="+mn-lt"/>
+        <a:ea typeface="+mn-ea"/>
+        <a:cs typeface="+mn-cs"/>
+      </a:defRPr>
+    </a:lvl7pPr>
+    <a:lvl8pPr marL="3200400" algn="l" defTabSz="914400" rtl="0" eaLnBrk="1" latinLnBrk="0" hangingPunct="1">
+      <a:defRPr sz="1200" kern="1200">
+        <a:solidFill>
+          <a:schemeClr val="tx1"/>
+        </a:solidFill>
+        <a:latin typeface="+mn-lt"/>
+        <a:ea typeface="+mn-ea"/>
+        <a:cs typeface="+mn-cs"/>
+      </a:defRPr>
+    </a:lvl8pPr>
+    <a:lvl9pPr marL="3657600" algn="l" defTabSz="914400" rtl="0" eaLnBrk="1" latinLnBrk="0" hangingPunct="1">
+      <a:defRPr sz="1200" kern="1200">
+        <a:solidFill>
+          <a:schemeClr val="tx1"/>
+        </a:solidFill>
+        <a:latin typeface="+mn-lt"/>
+        <a:ea typeface="+mn-ea"/>
+        <a:cs typeface="+mn-cs"/>
+      </a:defRPr>
+    </a:lvl9pPr>
+  </p:notesStyle>
+</p:notesMaster>
+</file>
+
+<file path=ppt/notesSlides/notesSlide1.xml><?xml version="1.0" encoding="utf-8"?>
+<p:notes xmlns:a="http://schemas.openxmlformats.org/drawingml/2006/main" xmlns:r="http://schemas.openxmlformats.org/officeDocument/2006/relationships" xmlns:p="http://schemas.openxmlformats.org/presentationml/2006/main">
+  <p:cSld>
+    <p:spTree>
+      <p:nvGrpSpPr>
+        <p:cNvPr id="1" name=""/>
+        <p:cNvGrpSpPr/>
+        <p:nvPr/>
+      </p:nvGrpSpPr>
+      <p:grpSpPr>
+        <a:xfrm>
+          <a:off x="0" y="0"/>
+          <a:ext cx="0" cy="0"/>
+          <a:chOff x="0" y="0"/>
+          <a:chExt cx="0" cy="0"/>
+        </a:xfrm>
+      </p:grpSpPr>
+      <p:sp>
+        <p:nvSpPr>
+          <p:cNvPr id="2" name="Slide Image Placeholder 1"/>
+          <p:cNvSpPr>
+            <a:spLocks noGrp="1" noRot="1" noChangeAspect="1"/>
+          </p:cNvSpPr>
+          <p:nvPr>
+            <p:ph type="sldImg"/>
+          </p:nvPr>
+        </p:nvSpPr>
+        <p:spPr/>
+      </p:sp>
+      <p:sp>
+        <p:nvSpPr>
+          <p:cNvPr id="3" name="Notes Placeholder 2"/>
+          <p:cNvSpPr>
+            <a:spLocks noGrp="1"/>
+          </p:cNvSpPr>
+          <p:nvPr>
+            <p:ph type="body" idx="1"/>
+          </p:nvPr>
+        </p:nvSpPr>
+        <p:spPr/>
+        <p:txBody>
+          <a:bodyPr/>
+          <a:lstStyle/>
+          <a:p>
+            <a:r>
+              <a:rPr lang="en-US" dirty="0"/>
+              <a:t>We had 41 predictors</a:t>
+            </a:r>
+          </a:p>
+        </p:txBody>
+      </p:sp>
+      <p:sp>
+        <p:nvSpPr>
+          <p:cNvPr id="4" name="Slide Number Placeholder 3"/>
+          <p:cNvSpPr>
+            <a:spLocks noGrp="1"/>
+          </p:cNvSpPr>
+          <p:nvPr>
+            <p:ph type="sldNum" sz="quarter" idx="5"/>
+          </p:nvPr>
+        </p:nvSpPr>
+        <p:spPr/>
+        <p:txBody>
+          <a:bodyPr/>
+          <a:lstStyle/>
+          <a:p>
+            <a:fld id="{F10F7202-B1F8-AE49-82BB-5054280ED757}" type="slidenum">
+              <a:rPr lang="en-US" smtClean="0"/>
+              <a:t>16</a:t>
+            </a:fld>
+            <a:endParaRPr lang="en-US"/>
+          </a:p>
+        </p:txBody>
+      </p:sp>
+    </p:spTree>
+    <p:extLst>
+      <p:ext uri="{BB962C8B-B14F-4D97-AF65-F5344CB8AC3E}">
+        <p14:creationId xmlns:p14="http://schemas.microsoft.com/office/powerpoint/2010/main" val="1858832454"/>
+      </p:ext>
+    </p:extLst>
+  </p:cSld>
+  <p:clrMapOvr>
+    <a:masterClrMapping/>
+  </p:clrMapOvr>
+</p:notes>
+</file>
+
 <file path=ppt/slideLayouts/slideLayout1.xml><?xml version="1.0" encoding="utf-8"?>
 <p:sldLayout xmlns:a="http://schemas.openxmlformats.org/drawingml/2006/main" xmlns:r="http://schemas.openxmlformats.org/officeDocument/2006/relationships" xmlns:p="http://schemas.openxmlformats.org/presentationml/2006/main" type="title" preserve="1">
   <p:cSld name="Title Slide">
@@ -272,7 +790,7 @@
           <a:p>
             <a:fld id="{645DE4A9-078E-D646-AE8E-B01AC47AB6EA}" type="datetimeFigureOut">
               <a:rPr lang="en-US" smtClean="0"/>
-              <a:t>2/9/26</a:t>
+              <a:t>3/9/26</a:t>
             </a:fld>
             <a:endParaRPr lang="en-US"/>
           </a:p>
@@ -470,7 +988,7 @@
           <a:p>
             <a:fld id="{645DE4A9-078E-D646-AE8E-B01AC47AB6EA}" type="datetimeFigureOut">
               <a:rPr lang="en-US" smtClean="0"/>
-              <a:t>2/9/26</a:t>
+              <a:t>3/9/26</a:t>
             </a:fld>
             <a:endParaRPr lang="en-US"/>
           </a:p>
@@ -678,7 +1196,7 @@
           <a:p>
             <a:fld id="{645DE4A9-078E-D646-AE8E-B01AC47AB6EA}" type="datetimeFigureOut">
               <a:rPr lang="en-US" smtClean="0"/>
-              <a:t>2/9/26</a:t>
+              <a:t>3/9/26</a:t>
             </a:fld>
             <a:endParaRPr lang="en-US"/>
           </a:p>
@@ -876,7 +1394,7 @@
           <a:p>
             <a:fld id="{645DE4A9-078E-D646-AE8E-B01AC47AB6EA}" type="datetimeFigureOut">
               <a:rPr lang="en-US" smtClean="0"/>
-              <a:t>2/9/26</a:t>
+              <a:t>3/9/26</a:t>
             </a:fld>
             <a:endParaRPr lang="en-US"/>
           </a:p>
@@ -1151,7 +1669,7 @@
           <a:p>
             <a:fld id="{645DE4A9-078E-D646-AE8E-B01AC47AB6EA}" type="datetimeFigureOut">
               <a:rPr lang="en-US" smtClean="0"/>
-              <a:t>2/9/26</a:t>
+              <a:t>3/9/26</a:t>
             </a:fld>
             <a:endParaRPr lang="en-US"/>
           </a:p>
@@ -1416,7 +1934,7 @@
           <a:p>
             <a:fld id="{645DE4A9-078E-D646-AE8E-B01AC47AB6EA}" type="datetimeFigureOut">
               <a:rPr lang="en-US" smtClean="0"/>
-              <a:t>2/9/26</a:t>
+              <a:t>3/9/26</a:t>
             </a:fld>
             <a:endParaRPr lang="en-US"/>
           </a:p>
@@ -1828,7 +2346,7 @@
           <a:p>
             <a:fld id="{645DE4A9-078E-D646-AE8E-B01AC47AB6EA}" type="datetimeFigureOut">
               <a:rPr lang="en-US" smtClean="0"/>
-              <a:t>2/9/26</a:t>
+              <a:t>3/9/26</a:t>
             </a:fld>
             <a:endParaRPr lang="en-US"/>
           </a:p>
@@ -1969,7 +2487,7 @@
           <a:p>
             <a:fld id="{645DE4A9-078E-D646-AE8E-B01AC47AB6EA}" type="datetimeFigureOut">
               <a:rPr lang="en-US" smtClean="0"/>
-              <a:t>2/9/26</a:t>
+              <a:t>3/9/26</a:t>
             </a:fld>
             <a:endParaRPr lang="en-US"/>
           </a:p>
@@ -2082,7 +2600,7 @@
           <a:p>
             <a:fld id="{645DE4A9-078E-D646-AE8E-B01AC47AB6EA}" type="datetimeFigureOut">
               <a:rPr lang="en-US" smtClean="0"/>
-              <a:t>2/9/26</a:t>
+              <a:t>3/9/26</a:t>
             </a:fld>
             <a:endParaRPr lang="en-US"/>
           </a:p>
@@ -2393,7 +2911,7 @@
           <a:p>
             <a:fld id="{645DE4A9-078E-D646-AE8E-B01AC47AB6EA}" type="datetimeFigureOut">
               <a:rPr lang="en-US" smtClean="0"/>
-              <a:t>2/9/26</a:t>
+              <a:t>3/9/26</a:t>
             </a:fld>
             <a:endParaRPr lang="en-US"/>
           </a:p>
@@ -2681,7 +3199,7 @@
           <a:p>
             <a:fld id="{645DE4A9-078E-D646-AE8E-B01AC47AB6EA}" type="datetimeFigureOut">
               <a:rPr lang="en-US" smtClean="0"/>
-              <a:t>2/9/26</a:t>
+              <a:t>3/9/26</a:t>
             </a:fld>
             <a:endParaRPr lang="en-US"/>
           </a:p>
@@ -2922,7 +3440,7 @@
           <a:p>
             <a:fld id="{645DE4A9-078E-D646-AE8E-B01AC47AB6EA}" type="datetimeFigureOut">
               <a:rPr lang="en-US" smtClean="0"/>
-              <a:t>2/9/26</a:t>
+              <a:t>3/9/26</a:t>
             </a:fld>
             <a:endParaRPr lang="en-US"/>
           </a:p>
@@ -3362,7 +3880,7 @@
           <a:p>
             <a:r>
               <a:rPr lang="en-US" dirty="0"/>
-              <a:t>Policy Index and Model Evaluation</a:t>
+              <a:t>Data and Model Updates</a:t>
             </a:r>
           </a:p>
         </p:txBody>
@@ -3388,7 +3906,16 @@
           <a:bodyPr/>
           <a:lstStyle/>
           <a:p>
-            <a:endParaRPr lang="en-US"/>
+            <a:r>
+              <a:rPr lang="en-US" dirty="0"/>
+              <a:t>Structural and policy determinants of NDC</a:t>
+            </a:r>
+          </a:p>
+          <a:p>
+            <a:r>
+              <a:rPr lang="en-US" dirty="0"/>
+              <a:t>implementation</a:t>
+            </a:r>
           </a:p>
         </p:txBody>
       </p:sp>
@@ -4226,6 +4753,1043 @@
 </p:sld>
 </file>
 
+<file path=ppt/slides/slide15.xml><?xml version="1.0" encoding="utf-8"?>
+<p:sld xmlns:a="http://schemas.openxmlformats.org/drawingml/2006/main" xmlns:r="http://schemas.openxmlformats.org/officeDocument/2006/relationships" xmlns:p="http://schemas.openxmlformats.org/presentationml/2006/main">
+  <p:cSld>
+    <p:spTree>
+      <p:nvGrpSpPr>
+        <p:cNvPr id="1" name="">
+          <a:extLst>
+            <a:ext uri="{FF2B5EF4-FFF2-40B4-BE49-F238E27FC236}">
+              <a16:creationId xmlns:a16="http://schemas.microsoft.com/office/drawing/2014/main" id="{C4376C7C-C81E-0EB0-A973-66F552CD2648}"/>
+            </a:ext>
+          </a:extLst>
+        </p:cNvPr>
+        <p:cNvGrpSpPr/>
+        <p:nvPr/>
+      </p:nvGrpSpPr>
+      <p:grpSpPr>
+        <a:xfrm>
+          <a:off x="0" y="0"/>
+          <a:ext cx="0" cy="0"/>
+          <a:chOff x="0" y="0"/>
+          <a:chExt cx="0" cy="0"/>
+        </a:xfrm>
+      </p:grpSpPr>
+      <p:sp>
+        <p:nvSpPr>
+          <p:cNvPr id="2" name="Title 1">
+            <a:extLst>
+              <a:ext uri="{FF2B5EF4-FFF2-40B4-BE49-F238E27FC236}">
+                <a16:creationId xmlns:a16="http://schemas.microsoft.com/office/drawing/2014/main" id="{A7283094-FA89-51BE-7730-71F0A8D03DBB}"/>
+              </a:ext>
+            </a:extLst>
+          </p:cNvPr>
+          <p:cNvSpPr>
+            <a:spLocks noGrp="1"/>
+          </p:cNvSpPr>
+          <p:nvPr>
+            <p:ph type="title"/>
+          </p:nvPr>
+        </p:nvSpPr>
+        <p:spPr/>
+        <p:txBody>
+          <a:bodyPr/>
+          <a:lstStyle/>
+          <a:p>
+            <a:r>
+              <a:rPr lang="en-US" dirty="0"/>
+              <a:t>Update Feb 16th</a:t>
+            </a:r>
+          </a:p>
+        </p:txBody>
+      </p:sp>
+      <p:sp>
+        <p:nvSpPr>
+          <p:cNvPr id="3" name="Text Placeholder 2">
+            <a:extLst>
+              <a:ext uri="{FF2B5EF4-FFF2-40B4-BE49-F238E27FC236}">
+                <a16:creationId xmlns:a16="http://schemas.microsoft.com/office/drawing/2014/main" id="{B948ECBE-F463-DD44-81D6-1278AB1FF8A8}"/>
+              </a:ext>
+            </a:extLst>
+          </p:cNvPr>
+          <p:cNvSpPr>
+            <a:spLocks noGrp="1"/>
+          </p:cNvSpPr>
+          <p:nvPr>
+            <p:ph type="body" idx="1"/>
+          </p:nvPr>
+        </p:nvSpPr>
+        <p:spPr/>
+        <p:txBody>
+          <a:bodyPr/>
+          <a:lstStyle/>
+          <a:p>
+            <a:endParaRPr lang="en-US"/>
+          </a:p>
+        </p:txBody>
+      </p:sp>
+    </p:spTree>
+    <p:extLst>
+      <p:ext uri="{BB962C8B-B14F-4D97-AF65-F5344CB8AC3E}">
+        <p14:creationId xmlns:p14="http://schemas.microsoft.com/office/powerpoint/2010/main" val="1292299553"/>
+      </p:ext>
+    </p:extLst>
+  </p:cSld>
+  <p:clrMapOvr>
+    <a:masterClrMapping/>
+  </p:clrMapOvr>
+</p:sld>
+</file>
+
+<file path=ppt/slides/slide16.xml><?xml version="1.0" encoding="utf-8"?>
+<p:sld xmlns:a="http://schemas.openxmlformats.org/drawingml/2006/main" xmlns:r="http://schemas.openxmlformats.org/officeDocument/2006/relationships" xmlns:p="http://schemas.openxmlformats.org/presentationml/2006/main">
+  <p:cSld>
+    <p:spTree>
+      <p:nvGrpSpPr>
+        <p:cNvPr id="1" name=""/>
+        <p:cNvGrpSpPr/>
+        <p:nvPr/>
+      </p:nvGrpSpPr>
+      <p:grpSpPr>
+        <a:xfrm>
+          <a:off x="0" y="0"/>
+          <a:ext cx="0" cy="0"/>
+          <a:chOff x="0" y="0"/>
+          <a:chExt cx="0" cy="0"/>
+        </a:xfrm>
+      </p:grpSpPr>
+      <p:sp>
+        <p:nvSpPr>
+          <p:cNvPr id="2" name="Title 1">
+            <a:extLst>
+              <a:ext uri="{FF2B5EF4-FFF2-40B4-BE49-F238E27FC236}">
+                <a16:creationId xmlns:a16="http://schemas.microsoft.com/office/drawing/2014/main" id="{302E600D-54B1-69F5-D73D-B5DBD454A706}"/>
+              </a:ext>
+            </a:extLst>
+          </p:cNvPr>
+          <p:cNvSpPr>
+            <a:spLocks noGrp="1"/>
+          </p:cNvSpPr>
+          <p:nvPr>
+            <p:ph type="title"/>
+          </p:nvPr>
+        </p:nvSpPr>
+        <p:spPr/>
+        <p:txBody>
+          <a:bodyPr/>
+          <a:lstStyle/>
+          <a:p>
+            <a:r>
+              <a:rPr lang="en-US" dirty="0"/>
+              <a:t>PCA</a:t>
+            </a:r>
+          </a:p>
+        </p:txBody>
+      </p:sp>
+      <p:pic>
+        <p:nvPicPr>
+          <p:cNvPr id="4" name="Content Placeholder 3">
+            <a:extLst>
+              <a:ext uri="{FF2B5EF4-FFF2-40B4-BE49-F238E27FC236}">
+                <a16:creationId xmlns:a16="http://schemas.microsoft.com/office/drawing/2014/main" id="{710D73BF-3286-4430-04A2-9C03A8CCBC63}"/>
+              </a:ext>
+            </a:extLst>
+          </p:cNvPr>
+          <p:cNvPicPr>
+            <a:picLocks noGrp="1" noChangeAspect="1"/>
+          </p:cNvPicPr>
+          <p:nvPr>
+            <p:ph idx="1"/>
+          </p:nvPr>
+        </p:nvPicPr>
+        <p:blipFill>
+          <a:blip r:embed="rId3"/>
+          <a:stretch>
+            <a:fillRect/>
+          </a:stretch>
+        </p:blipFill>
+        <p:spPr>
+          <a:xfrm>
+            <a:off x="1684287" y="1506969"/>
+            <a:ext cx="8823425" cy="5153583"/>
+          </a:xfrm>
+          <a:prstGeom prst="rect">
+            <a:avLst/>
+          </a:prstGeom>
+        </p:spPr>
+      </p:pic>
+    </p:spTree>
+    <p:extLst>
+      <p:ext uri="{BB962C8B-B14F-4D97-AF65-F5344CB8AC3E}">
+        <p14:creationId xmlns:p14="http://schemas.microsoft.com/office/powerpoint/2010/main" val="2233984329"/>
+      </p:ext>
+    </p:extLst>
+  </p:cSld>
+  <p:clrMapOvr>
+    <a:masterClrMapping/>
+  </p:clrMapOvr>
+</p:sld>
+</file>
+
+<file path=ppt/slides/slide17.xml><?xml version="1.0" encoding="utf-8"?>
+<p:sld xmlns:a="http://schemas.openxmlformats.org/drawingml/2006/main" xmlns:r="http://schemas.openxmlformats.org/officeDocument/2006/relationships" xmlns:p="http://schemas.openxmlformats.org/presentationml/2006/main">
+  <p:cSld>
+    <p:spTree>
+      <p:nvGrpSpPr>
+        <p:cNvPr id="1" name=""/>
+        <p:cNvGrpSpPr/>
+        <p:nvPr/>
+      </p:nvGrpSpPr>
+      <p:grpSpPr>
+        <a:xfrm>
+          <a:off x="0" y="0"/>
+          <a:ext cx="0" cy="0"/>
+          <a:chOff x="0" y="0"/>
+          <a:chExt cx="0" cy="0"/>
+        </a:xfrm>
+      </p:grpSpPr>
+      <p:sp>
+        <p:nvSpPr>
+          <p:cNvPr id="2" name="Title 1">
+            <a:extLst>
+              <a:ext uri="{FF2B5EF4-FFF2-40B4-BE49-F238E27FC236}">
+                <a16:creationId xmlns:a16="http://schemas.microsoft.com/office/drawing/2014/main" id="{FD44F2F8-A022-9564-774F-613F2A592A7A}"/>
+              </a:ext>
+            </a:extLst>
+          </p:cNvPr>
+          <p:cNvSpPr>
+            <a:spLocks noGrp="1"/>
+          </p:cNvSpPr>
+          <p:nvPr>
+            <p:ph type="title"/>
+          </p:nvPr>
+        </p:nvSpPr>
+        <p:spPr/>
+        <p:txBody>
+          <a:bodyPr/>
+          <a:lstStyle/>
+          <a:p>
+            <a:r>
+              <a:rPr lang="en-US" dirty="0"/>
+              <a:t>Correlation Analysis</a:t>
+            </a:r>
+          </a:p>
+        </p:txBody>
+      </p:sp>
+      <p:pic>
+        <p:nvPicPr>
+          <p:cNvPr id="4" name="Content Placeholder 3">
+            <a:extLst>
+              <a:ext uri="{FF2B5EF4-FFF2-40B4-BE49-F238E27FC236}">
+                <a16:creationId xmlns:a16="http://schemas.microsoft.com/office/drawing/2014/main" id="{8C06E2D1-A7D5-8B20-9055-895CC346647E}"/>
+              </a:ext>
+            </a:extLst>
+          </p:cNvPr>
+          <p:cNvPicPr>
+            <a:picLocks noGrp="1" noChangeAspect="1"/>
+          </p:cNvPicPr>
+          <p:nvPr>
+            <p:ph idx="1"/>
+          </p:nvPr>
+        </p:nvPicPr>
+        <p:blipFill>
+          <a:blip r:embed="rId2"/>
+          <a:stretch>
+            <a:fillRect/>
+          </a:stretch>
+        </p:blipFill>
+        <p:spPr>
+          <a:xfrm>
+            <a:off x="5556106" y="1677988"/>
+            <a:ext cx="5537200" cy="4191000"/>
+          </a:xfrm>
+          <a:prstGeom prst="rect">
+            <a:avLst/>
+          </a:prstGeom>
+        </p:spPr>
+      </p:pic>
+      <p:sp>
+        <p:nvSpPr>
+          <p:cNvPr id="5" name="Text Placeholder 4">
+            <a:extLst>
+              <a:ext uri="{FF2B5EF4-FFF2-40B4-BE49-F238E27FC236}">
+                <a16:creationId xmlns:a16="http://schemas.microsoft.com/office/drawing/2014/main" id="{C567E592-0C67-D462-E238-DFE4FF84A9C0}"/>
+              </a:ext>
+            </a:extLst>
+          </p:cNvPr>
+          <p:cNvSpPr>
+            <a:spLocks noGrp="1"/>
+          </p:cNvSpPr>
+          <p:nvPr>
+            <p:ph type="body" sz="half" idx="2"/>
+          </p:nvPr>
+        </p:nvSpPr>
+        <p:spPr/>
+        <p:txBody>
+          <a:bodyPr/>
+          <a:lstStyle/>
+          <a:p>
+            <a:pPr marL="285750" indent="-285750">
+              <a:buFont typeface="Arial" panose="020B0604020202020204" pitchFamily="34" charset="0"/>
+              <a:buChar char="•"/>
+            </a:pPr>
+            <a:r>
+              <a:rPr lang="en-US" dirty="0"/>
+              <a:t>Computed pairwise feature correlation</a:t>
+            </a:r>
+          </a:p>
+          <a:p>
+            <a:pPr marL="285750" indent="-285750">
+              <a:buFont typeface="Arial" panose="020B0604020202020204" pitchFamily="34" charset="0"/>
+              <a:buChar char="•"/>
+            </a:pPr>
+            <a:r>
+              <a:rPr lang="en-US" dirty="0"/>
+              <a:t>Tested removal of highly correlated features individually</a:t>
+            </a:r>
+          </a:p>
+          <a:p>
+            <a:pPr marL="285750" indent="-285750">
+              <a:buFont typeface="Arial" panose="020B0604020202020204" pitchFamily="34" charset="0"/>
+              <a:buChar char="•"/>
+            </a:pPr>
+            <a:r>
+              <a:rPr lang="en-US" dirty="0"/>
+              <a:t>Dropped features with no performance loss (or improvement)</a:t>
+            </a:r>
+          </a:p>
+        </p:txBody>
+      </p:sp>
+    </p:spTree>
+    <p:extLst>
+      <p:ext uri="{BB962C8B-B14F-4D97-AF65-F5344CB8AC3E}">
+        <p14:creationId xmlns:p14="http://schemas.microsoft.com/office/powerpoint/2010/main" val="2271154975"/>
+      </p:ext>
+    </p:extLst>
+  </p:cSld>
+  <p:clrMapOvr>
+    <a:masterClrMapping/>
+  </p:clrMapOvr>
+</p:sld>
+</file>
+
+<file path=ppt/slides/slide18.xml><?xml version="1.0" encoding="utf-8"?>
+<p:sld xmlns:a="http://schemas.openxmlformats.org/drawingml/2006/main" xmlns:r="http://schemas.openxmlformats.org/officeDocument/2006/relationships" xmlns:p="http://schemas.openxmlformats.org/presentationml/2006/main">
+  <p:cSld>
+    <p:spTree>
+      <p:nvGrpSpPr>
+        <p:cNvPr id="1" name=""/>
+        <p:cNvGrpSpPr/>
+        <p:nvPr/>
+      </p:nvGrpSpPr>
+      <p:grpSpPr>
+        <a:xfrm>
+          <a:off x="0" y="0"/>
+          <a:ext cx="0" cy="0"/>
+          <a:chOff x="0" y="0"/>
+          <a:chExt cx="0" cy="0"/>
+        </a:xfrm>
+      </p:grpSpPr>
+      <p:sp>
+        <p:nvSpPr>
+          <p:cNvPr id="2" name="Title 1">
+            <a:extLst>
+              <a:ext uri="{FF2B5EF4-FFF2-40B4-BE49-F238E27FC236}">
+                <a16:creationId xmlns:a16="http://schemas.microsoft.com/office/drawing/2014/main" id="{6D035B3D-DEE5-FFDD-980D-99BBF12D17C2}"/>
+              </a:ext>
+            </a:extLst>
+          </p:cNvPr>
+          <p:cNvSpPr>
+            <a:spLocks noGrp="1"/>
+          </p:cNvSpPr>
+          <p:nvPr>
+            <p:ph type="title"/>
+          </p:nvPr>
+        </p:nvSpPr>
+        <p:spPr/>
+        <p:txBody>
+          <a:bodyPr/>
+          <a:lstStyle/>
+          <a:p>
+            <a:r>
+              <a:rPr lang="en-US" dirty="0"/>
+              <a:t>Top Loadings in Top PCs</a:t>
+            </a:r>
+          </a:p>
+        </p:txBody>
+      </p:sp>
+      <p:sp>
+        <p:nvSpPr>
+          <p:cNvPr id="4" name="Rectangle 1">
+            <a:extLst>
+              <a:ext uri="{FF2B5EF4-FFF2-40B4-BE49-F238E27FC236}">
+                <a16:creationId xmlns:a16="http://schemas.microsoft.com/office/drawing/2014/main" id="{E3DFF8AC-64B7-B2DF-3ADB-7376E6EA22BA}"/>
+              </a:ext>
+            </a:extLst>
+          </p:cNvPr>
+          <p:cNvSpPr>
+            <a:spLocks noGrp="1" noChangeArrowheads="1"/>
+          </p:cNvSpPr>
+          <p:nvPr>
+            <p:ph idx="1"/>
+          </p:nvPr>
+        </p:nvSpPr>
+        <p:spPr bwMode="auto">
+          <a:xfrm>
+            <a:off x="838200" y="1631414"/>
+            <a:ext cx="9166412" cy="4739759"/>
+          </a:xfrm>
+          <a:prstGeom prst="rect">
+            <a:avLst/>
+          </a:prstGeom>
+          <a:noFill/>
+          <a:ln>
+            <a:noFill/>
+          </a:ln>
+          <a:effectLst/>
+          <a:extLst>
+            <a:ext uri="{909E8E84-426E-40DD-AFC4-6F175D3DCCD1}">
+              <a14:hiddenFill xmlns:a14="http://schemas.microsoft.com/office/drawing/2010/main">
+                <a:solidFill>
+                  <a:schemeClr val="accent1"/>
+                </a:solidFill>
+              </a14:hiddenFill>
+            </a:ext>
+            <a:ext uri="{91240B29-F687-4F45-9708-019B960494DF}">
+              <a14:hiddenLine xmlns:a14="http://schemas.microsoft.com/office/drawing/2010/main" w="9525">
+                <a:solidFill>
+                  <a:schemeClr val="tx1"/>
+                </a:solidFill>
+                <a:miter lim="800000"/>
+                <a:headEnd/>
+                <a:tailEnd/>
+              </a14:hiddenLine>
+            </a:ext>
+            <a:ext uri="{AF507438-7753-43E0-B8FC-AC1667EBCBE1}">
+              <a14:hiddenEffects xmlns:a14="http://schemas.microsoft.com/office/drawing/2010/main">
+                <a:effectLst>
+                  <a:outerShdw dist="35921" dir="2700000" algn="ctr" rotWithShape="0">
+                    <a:schemeClr val="bg2"/>
+                  </a:outerShdw>
+                </a:effectLst>
+              </a14:hiddenEffects>
+            </a:ext>
+          </a:extLst>
+        </p:spPr>
+        <p:txBody>
+          <a:bodyPr vert="horz" wrap="square" lIns="91440" tIns="45720" rIns="91440" bIns="45720" numCol="1" anchor="ctr" anchorCtr="0" compatLnSpc="1">
+            <a:prstTxWarp prst="textNoShape">
+              <a:avLst/>
+            </a:prstTxWarp>
+            <a:spAutoFit/>
+          </a:bodyPr>
+          <a:lstStyle>
+            <a:lvl1pPr eaLnBrk="0" fontAlgn="base" hangingPunct="0">
+              <a:spcBef>
+                <a:spcPct val="0"/>
+              </a:spcBef>
+              <a:spcAft>
+                <a:spcPct val="0"/>
+              </a:spcAft>
+              <a:defRPr>
+                <a:solidFill>
+                  <a:schemeClr val="tx1"/>
+                </a:solidFill>
+                <a:latin typeface="Arial" panose="020B0604020202020204" pitchFamily="34" charset="0"/>
+              </a:defRPr>
+            </a:lvl1pPr>
+            <a:lvl2pPr eaLnBrk="0" fontAlgn="base" hangingPunct="0">
+              <a:spcBef>
+                <a:spcPct val="0"/>
+              </a:spcBef>
+              <a:spcAft>
+                <a:spcPct val="0"/>
+              </a:spcAft>
+              <a:defRPr>
+                <a:solidFill>
+                  <a:schemeClr val="tx1"/>
+                </a:solidFill>
+                <a:latin typeface="Arial" panose="020B0604020202020204" pitchFamily="34" charset="0"/>
+              </a:defRPr>
+            </a:lvl2pPr>
+            <a:lvl3pPr eaLnBrk="0" fontAlgn="base" hangingPunct="0">
+              <a:spcBef>
+                <a:spcPct val="0"/>
+              </a:spcBef>
+              <a:spcAft>
+                <a:spcPct val="0"/>
+              </a:spcAft>
+              <a:defRPr>
+                <a:solidFill>
+                  <a:schemeClr val="tx1"/>
+                </a:solidFill>
+                <a:latin typeface="Arial" panose="020B0604020202020204" pitchFamily="34" charset="0"/>
+              </a:defRPr>
+            </a:lvl3pPr>
+            <a:lvl4pPr eaLnBrk="0" fontAlgn="base" hangingPunct="0">
+              <a:spcBef>
+                <a:spcPct val="0"/>
+              </a:spcBef>
+              <a:spcAft>
+                <a:spcPct val="0"/>
+              </a:spcAft>
+              <a:defRPr>
+                <a:solidFill>
+                  <a:schemeClr val="tx1"/>
+                </a:solidFill>
+                <a:latin typeface="Arial" panose="020B0604020202020204" pitchFamily="34" charset="0"/>
+              </a:defRPr>
+            </a:lvl4pPr>
+            <a:lvl5pPr eaLnBrk="0" fontAlgn="base" hangingPunct="0">
+              <a:spcBef>
+                <a:spcPct val="0"/>
+              </a:spcBef>
+              <a:spcAft>
+                <a:spcPct val="0"/>
+              </a:spcAft>
+              <a:defRPr>
+                <a:solidFill>
+                  <a:schemeClr val="tx1"/>
+                </a:solidFill>
+                <a:latin typeface="Arial" panose="020B0604020202020204" pitchFamily="34" charset="0"/>
+              </a:defRPr>
+            </a:lvl5pPr>
+            <a:lvl6pPr eaLnBrk="0" fontAlgn="base" hangingPunct="0">
+              <a:spcBef>
+                <a:spcPct val="0"/>
+              </a:spcBef>
+              <a:spcAft>
+                <a:spcPct val="0"/>
+              </a:spcAft>
+              <a:defRPr>
+                <a:solidFill>
+                  <a:schemeClr val="tx1"/>
+                </a:solidFill>
+                <a:latin typeface="Arial" panose="020B0604020202020204" pitchFamily="34" charset="0"/>
+              </a:defRPr>
+            </a:lvl6pPr>
+            <a:lvl7pPr eaLnBrk="0" fontAlgn="base" hangingPunct="0">
+              <a:spcBef>
+                <a:spcPct val="0"/>
+              </a:spcBef>
+              <a:spcAft>
+                <a:spcPct val="0"/>
+              </a:spcAft>
+              <a:defRPr>
+                <a:solidFill>
+                  <a:schemeClr val="tx1"/>
+                </a:solidFill>
+                <a:latin typeface="Arial" panose="020B0604020202020204" pitchFamily="34" charset="0"/>
+              </a:defRPr>
+            </a:lvl7pPr>
+            <a:lvl8pPr eaLnBrk="0" fontAlgn="base" hangingPunct="0">
+              <a:spcBef>
+                <a:spcPct val="0"/>
+              </a:spcBef>
+              <a:spcAft>
+                <a:spcPct val="0"/>
+              </a:spcAft>
+              <a:defRPr>
+                <a:solidFill>
+                  <a:schemeClr val="tx1"/>
+                </a:solidFill>
+                <a:latin typeface="Arial" panose="020B0604020202020204" pitchFamily="34" charset="0"/>
+              </a:defRPr>
+            </a:lvl8pPr>
+            <a:lvl9pPr eaLnBrk="0" fontAlgn="base" hangingPunct="0">
+              <a:spcBef>
+                <a:spcPct val="0"/>
+              </a:spcBef>
+              <a:spcAft>
+                <a:spcPct val="0"/>
+              </a:spcAft>
+              <a:defRPr>
+                <a:solidFill>
+                  <a:schemeClr val="tx1"/>
+                </a:solidFill>
+                <a:latin typeface="Arial" panose="020B0604020202020204" pitchFamily="34" charset="0"/>
+              </a:defRPr>
+            </a:lvl9pPr>
+          </a:lstStyle>
+          <a:p>
+            <a:pPr>
+              <a:lnSpc>
+                <a:spcPct val="100000"/>
+              </a:lnSpc>
+            </a:pPr>
+            <a:r>
+              <a:rPr kumimoji="0" lang="en-MX" altLang="en-MX" sz="1800" b="1" i="0" u="none" strike="noStrike" cap="none" normalizeH="0" baseline="0" dirty="0">
+                <a:ln>
+                  <a:noFill/>
+                </a:ln>
+                <a:effectLst/>
+                <a:latin typeface="Arial" panose="020B0604020202020204" pitchFamily="34" charset="0"/>
+              </a:rPr>
+              <a:t>PC1 — Vulnerability and institutional capacity to act</a:t>
+            </a:r>
+            <a:endParaRPr kumimoji="0" lang="en-MX" altLang="en-MX" sz="1800" b="0" i="0" u="none" strike="noStrike" cap="none" normalizeH="0" baseline="0" dirty="0">
+              <a:ln>
+                <a:noFill/>
+              </a:ln>
+              <a:effectLst/>
+              <a:latin typeface="Arial" panose="020B0604020202020204" pitchFamily="34" charset="0"/>
+            </a:endParaRPr>
+          </a:p>
+          <a:p>
+            <a:pPr lvl="1">
+              <a:lnSpc>
+                <a:spcPct val="100000"/>
+              </a:lnSpc>
+            </a:pPr>
+            <a:r>
+              <a:rPr kumimoji="0" lang="en-MX" altLang="en-MX" sz="1400" b="0" i="0" u="none" strike="noStrike" cap="none" normalizeH="0" baseline="0" dirty="0">
+                <a:ln>
+                  <a:noFill/>
+                </a:ln>
+                <a:effectLst/>
+                <a:latin typeface="Arial" panose="020B0604020202020204" pitchFamily="34" charset="0"/>
+              </a:rPr>
+              <a:t>ND-GAIN score</a:t>
+            </a:r>
+          </a:p>
+          <a:p>
+            <a:pPr lvl="1">
+              <a:lnSpc>
+                <a:spcPct val="100000"/>
+              </a:lnSpc>
+            </a:pPr>
+            <a:r>
+              <a:rPr kumimoji="0" lang="en-MX" altLang="en-MX" sz="1400" b="0" i="0" u="none" strike="noStrike" cap="none" normalizeH="0" baseline="0" dirty="0">
+                <a:ln>
+                  <a:noFill/>
+                </a:ln>
+                <a:effectLst/>
+                <a:latin typeface="Arial" panose="020B0604020202020204" pitchFamily="34" charset="0"/>
+              </a:rPr>
+              <a:t>Government effectiveness</a:t>
+            </a:r>
+          </a:p>
+          <a:p>
+            <a:pPr>
+              <a:lnSpc>
+                <a:spcPct val="100000"/>
+              </a:lnSpc>
+            </a:pPr>
+            <a:r>
+              <a:rPr kumimoji="0" lang="en-MX" altLang="en-MX" sz="1800" b="1" i="0" u="none" strike="noStrike" cap="none" normalizeH="0" baseline="0" dirty="0">
+                <a:ln>
+                  <a:noFill/>
+                </a:ln>
+                <a:effectLst/>
+                <a:latin typeface="Arial" panose="020B0604020202020204" pitchFamily="34" charset="0"/>
+              </a:rPr>
+              <a:t>PC2 — Fossil-fuel electricity generation</a:t>
+            </a:r>
+            <a:endParaRPr kumimoji="0" lang="en-MX" altLang="en-MX" sz="1800" b="0" i="0" u="none" strike="noStrike" cap="none" normalizeH="0" baseline="0" dirty="0">
+              <a:ln>
+                <a:noFill/>
+              </a:ln>
+              <a:effectLst/>
+              <a:latin typeface="Arial" panose="020B0604020202020204" pitchFamily="34" charset="0"/>
+            </a:endParaRPr>
+          </a:p>
+          <a:p>
+            <a:pPr lvl="1">
+              <a:lnSpc>
+                <a:spcPct val="100000"/>
+              </a:lnSpc>
+            </a:pPr>
+            <a:r>
+              <a:rPr kumimoji="0" lang="en-MX" altLang="en-MX" sz="1400" b="0" i="0" u="none" strike="noStrike" cap="none" normalizeH="0" baseline="0" dirty="0">
+                <a:ln>
+                  <a:noFill/>
+                </a:ln>
+                <a:effectLst/>
+                <a:latin typeface="Arial" panose="020B0604020202020204" pitchFamily="34" charset="0"/>
+              </a:rPr>
+              <a:t>Gas generation share</a:t>
+            </a:r>
+          </a:p>
+          <a:p>
+            <a:pPr lvl="1">
+              <a:lnSpc>
+                <a:spcPct val="100000"/>
+              </a:lnSpc>
+            </a:pPr>
+            <a:r>
+              <a:rPr kumimoji="0" lang="en-MX" altLang="en-MX" sz="1400" b="0" i="0" u="none" strike="noStrike" cap="none" normalizeH="0" baseline="0" dirty="0">
+                <a:ln>
+                  <a:noFill/>
+                </a:ln>
+                <a:effectLst/>
+                <a:latin typeface="Arial" panose="020B0604020202020204" pitchFamily="34" charset="0"/>
+              </a:rPr>
+              <a:t>Coal generation share</a:t>
+            </a:r>
+          </a:p>
+          <a:p>
+            <a:pPr>
+              <a:lnSpc>
+                <a:spcPct val="100000"/>
+              </a:lnSpc>
+            </a:pPr>
+            <a:r>
+              <a:rPr kumimoji="0" lang="en-MX" altLang="en-MX" sz="1800" b="1" i="0" u="none" strike="noStrike" cap="none" normalizeH="0" baseline="0" dirty="0">
+                <a:ln>
+                  <a:noFill/>
+                </a:ln>
+                <a:effectLst/>
+                <a:latin typeface="Arial" panose="020B0604020202020204" pitchFamily="34" charset="0"/>
+              </a:rPr>
+              <a:t>PC3 — Renewable vs. fossil electricity mix</a:t>
+            </a:r>
+            <a:endParaRPr kumimoji="0" lang="en-MX" altLang="en-MX" sz="1800" b="0" i="0" u="none" strike="noStrike" cap="none" normalizeH="0" baseline="0" dirty="0">
+              <a:ln>
+                <a:noFill/>
+              </a:ln>
+              <a:effectLst/>
+              <a:latin typeface="Arial" panose="020B0604020202020204" pitchFamily="34" charset="0"/>
+            </a:endParaRPr>
+          </a:p>
+          <a:p>
+            <a:pPr lvl="1">
+              <a:lnSpc>
+                <a:spcPct val="100000"/>
+              </a:lnSpc>
+            </a:pPr>
+            <a:r>
+              <a:rPr kumimoji="0" lang="en-MX" altLang="en-MX" sz="1400" b="0" i="0" u="none" strike="noStrike" cap="none" normalizeH="0" baseline="0" dirty="0">
+                <a:ln>
+                  <a:noFill/>
+                </a:ln>
+                <a:effectLst/>
+                <a:latin typeface="Arial" panose="020B0604020202020204" pitchFamily="34" charset="0"/>
+              </a:rPr>
+              <a:t>Renewable generation share</a:t>
+            </a:r>
+          </a:p>
+          <a:p>
+            <a:pPr lvl="1">
+              <a:lnSpc>
+                <a:spcPct val="100000"/>
+              </a:lnSpc>
+            </a:pPr>
+            <a:r>
+              <a:rPr kumimoji="0" lang="en-MX" altLang="en-MX" sz="1400" b="0" i="0" u="none" strike="noStrike" cap="none" normalizeH="0" baseline="0" dirty="0">
+                <a:ln>
+                  <a:noFill/>
+                </a:ln>
+                <a:effectLst/>
+                <a:latin typeface="Arial" panose="020B0604020202020204" pitchFamily="34" charset="0"/>
+              </a:rPr>
+              <a:t>Fossil-fuel generation share</a:t>
+            </a:r>
+          </a:p>
+          <a:p>
+            <a:pPr>
+              <a:lnSpc>
+                <a:spcPct val="100000"/>
+              </a:lnSpc>
+            </a:pPr>
+            <a:r>
+              <a:rPr kumimoji="0" lang="en-MX" altLang="en-MX" sz="1800" b="1" i="0" u="none" strike="noStrike" cap="none" normalizeH="0" baseline="0" dirty="0">
+                <a:ln>
+                  <a:noFill/>
+                </a:ln>
+                <a:effectLst/>
+                <a:latin typeface="Arial" panose="020B0604020202020204" pitchFamily="34" charset="0"/>
+              </a:rPr>
+              <a:t>PC4 — Climate policy adoption</a:t>
+            </a:r>
+            <a:endParaRPr kumimoji="0" lang="en-MX" altLang="en-MX" sz="1800" b="0" i="0" u="none" strike="noStrike" cap="none" normalizeH="0" baseline="0" dirty="0">
+              <a:ln>
+                <a:noFill/>
+              </a:ln>
+              <a:effectLst/>
+              <a:latin typeface="Arial" panose="020B0604020202020204" pitchFamily="34" charset="0"/>
+            </a:endParaRPr>
+          </a:p>
+          <a:p>
+            <a:pPr lvl="1">
+              <a:lnSpc>
+                <a:spcPct val="100000"/>
+              </a:lnSpc>
+            </a:pPr>
+            <a:r>
+              <a:rPr kumimoji="0" lang="en-MX" altLang="en-MX" sz="1400" b="0" i="0" u="none" strike="noStrike" cap="none" normalizeH="0" baseline="0" dirty="0">
+                <a:ln>
+                  <a:noFill/>
+                </a:ln>
+                <a:effectLst/>
+                <a:latin typeface="Arial" panose="020B0604020202020204" pitchFamily="34" charset="0"/>
+              </a:rPr>
+              <a:t>Cumulative number of climate laws</a:t>
+            </a:r>
+          </a:p>
+          <a:p>
+            <a:pPr lvl="1">
+              <a:lnSpc>
+                <a:spcPct val="100000"/>
+              </a:lnSpc>
+            </a:pPr>
+            <a:r>
+              <a:rPr kumimoji="0" lang="en-MX" altLang="en-MX" sz="1400" b="0" i="0" u="none" strike="noStrike" cap="none" normalizeH="0" baseline="0" dirty="0">
+                <a:ln>
+                  <a:noFill/>
+                </a:ln>
+                <a:effectLst/>
+                <a:latin typeface="Arial" panose="020B0604020202020204" pitchFamily="34" charset="0"/>
+              </a:rPr>
+              <a:t>Presence of climate framework law</a:t>
+            </a:r>
+          </a:p>
+          <a:p>
+            <a:pPr>
+              <a:lnSpc>
+                <a:spcPct val="100000"/>
+              </a:lnSpc>
+            </a:pPr>
+            <a:r>
+              <a:rPr kumimoji="0" lang="en-MX" altLang="en-MX" sz="1800" b="1" i="0" u="none" strike="noStrike" cap="none" normalizeH="0" baseline="0" dirty="0">
+                <a:ln>
+                  <a:noFill/>
+                </a:ln>
+                <a:effectLst/>
+                <a:latin typeface="Arial" panose="020B0604020202020204" pitchFamily="34" charset="0"/>
+              </a:rPr>
+              <a:t>PC5 — Land use</a:t>
+            </a:r>
+            <a:endParaRPr kumimoji="0" lang="en-MX" altLang="en-MX" sz="1800" b="0" i="0" u="none" strike="noStrike" cap="none" normalizeH="0" baseline="0" dirty="0">
+              <a:ln>
+                <a:noFill/>
+              </a:ln>
+              <a:effectLst/>
+              <a:latin typeface="Arial" panose="020B0604020202020204" pitchFamily="34" charset="0"/>
+            </a:endParaRPr>
+          </a:p>
+          <a:p>
+            <a:pPr lvl="1">
+              <a:lnSpc>
+                <a:spcPct val="100000"/>
+              </a:lnSpc>
+            </a:pPr>
+            <a:r>
+              <a:rPr kumimoji="0" lang="en-MX" altLang="en-MX" sz="1400" b="0" i="0" u="none" strike="noStrike" cap="none" normalizeH="0" baseline="0" dirty="0">
+                <a:ln>
+                  <a:noFill/>
+                </a:ln>
+                <a:effectLst/>
+                <a:latin typeface="Arial" panose="020B0604020202020204" pitchFamily="34" charset="0"/>
+              </a:rPr>
+              <a:t>Agricultural land share of total area</a:t>
+            </a:r>
+          </a:p>
+          <a:p>
+            <a:pPr lvl="1">
+              <a:lnSpc>
+                <a:spcPct val="100000"/>
+              </a:lnSpc>
+            </a:pPr>
+            <a:r>
+              <a:rPr kumimoji="0" lang="en-MX" altLang="en-MX" sz="1400" b="0" i="0" u="none" strike="noStrike" cap="none" normalizeH="0" baseline="0" dirty="0">
+                <a:ln>
+                  <a:noFill/>
+                </a:ln>
+                <a:effectLst/>
+                <a:latin typeface="Arial" panose="020B0604020202020204" pitchFamily="34" charset="0"/>
+              </a:rPr>
+              <a:t>Forest area share of total area</a:t>
+            </a:r>
+          </a:p>
+          <a:p>
+            <a:pPr>
+              <a:lnSpc>
+                <a:spcPct val="100000"/>
+              </a:lnSpc>
+            </a:pPr>
+            <a:r>
+              <a:rPr kumimoji="0" lang="en-MX" altLang="en-MX" sz="1800" b="1" i="0" u="none" strike="noStrike" cap="none" normalizeH="0" baseline="0" dirty="0">
+                <a:ln>
+                  <a:noFill/>
+                </a:ln>
+                <a:effectLst/>
+                <a:latin typeface="Arial" panose="020B0604020202020204" pitchFamily="34" charset="0"/>
+              </a:rPr>
+              <a:t>PC6 — Carbon pricing policy</a:t>
+            </a:r>
+            <a:endParaRPr kumimoji="0" lang="en-MX" altLang="en-MX" sz="1800" b="0" i="0" u="none" strike="noStrike" cap="none" normalizeH="0" baseline="0" dirty="0">
+              <a:ln>
+                <a:noFill/>
+              </a:ln>
+              <a:effectLst/>
+              <a:latin typeface="Arial" panose="020B0604020202020204" pitchFamily="34" charset="0"/>
+            </a:endParaRPr>
+          </a:p>
+          <a:p>
+            <a:pPr lvl="1">
+              <a:lnSpc>
+                <a:spcPct val="100000"/>
+              </a:lnSpc>
+            </a:pPr>
+            <a:r>
+              <a:rPr kumimoji="0" lang="en-MX" altLang="en-MX" sz="1400" b="0" i="0" u="none" strike="noStrike" cap="none" normalizeH="0" baseline="0" dirty="0">
+                <a:ln>
+                  <a:noFill/>
+                </a:ln>
+                <a:effectLst/>
+                <a:latin typeface="Arial" panose="020B0604020202020204" pitchFamily="34" charset="0"/>
+              </a:rPr>
+              <a:t>Carbon pricing coverage</a:t>
+            </a:r>
+          </a:p>
+          <a:p>
+            <a:pPr lvl="1">
+              <a:lnSpc>
+                <a:spcPct val="100000"/>
+              </a:lnSpc>
+            </a:pPr>
+            <a:r>
+              <a:rPr kumimoji="0" lang="en-MX" altLang="en-MX" sz="1400" b="0" i="0" u="none" strike="noStrike" cap="none" normalizeH="0" baseline="0" dirty="0">
+                <a:ln>
+                  <a:noFill/>
+                </a:ln>
+                <a:effectLst/>
+                <a:latin typeface="Arial" panose="020B0604020202020204" pitchFamily="34" charset="0"/>
+              </a:rPr>
+              <a:t>Presence of ETS</a:t>
+            </a:r>
+          </a:p>
+          <a:p>
+            <a:pPr marL="0" marR="0" lvl="0" indent="0" algn="l" defTabSz="914400" rtl="0" eaLnBrk="0" fontAlgn="base" latinLnBrk="0" hangingPunct="0">
+              <a:lnSpc>
+                <a:spcPct val="100000"/>
+              </a:lnSpc>
+              <a:spcBef>
+                <a:spcPct val="0"/>
+              </a:spcBef>
+              <a:spcAft>
+                <a:spcPct val="0"/>
+              </a:spcAft>
+              <a:buClrTx/>
+              <a:buSzTx/>
+              <a:buFontTx/>
+              <a:buNone/>
+              <a:tabLst/>
+            </a:pPr>
+            <a:endParaRPr kumimoji="0" lang="en-MX" altLang="en-MX" sz="1800" b="0" i="0" u="none" strike="noStrike" cap="none" normalizeH="0" baseline="0" dirty="0">
+              <a:ln>
+                <a:noFill/>
+              </a:ln>
+              <a:effectLst/>
+              <a:latin typeface="Arial" panose="020B0604020202020204" pitchFamily="34" charset="0"/>
+            </a:endParaRPr>
+          </a:p>
+        </p:txBody>
+      </p:sp>
+    </p:spTree>
+    <p:extLst>
+      <p:ext uri="{BB962C8B-B14F-4D97-AF65-F5344CB8AC3E}">
+        <p14:creationId xmlns:p14="http://schemas.microsoft.com/office/powerpoint/2010/main" val="440547678"/>
+      </p:ext>
+    </p:extLst>
+  </p:cSld>
+  <p:clrMapOvr>
+    <a:masterClrMapping/>
+  </p:clrMapOvr>
+</p:sld>
+</file>
+
+<file path=ppt/slides/slide19.xml><?xml version="1.0" encoding="utf-8"?>
+<p:sld xmlns:a="http://schemas.openxmlformats.org/drawingml/2006/main" xmlns:r="http://schemas.openxmlformats.org/officeDocument/2006/relationships" xmlns:p="http://schemas.openxmlformats.org/presentationml/2006/main">
+  <p:cSld>
+    <p:spTree>
+      <p:nvGrpSpPr>
+        <p:cNvPr id="1" name=""/>
+        <p:cNvGrpSpPr/>
+        <p:nvPr/>
+      </p:nvGrpSpPr>
+      <p:grpSpPr>
+        <a:xfrm>
+          <a:off x="0" y="0"/>
+          <a:ext cx="0" cy="0"/>
+          <a:chOff x="0" y="0"/>
+          <a:chExt cx="0" cy="0"/>
+        </a:xfrm>
+      </p:grpSpPr>
+      <p:sp>
+        <p:nvSpPr>
+          <p:cNvPr id="2" name="Title 1">
+            <a:extLst>
+              <a:ext uri="{FF2B5EF4-FFF2-40B4-BE49-F238E27FC236}">
+                <a16:creationId xmlns:a16="http://schemas.microsoft.com/office/drawing/2014/main" id="{CAC5615E-16DC-6F87-76E0-F11B12BCA83F}"/>
+              </a:ext>
+            </a:extLst>
+          </p:cNvPr>
+          <p:cNvSpPr>
+            <a:spLocks noGrp="1"/>
+          </p:cNvSpPr>
+          <p:nvPr>
+            <p:ph type="title"/>
+          </p:nvPr>
+        </p:nvSpPr>
+        <p:spPr/>
+        <p:txBody>
+          <a:bodyPr/>
+          <a:lstStyle/>
+          <a:p>
+            <a:r>
+              <a:rPr lang="en-US" dirty="0"/>
+              <a:t>Train-test Metrics with Cleaner Feature Set</a:t>
+            </a:r>
+          </a:p>
+        </p:txBody>
+      </p:sp>
+      <p:pic>
+        <p:nvPicPr>
+          <p:cNvPr id="4" name="Content Placeholder 3">
+            <a:extLst>
+              <a:ext uri="{FF2B5EF4-FFF2-40B4-BE49-F238E27FC236}">
+                <a16:creationId xmlns:a16="http://schemas.microsoft.com/office/drawing/2014/main" id="{A3F1E076-4069-F978-D11A-BF111639DAA4}"/>
+              </a:ext>
+            </a:extLst>
+          </p:cNvPr>
+          <p:cNvPicPr>
+            <a:picLocks noGrp="1" noChangeAspect="1"/>
+          </p:cNvPicPr>
+          <p:nvPr>
+            <p:ph idx="1"/>
+          </p:nvPr>
+        </p:nvPicPr>
+        <p:blipFill>
+          <a:blip r:embed="rId2"/>
+          <a:stretch>
+            <a:fillRect/>
+          </a:stretch>
+        </p:blipFill>
+        <p:spPr>
+          <a:xfrm>
+            <a:off x="838200" y="3088401"/>
+            <a:ext cx="10515600" cy="1825785"/>
+          </a:xfrm>
+          <a:prstGeom prst="rect">
+            <a:avLst/>
+          </a:prstGeom>
+        </p:spPr>
+      </p:pic>
+    </p:spTree>
+    <p:extLst>
+      <p:ext uri="{BB962C8B-B14F-4D97-AF65-F5344CB8AC3E}">
+        <p14:creationId xmlns:p14="http://schemas.microsoft.com/office/powerpoint/2010/main" val="2695976627"/>
+      </p:ext>
+    </p:extLst>
+  </p:cSld>
+  <p:clrMapOvr>
+    <a:masterClrMapping/>
+  </p:clrMapOvr>
+</p:sld>
+</file>
+
 <file path=ppt/slides/slide2.xml><?xml version="1.0" encoding="utf-8"?>
 <p:sld xmlns:a="http://schemas.openxmlformats.org/drawingml/2006/main" xmlns:r="http://schemas.openxmlformats.org/officeDocument/2006/relationships" xmlns:p="http://schemas.openxmlformats.org/presentationml/2006/main">
   <p:cSld>
@@ -4327,6 +5891,1366 @@
     <p:extLst>
       <p:ext uri="{BB962C8B-B14F-4D97-AF65-F5344CB8AC3E}">
         <p14:creationId xmlns:p14="http://schemas.microsoft.com/office/powerpoint/2010/main" val="1725363406"/>
+      </p:ext>
+    </p:extLst>
+  </p:cSld>
+  <p:clrMapOvr>
+    <a:masterClrMapping/>
+  </p:clrMapOvr>
+</p:sld>
+</file>
+
+<file path=ppt/slides/slide20.xml><?xml version="1.0" encoding="utf-8"?>
+<p:sld xmlns:a="http://schemas.openxmlformats.org/drawingml/2006/main" xmlns:r="http://schemas.openxmlformats.org/officeDocument/2006/relationships" xmlns:p="http://schemas.openxmlformats.org/presentationml/2006/main">
+  <p:cSld>
+    <p:spTree>
+      <p:nvGrpSpPr>
+        <p:cNvPr id="1" name=""/>
+        <p:cNvGrpSpPr/>
+        <p:nvPr/>
+      </p:nvGrpSpPr>
+      <p:grpSpPr>
+        <a:xfrm>
+          <a:off x="0" y="0"/>
+          <a:ext cx="0" cy="0"/>
+          <a:chOff x="0" y="0"/>
+          <a:chExt cx="0" cy="0"/>
+        </a:xfrm>
+      </p:grpSpPr>
+      <p:sp>
+        <p:nvSpPr>
+          <p:cNvPr id="2" name="Title 1">
+            <a:extLst>
+              <a:ext uri="{FF2B5EF4-FFF2-40B4-BE49-F238E27FC236}">
+                <a16:creationId xmlns:a16="http://schemas.microsoft.com/office/drawing/2014/main" id="{E6D39538-854B-D575-DF99-076C8E9A5CEE}"/>
+              </a:ext>
+            </a:extLst>
+          </p:cNvPr>
+          <p:cNvSpPr>
+            <a:spLocks noGrp="1"/>
+          </p:cNvSpPr>
+          <p:nvPr>
+            <p:ph type="title"/>
+          </p:nvPr>
+        </p:nvSpPr>
+        <p:spPr/>
+        <p:txBody>
+          <a:bodyPr/>
+          <a:lstStyle/>
+          <a:p>
+            <a:r>
+              <a:rPr lang="en-US" dirty="0"/>
+              <a:t>Most Important Features</a:t>
+            </a:r>
+          </a:p>
+        </p:txBody>
+      </p:sp>
+      <p:pic>
+        <p:nvPicPr>
+          <p:cNvPr id="21" name="Content Placeholder 20">
+            <a:extLst>
+              <a:ext uri="{FF2B5EF4-FFF2-40B4-BE49-F238E27FC236}">
+                <a16:creationId xmlns:a16="http://schemas.microsoft.com/office/drawing/2014/main" id="{379C6459-76C1-EF31-6F51-72B105D0816F}"/>
+              </a:ext>
+            </a:extLst>
+          </p:cNvPr>
+          <p:cNvPicPr>
+            <a:picLocks noGrp="1" noChangeAspect="1"/>
+          </p:cNvPicPr>
+          <p:nvPr>
+            <p:ph idx="1"/>
+          </p:nvPr>
+        </p:nvPicPr>
+        <p:blipFill>
+          <a:blip r:embed="rId2"/>
+          <a:stretch>
+            <a:fillRect/>
+          </a:stretch>
+        </p:blipFill>
+        <p:spPr>
+          <a:xfrm>
+            <a:off x="5259573" y="457200"/>
+            <a:ext cx="6092639" cy="6092639"/>
+          </a:xfrm>
+          <a:prstGeom prst="rect">
+            <a:avLst/>
+          </a:prstGeom>
+        </p:spPr>
+      </p:pic>
+      <p:sp>
+        <p:nvSpPr>
+          <p:cNvPr id="20" name="Text Placeholder 19">
+            <a:extLst>
+              <a:ext uri="{FF2B5EF4-FFF2-40B4-BE49-F238E27FC236}">
+                <a16:creationId xmlns:a16="http://schemas.microsoft.com/office/drawing/2014/main" id="{324D3443-D685-4E03-A761-E6642B63759E}"/>
+              </a:ext>
+            </a:extLst>
+          </p:cNvPr>
+          <p:cNvSpPr>
+            <a:spLocks noGrp="1"/>
+          </p:cNvSpPr>
+          <p:nvPr>
+            <p:ph type="body" sz="half" idx="2"/>
+          </p:nvPr>
+        </p:nvSpPr>
+        <p:spPr/>
+        <p:txBody>
+          <a:bodyPr/>
+          <a:lstStyle/>
+          <a:p>
+            <a:pPr marL="285750" indent="-285750">
+              <a:buFont typeface="Arial" panose="020B0604020202020204" pitchFamily="34" charset="0"/>
+              <a:buChar char="•"/>
+            </a:pPr>
+            <a:r>
+              <a:rPr lang="en-US" dirty="0"/>
+              <a:t>Top regression features may differ from the highest PC loadings, but they support the same narrative</a:t>
+            </a:r>
+          </a:p>
+          <a:p>
+            <a:pPr marL="285750" indent="-285750">
+              <a:buFont typeface="Arial" panose="020B0604020202020204" pitchFamily="34" charset="0"/>
+              <a:buChar char="•"/>
+            </a:pPr>
+            <a:r>
+              <a:rPr lang="en-US" dirty="0"/>
+              <a:t>This narrative centers on institutional capacity, vulnerability, and electricity generation</a:t>
+            </a:r>
+          </a:p>
+        </p:txBody>
+      </p:sp>
+    </p:spTree>
+    <p:extLst>
+      <p:ext uri="{BB962C8B-B14F-4D97-AF65-F5344CB8AC3E}">
+        <p14:creationId xmlns:p14="http://schemas.microsoft.com/office/powerpoint/2010/main" val="1827224500"/>
+      </p:ext>
+    </p:extLst>
+  </p:cSld>
+  <p:clrMapOvr>
+    <a:masterClrMapping/>
+  </p:clrMapOvr>
+</p:sld>
+</file>
+
+<file path=ppt/slides/slide21.xml><?xml version="1.0" encoding="utf-8"?>
+<p:sld xmlns:a="http://schemas.openxmlformats.org/drawingml/2006/main" xmlns:r="http://schemas.openxmlformats.org/officeDocument/2006/relationships" xmlns:p="http://schemas.openxmlformats.org/presentationml/2006/main">
+  <p:cSld>
+    <p:spTree>
+      <p:nvGrpSpPr>
+        <p:cNvPr id="1" name=""/>
+        <p:cNvGrpSpPr/>
+        <p:nvPr/>
+      </p:nvGrpSpPr>
+      <p:grpSpPr>
+        <a:xfrm>
+          <a:off x="0" y="0"/>
+          <a:ext cx="0" cy="0"/>
+          <a:chOff x="0" y="0"/>
+          <a:chExt cx="0" cy="0"/>
+        </a:xfrm>
+      </p:grpSpPr>
+      <p:sp>
+        <p:nvSpPr>
+          <p:cNvPr id="2" name="Title 1">
+            <a:extLst>
+              <a:ext uri="{FF2B5EF4-FFF2-40B4-BE49-F238E27FC236}">
+                <a16:creationId xmlns:a16="http://schemas.microsoft.com/office/drawing/2014/main" id="{98C79100-A6BA-3303-D8F3-5C0747427BFC}"/>
+              </a:ext>
+            </a:extLst>
+          </p:cNvPr>
+          <p:cNvSpPr>
+            <a:spLocks noGrp="1"/>
+          </p:cNvSpPr>
+          <p:nvPr>
+            <p:ph type="title"/>
+          </p:nvPr>
+        </p:nvSpPr>
+        <p:spPr/>
+        <p:txBody>
+          <a:bodyPr/>
+          <a:lstStyle/>
+          <a:p>
+            <a:r>
+              <a:rPr lang="en-US" dirty="0"/>
+              <a:t>Update Feb 23rd</a:t>
+            </a:r>
+          </a:p>
+        </p:txBody>
+      </p:sp>
+      <p:sp>
+        <p:nvSpPr>
+          <p:cNvPr id="3" name="Text Placeholder 2">
+            <a:extLst>
+              <a:ext uri="{FF2B5EF4-FFF2-40B4-BE49-F238E27FC236}">
+                <a16:creationId xmlns:a16="http://schemas.microsoft.com/office/drawing/2014/main" id="{8D03E27C-FEFA-943D-9F18-43099CFCB170}"/>
+              </a:ext>
+            </a:extLst>
+          </p:cNvPr>
+          <p:cNvSpPr>
+            <a:spLocks noGrp="1"/>
+          </p:cNvSpPr>
+          <p:nvPr>
+            <p:ph type="body" idx="1"/>
+          </p:nvPr>
+        </p:nvSpPr>
+        <p:spPr/>
+        <p:txBody>
+          <a:bodyPr/>
+          <a:lstStyle/>
+          <a:p>
+            <a:endParaRPr lang="en-US"/>
+          </a:p>
+        </p:txBody>
+      </p:sp>
+    </p:spTree>
+    <p:extLst>
+      <p:ext uri="{BB962C8B-B14F-4D97-AF65-F5344CB8AC3E}">
+        <p14:creationId xmlns:p14="http://schemas.microsoft.com/office/powerpoint/2010/main" val="3168347470"/>
+      </p:ext>
+    </p:extLst>
+  </p:cSld>
+  <p:clrMapOvr>
+    <a:masterClrMapping/>
+  </p:clrMapOvr>
+</p:sld>
+</file>
+
+<file path=ppt/slides/slide22.xml><?xml version="1.0" encoding="utf-8"?>
+<p:sld xmlns:a="http://schemas.openxmlformats.org/drawingml/2006/main" xmlns:r="http://schemas.openxmlformats.org/officeDocument/2006/relationships" xmlns:p="http://schemas.openxmlformats.org/presentationml/2006/main">
+  <p:cSld>
+    <p:spTree>
+      <p:nvGrpSpPr>
+        <p:cNvPr id="1" name=""/>
+        <p:cNvGrpSpPr/>
+        <p:nvPr/>
+      </p:nvGrpSpPr>
+      <p:grpSpPr>
+        <a:xfrm>
+          <a:off x="0" y="0"/>
+          <a:ext cx="0" cy="0"/>
+          <a:chOff x="0" y="0"/>
+          <a:chExt cx="0" cy="0"/>
+        </a:xfrm>
+      </p:grpSpPr>
+      <p:sp>
+        <p:nvSpPr>
+          <p:cNvPr id="2" name="Title 1">
+            <a:extLst>
+              <a:ext uri="{FF2B5EF4-FFF2-40B4-BE49-F238E27FC236}">
+                <a16:creationId xmlns:a16="http://schemas.microsoft.com/office/drawing/2014/main" id="{16A2CF4C-7674-8F33-7981-CE6C0DC7494A}"/>
+              </a:ext>
+            </a:extLst>
+          </p:cNvPr>
+          <p:cNvSpPr>
+            <a:spLocks noGrp="1"/>
+          </p:cNvSpPr>
+          <p:nvPr>
+            <p:ph type="title"/>
+          </p:nvPr>
+        </p:nvSpPr>
+        <p:spPr/>
+        <p:txBody>
+          <a:bodyPr/>
+          <a:lstStyle/>
+          <a:p>
+            <a:r>
+              <a:rPr lang="en-US" dirty="0"/>
+              <a:t>Reminder of the Top Loading Features per PC</a:t>
+            </a:r>
+          </a:p>
+        </p:txBody>
+      </p:sp>
+      <p:pic>
+        <p:nvPicPr>
+          <p:cNvPr id="6" name="Content Placeholder 5">
+            <a:extLst>
+              <a:ext uri="{FF2B5EF4-FFF2-40B4-BE49-F238E27FC236}">
+                <a16:creationId xmlns:a16="http://schemas.microsoft.com/office/drawing/2014/main" id="{070A67AF-7EAB-2682-8124-0F06D9C99D5D}"/>
+              </a:ext>
+            </a:extLst>
+          </p:cNvPr>
+          <p:cNvPicPr>
+            <a:picLocks noGrp="1" noChangeAspect="1"/>
+          </p:cNvPicPr>
+          <p:nvPr>
+            <p:ph idx="1"/>
+          </p:nvPr>
+        </p:nvPicPr>
+        <p:blipFill>
+          <a:blip r:embed="rId2"/>
+          <a:stretch>
+            <a:fillRect/>
+          </a:stretch>
+        </p:blipFill>
+        <p:spPr>
+          <a:xfrm>
+            <a:off x="5765514" y="987425"/>
+            <a:ext cx="5007547" cy="4873625"/>
+          </a:xfrm>
+          <a:prstGeom prst="rect">
+            <a:avLst/>
+          </a:prstGeom>
+        </p:spPr>
+      </p:pic>
+      <p:sp>
+        <p:nvSpPr>
+          <p:cNvPr id="5" name="Text Placeholder 4">
+            <a:extLst>
+              <a:ext uri="{FF2B5EF4-FFF2-40B4-BE49-F238E27FC236}">
+                <a16:creationId xmlns:a16="http://schemas.microsoft.com/office/drawing/2014/main" id="{BAD9692A-1B9D-176F-9DD3-3D27816EA45A}"/>
+              </a:ext>
+            </a:extLst>
+          </p:cNvPr>
+          <p:cNvSpPr>
+            <a:spLocks noGrp="1"/>
+          </p:cNvSpPr>
+          <p:nvPr>
+            <p:ph type="body" sz="half" idx="2"/>
+          </p:nvPr>
+        </p:nvSpPr>
+        <p:spPr/>
+        <p:txBody>
+          <a:bodyPr/>
+          <a:lstStyle/>
+          <a:p>
+            <a:pPr marL="285750" indent="-285750">
+              <a:buFont typeface="Arial" panose="020B0604020202020204" pitchFamily="34" charset="0"/>
+              <a:buChar char="•"/>
+            </a:pPr>
+            <a:r>
+              <a:rPr lang="en-US" dirty="0"/>
+              <a:t>Features are tied to institutional capacity, policy, vulnerabilities, and how electricity is generated</a:t>
+            </a:r>
+          </a:p>
+          <a:p>
+            <a:pPr marL="285750" indent="-285750">
+              <a:buFont typeface="Arial" panose="020B0604020202020204" pitchFamily="34" charset="0"/>
+              <a:buChar char="•"/>
+            </a:pPr>
+            <a:r>
+              <a:rPr lang="en-US" dirty="0"/>
+              <a:t>Agricultural land and forest areas are also included.</a:t>
+            </a:r>
+          </a:p>
+        </p:txBody>
+      </p:sp>
+    </p:spTree>
+    <p:extLst>
+      <p:ext uri="{BB962C8B-B14F-4D97-AF65-F5344CB8AC3E}">
+        <p14:creationId xmlns:p14="http://schemas.microsoft.com/office/powerpoint/2010/main" val="1900594449"/>
+      </p:ext>
+    </p:extLst>
+  </p:cSld>
+  <p:clrMapOvr>
+    <a:masterClrMapping/>
+  </p:clrMapOvr>
+</p:sld>
+</file>
+
+<file path=ppt/slides/slide23.xml><?xml version="1.0" encoding="utf-8"?>
+<p:sld xmlns:a="http://schemas.openxmlformats.org/drawingml/2006/main" xmlns:r="http://schemas.openxmlformats.org/officeDocument/2006/relationships" xmlns:p="http://schemas.openxmlformats.org/presentationml/2006/main">
+  <p:cSld>
+    <p:spTree>
+      <p:nvGrpSpPr>
+        <p:cNvPr id="1" name="">
+          <a:extLst>
+            <a:ext uri="{FF2B5EF4-FFF2-40B4-BE49-F238E27FC236}">
+              <a16:creationId xmlns:a16="http://schemas.microsoft.com/office/drawing/2014/main" id="{43A5C365-AD37-D215-3CF4-8356F94C4841}"/>
+            </a:ext>
+          </a:extLst>
+        </p:cNvPr>
+        <p:cNvGrpSpPr/>
+        <p:nvPr/>
+      </p:nvGrpSpPr>
+      <p:grpSpPr>
+        <a:xfrm>
+          <a:off x="0" y="0"/>
+          <a:ext cx="0" cy="0"/>
+          <a:chOff x="0" y="0"/>
+          <a:chExt cx="0" cy="0"/>
+        </a:xfrm>
+      </p:grpSpPr>
+      <p:sp>
+        <p:nvSpPr>
+          <p:cNvPr id="2" name="Title 1">
+            <a:extLst>
+              <a:ext uri="{FF2B5EF4-FFF2-40B4-BE49-F238E27FC236}">
+                <a16:creationId xmlns:a16="http://schemas.microsoft.com/office/drawing/2014/main" id="{665D0F65-5A88-316C-653D-679786018E41}"/>
+              </a:ext>
+            </a:extLst>
+          </p:cNvPr>
+          <p:cNvSpPr>
+            <a:spLocks noGrp="1"/>
+          </p:cNvSpPr>
+          <p:nvPr>
+            <p:ph type="title"/>
+          </p:nvPr>
+        </p:nvSpPr>
+        <p:spPr/>
+        <p:txBody>
+          <a:bodyPr/>
+          <a:lstStyle/>
+          <a:p>
+            <a:r>
+              <a:rPr lang="en-US" dirty="0"/>
+              <a:t>Ablation Experiment</a:t>
+            </a:r>
+          </a:p>
+        </p:txBody>
+      </p:sp>
+      <p:pic>
+        <p:nvPicPr>
+          <p:cNvPr id="6" name="Content Placeholder 5">
+            <a:extLst>
+              <a:ext uri="{FF2B5EF4-FFF2-40B4-BE49-F238E27FC236}">
+                <a16:creationId xmlns:a16="http://schemas.microsoft.com/office/drawing/2014/main" id="{31996E05-733A-977B-C625-4AB04843ABC6}"/>
+              </a:ext>
+            </a:extLst>
+          </p:cNvPr>
+          <p:cNvPicPr>
+            <a:picLocks noGrp="1" noChangeAspect="1"/>
+          </p:cNvPicPr>
+          <p:nvPr>
+            <p:ph idx="1"/>
+          </p:nvPr>
+        </p:nvPicPr>
+        <p:blipFill>
+          <a:blip r:embed="rId2"/>
+          <a:stretch>
+            <a:fillRect/>
+          </a:stretch>
+        </p:blipFill>
+        <p:spPr>
+          <a:xfrm>
+            <a:off x="5183188" y="1510074"/>
+            <a:ext cx="6172200" cy="3828326"/>
+          </a:xfrm>
+          <a:prstGeom prst="rect">
+            <a:avLst/>
+          </a:prstGeom>
+        </p:spPr>
+      </p:pic>
+      <p:sp>
+        <p:nvSpPr>
+          <p:cNvPr id="5" name="Text Placeholder 4">
+            <a:extLst>
+              <a:ext uri="{FF2B5EF4-FFF2-40B4-BE49-F238E27FC236}">
+                <a16:creationId xmlns:a16="http://schemas.microsoft.com/office/drawing/2014/main" id="{E86C8ACC-6513-F0C2-63FB-41E8AF250A37}"/>
+              </a:ext>
+            </a:extLst>
+          </p:cNvPr>
+          <p:cNvSpPr>
+            <a:spLocks noGrp="1"/>
+          </p:cNvSpPr>
+          <p:nvPr>
+            <p:ph type="body" sz="half" idx="2"/>
+          </p:nvPr>
+        </p:nvSpPr>
+        <p:spPr/>
+        <p:txBody>
+          <a:bodyPr/>
+          <a:lstStyle/>
+          <a:p>
+            <a:pPr marL="285750" indent="-285750">
+              <a:buFont typeface="Arial" panose="020B0604020202020204" pitchFamily="34" charset="0"/>
+              <a:buChar char="•"/>
+            </a:pPr>
+            <a:r>
+              <a:rPr lang="en-US" dirty="0"/>
+              <a:t>We obtained the unique feature names that appeared in the top 5 loadings for each principal component.</a:t>
+            </a:r>
+          </a:p>
+          <a:p>
+            <a:pPr marL="285750" indent="-285750">
+              <a:buFont typeface="Arial" panose="020B0604020202020204" pitchFamily="34" charset="0"/>
+              <a:buChar char="•"/>
+            </a:pPr>
+            <a:r>
+              <a:rPr lang="en-US" dirty="0"/>
+              <a:t>The experiment consisted of training and evaluating the model iteratively by removing one feature at a time</a:t>
+            </a:r>
+          </a:p>
+          <a:p>
+            <a:pPr marL="285750" indent="-285750">
+              <a:buFont typeface="Arial" panose="020B0604020202020204" pitchFamily="34" charset="0"/>
+              <a:buChar char="•"/>
+            </a:pPr>
+            <a:r>
+              <a:rPr lang="en-US" dirty="0"/>
+              <a:t>The features with the lowest loading and from the last principal components are removed first</a:t>
+            </a:r>
+          </a:p>
+        </p:txBody>
+      </p:sp>
+    </p:spTree>
+    <p:extLst>
+      <p:ext uri="{BB962C8B-B14F-4D97-AF65-F5344CB8AC3E}">
+        <p14:creationId xmlns:p14="http://schemas.microsoft.com/office/powerpoint/2010/main" val="4220539146"/>
+      </p:ext>
+    </p:extLst>
+  </p:cSld>
+  <p:clrMapOvr>
+    <a:masterClrMapping/>
+  </p:clrMapOvr>
+</p:sld>
+</file>
+
+<file path=ppt/slides/slide24.xml><?xml version="1.0" encoding="utf-8"?>
+<p:sld xmlns:a="http://schemas.openxmlformats.org/drawingml/2006/main" xmlns:r="http://schemas.openxmlformats.org/officeDocument/2006/relationships" xmlns:p="http://schemas.openxmlformats.org/presentationml/2006/main">
+  <p:cSld>
+    <p:spTree>
+      <p:nvGrpSpPr>
+        <p:cNvPr id="1" name=""/>
+        <p:cNvGrpSpPr/>
+        <p:nvPr/>
+      </p:nvGrpSpPr>
+      <p:grpSpPr>
+        <a:xfrm>
+          <a:off x="0" y="0"/>
+          <a:ext cx="0" cy="0"/>
+          <a:chOff x="0" y="0"/>
+          <a:chExt cx="0" cy="0"/>
+        </a:xfrm>
+      </p:grpSpPr>
+      <p:sp>
+        <p:nvSpPr>
+          <p:cNvPr id="2" name="Title 1">
+            <a:extLst>
+              <a:ext uri="{FF2B5EF4-FFF2-40B4-BE49-F238E27FC236}">
+                <a16:creationId xmlns:a16="http://schemas.microsoft.com/office/drawing/2014/main" id="{C74ACC1F-501E-AA3D-4B0E-2F51DF0446BB}"/>
+              </a:ext>
+            </a:extLst>
+          </p:cNvPr>
+          <p:cNvSpPr>
+            <a:spLocks noGrp="1"/>
+          </p:cNvSpPr>
+          <p:nvPr>
+            <p:ph type="title"/>
+          </p:nvPr>
+        </p:nvSpPr>
+        <p:spPr/>
+        <p:txBody>
+          <a:bodyPr/>
+          <a:lstStyle/>
+          <a:p>
+            <a:r>
+              <a:rPr lang="en-US" dirty="0"/>
+              <a:t>Ablation Experiment Results</a:t>
+            </a:r>
+          </a:p>
+        </p:txBody>
+      </p:sp>
+      <p:pic>
+        <p:nvPicPr>
+          <p:cNvPr id="4" name="Content Placeholder 3">
+            <a:extLst>
+              <a:ext uri="{FF2B5EF4-FFF2-40B4-BE49-F238E27FC236}">
+                <a16:creationId xmlns:a16="http://schemas.microsoft.com/office/drawing/2014/main" id="{C19A1FFD-4C7E-8517-2411-B7CA08E6D2AD}"/>
+              </a:ext>
+            </a:extLst>
+          </p:cNvPr>
+          <p:cNvPicPr>
+            <a:picLocks noGrp="1" noChangeAspect="1"/>
+          </p:cNvPicPr>
+          <p:nvPr>
+            <p:ph idx="1"/>
+          </p:nvPr>
+        </p:nvPicPr>
+        <p:blipFill>
+          <a:blip r:embed="rId2"/>
+          <a:stretch>
+            <a:fillRect/>
+          </a:stretch>
+        </p:blipFill>
+        <p:spPr>
+          <a:xfrm>
+            <a:off x="3340205" y="1466063"/>
+            <a:ext cx="4833742" cy="5271968"/>
+          </a:xfrm>
+          <a:prstGeom prst="rect">
+            <a:avLst/>
+          </a:prstGeom>
+        </p:spPr>
+      </p:pic>
+    </p:spTree>
+    <p:extLst>
+      <p:ext uri="{BB962C8B-B14F-4D97-AF65-F5344CB8AC3E}">
+        <p14:creationId xmlns:p14="http://schemas.microsoft.com/office/powerpoint/2010/main" val="1631846662"/>
+      </p:ext>
+    </p:extLst>
+  </p:cSld>
+  <p:clrMapOvr>
+    <a:masterClrMapping/>
+  </p:clrMapOvr>
+</p:sld>
+</file>
+
+<file path=ppt/slides/slide25.xml><?xml version="1.0" encoding="utf-8"?>
+<p:sld xmlns:a="http://schemas.openxmlformats.org/drawingml/2006/main" xmlns:r="http://schemas.openxmlformats.org/officeDocument/2006/relationships" xmlns:p="http://schemas.openxmlformats.org/presentationml/2006/main">
+  <p:cSld>
+    <p:spTree>
+      <p:nvGrpSpPr>
+        <p:cNvPr id="1" name="">
+          <a:extLst>
+            <a:ext uri="{FF2B5EF4-FFF2-40B4-BE49-F238E27FC236}">
+              <a16:creationId xmlns:a16="http://schemas.microsoft.com/office/drawing/2014/main" id="{C9BDD2E4-886C-8A9D-4923-22976F1B87E0}"/>
+            </a:ext>
+          </a:extLst>
+        </p:cNvPr>
+        <p:cNvGrpSpPr/>
+        <p:nvPr/>
+      </p:nvGrpSpPr>
+      <p:grpSpPr>
+        <a:xfrm>
+          <a:off x="0" y="0"/>
+          <a:ext cx="0" cy="0"/>
+          <a:chOff x="0" y="0"/>
+          <a:chExt cx="0" cy="0"/>
+        </a:xfrm>
+      </p:grpSpPr>
+      <p:sp>
+        <p:nvSpPr>
+          <p:cNvPr id="2" name="Title 1">
+            <a:extLst>
+              <a:ext uri="{FF2B5EF4-FFF2-40B4-BE49-F238E27FC236}">
+                <a16:creationId xmlns:a16="http://schemas.microsoft.com/office/drawing/2014/main" id="{6FD5C40C-364B-C38F-163F-1F1D4911A786}"/>
+              </a:ext>
+            </a:extLst>
+          </p:cNvPr>
+          <p:cNvSpPr>
+            <a:spLocks noGrp="1"/>
+          </p:cNvSpPr>
+          <p:nvPr>
+            <p:ph type="title"/>
+          </p:nvPr>
+        </p:nvSpPr>
+        <p:spPr/>
+        <p:txBody>
+          <a:bodyPr/>
+          <a:lstStyle/>
+          <a:p>
+            <a:r>
+              <a:rPr lang="en-US" dirty="0"/>
+              <a:t>Model Training and Evaluation</a:t>
+            </a:r>
+          </a:p>
+        </p:txBody>
+      </p:sp>
+      <p:pic>
+        <p:nvPicPr>
+          <p:cNvPr id="6" name="Content Placeholder 5">
+            <a:extLst>
+              <a:ext uri="{FF2B5EF4-FFF2-40B4-BE49-F238E27FC236}">
+                <a16:creationId xmlns:a16="http://schemas.microsoft.com/office/drawing/2014/main" id="{FF997CD1-4AB4-969A-28FD-B572E53DCA0F}"/>
+              </a:ext>
+            </a:extLst>
+          </p:cNvPr>
+          <p:cNvPicPr>
+            <a:picLocks noGrp="1" noChangeAspect="1"/>
+          </p:cNvPicPr>
+          <p:nvPr>
+            <p:ph idx="1"/>
+          </p:nvPr>
+        </p:nvPicPr>
+        <p:blipFill>
+          <a:blip r:embed="rId2"/>
+          <a:stretch>
+            <a:fillRect/>
+          </a:stretch>
+        </p:blipFill>
+        <p:spPr>
+          <a:xfrm>
+            <a:off x="6373093" y="995362"/>
+            <a:ext cx="4437272" cy="4873625"/>
+          </a:xfrm>
+          <a:prstGeom prst="rect">
+            <a:avLst/>
+          </a:prstGeom>
+        </p:spPr>
+      </p:pic>
+      <p:sp>
+        <p:nvSpPr>
+          <p:cNvPr id="5" name="Text Placeholder 4">
+            <a:extLst>
+              <a:ext uri="{FF2B5EF4-FFF2-40B4-BE49-F238E27FC236}">
+                <a16:creationId xmlns:a16="http://schemas.microsoft.com/office/drawing/2014/main" id="{CF4F2444-067F-82CC-401F-580093D0C909}"/>
+              </a:ext>
+            </a:extLst>
+          </p:cNvPr>
+          <p:cNvSpPr>
+            <a:spLocks noGrp="1"/>
+          </p:cNvSpPr>
+          <p:nvPr>
+            <p:ph type="body" sz="half" idx="2"/>
+          </p:nvPr>
+        </p:nvSpPr>
+        <p:spPr/>
+        <p:txBody>
+          <a:bodyPr/>
+          <a:lstStyle/>
+          <a:p>
+            <a:pPr marL="285750" indent="-285750">
+              <a:buFont typeface="Arial" panose="020B0604020202020204" pitchFamily="34" charset="0"/>
+              <a:buChar char="•"/>
+            </a:pPr>
+            <a:r>
+              <a:rPr lang="en-US" dirty="0"/>
+              <a:t>We trained the model by removing 7 features from the top loadings set</a:t>
+            </a:r>
+          </a:p>
+          <a:p>
+            <a:pPr marL="285750" indent="-285750">
+              <a:buFont typeface="Arial" panose="020B0604020202020204" pitchFamily="34" charset="0"/>
+              <a:buChar char="•"/>
+            </a:pPr>
+            <a:r>
+              <a:rPr lang="en-US" dirty="0"/>
+              <a:t>When evaluating it we get a similar if not better performance than the original model with correlation filtering</a:t>
+            </a:r>
+          </a:p>
+        </p:txBody>
+      </p:sp>
+      <p:pic>
+        <p:nvPicPr>
+          <p:cNvPr id="7" name="Picture 6">
+            <a:extLst>
+              <a:ext uri="{FF2B5EF4-FFF2-40B4-BE49-F238E27FC236}">
+                <a16:creationId xmlns:a16="http://schemas.microsoft.com/office/drawing/2014/main" id="{6228BFCB-DF0B-4CA7-A5EE-16E6472B3C70}"/>
+              </a:ext>
+            </a:extLst>
+          </p:cNvPr>
+          <p:cNvPicPr>
+            <a:picLocks noChangeAspect="1"/>
+          </p:cNvPicPr>
+          <p:nvPr/>
+        </p:nvPicPr>
+        <p:blipFill>
+          <a:blip r:embed="rId3"/>
+          <a:stretch>
+            <a:fillRect/>
+          </a:stretch>
+        </p:blipFill>
+        <p:spPr>
+          <a:xfrm>
+            <a:off x="290316" y="4893482"/>
+            <a:ext cx="5649506" cy="1029053"/>
+          </a:xfrm>
+          <a:prstGeom prst="rect">
+            <a:avLst/>
+          </a:prstGeom>
+        </p:spPr>
+      </p:pic>
+      <p:pic>
+        <p:nvPicPr>
+          <p:cNvPr id="8" name="Picture 7">
+            <a:extLst>
+              <a:ext uri="{FF2B5EF4-FFF2-40B4-BE49-F238E27FC236}">
+                <a16:creationId xmlns:a16="http://schemas.microsoft.com/office/drawing/2014/main" id="{76095729-D5FE-3354-1679-68B2181054B1}"/>
+              </a:ext>
+            </a:extLst>
+          </p:cNvPr>
+          <p:cNvPicPr>
+            <a:picLocks noChangeAspect="1"/>
+          </p:cNvPicPr>
+          <p:nvPr/>
+        </p:nvPicPr>
+        <p:blipFill>
+          <a:blip r:embed="rId4"/>
+          <a:stretch>
+            <a:fillRect/>
+          </a:stretch>
+        </p:blipFill>
+        <p:spPr>
+          <a:xfrm>
+            <a:off x="290316" y="3488051"/>
+            <a:ext cx="5649506" cy="950286"/>
+          </a:xfrm>
+          <a:prstGeom prst="rect">
+            <a:avLst/>
+          </a:prstGeom>
+        </p:spPr>
+      </p:pic>
+      <mc:AlternateContent xmlns:mc="http://schemas.openxmlformats.org/markup-compatibility/2006" xmlns:p14="http://schemas.microsoft.com/office/powerpoint/2010/main">
+        <mc:Choice Requires="p14">
+          <p:contentPart p14:bwMode="auto" r:id="rId5">
+            <p14:nvContentPartPr>
+              <p14:cNvPr id="9" name="Ink 8">
+                <a:extLst>
+                  <a:ext uri="{FF2B5EF4-FFF2-40B4-BE49-F238E27FC236}">
+                    <a16:creationId xmlns:a16="http://schemas.microsoft.com/office/drawing/2014/main" id="{A4BA9A9B-C3C1-0EF1-91BC-1DF472693607}"/>
+                  </a:ext>
+                </a:extLst>
+              </p14:cNvPr>
+              <p14:cNvContentPartPr/>
+              <p14:nvPr/>
+            </p14:nvContentPartPr>
+            <p14:xfrm>
+              <a:off x="4567046" y="4049905"/>
+              <a:ext cx="1275840" cy="29160"/>
+            </p14:xfrm>
+          </p:contentPart>
+        </mc:Choice>
+        <mc:Fallback xmlns="">
+          <p:pic>
+            <p:nvPicPr>
+              <p:cNvPr id="9" name="Ink 8">
+                <a:extLst>
+                  <a:ext uri="{FF2B5EF4-FFF2-40B4-BE49-F238E27FC236}">
+                    <a16:creationId xmlns:a16="http://schemas.microsoft.com/office/drawing/2014/main" id="{A4BA9A9B-C3C1-0EF1-91BC-1DF472693607}"/>
+                  </a:ext>
+                </a:extLst>
+              </p:cNvPr>
+              <p:cNvPicPr/>
+              <p:nvPr/>
+            </p:nvPicPr>
+            <p:blipFill>
+              <a:blip r:embed="rId6"/>
+              <a:stretch>
+                <a:fillRect/>
+              </a:stretch>
+            </p:blipFill>
+            <p:spPr>
+              <a:xfrm>
+                <a:off x="4560926" y="4043785"/>
+                <a:ext cx="1288080" cy="41400"/>
+              </a:xfrm>
+              <a:prstGeom prst="rect">
+                <a:avLst/>
+              </a:prstGeom>
+            </p:spPr>
+          </p:pic>
+        </mc:Fallback>
+      </mc:AlternateContent>
+      <mc:AlternateContent xmlns:mc="http://schemas.openxmlformats.org/markup-compatibility/2006" xmlns:p14="http://schemas.microsoft.com/office/powerpoint/2010/main">
+        <mc:Choice Requires="p14">
+          <p:contentPart p14:bwMode="auto" r:id="rId7">
+            <p14:nvContentPartPr>
+              <p14:cNvPr id="11" name="Ink 10">
+                <a:extLst>
+                  <a:ext uri="{FF2B5EF4-FFF2-40B4-BE49-F238E27FC236}">
+                    <a16:creationId xmlns:a16="http://schemas.microsoft.com/office/drawing/2014/main" id="{4C955939-FCBA-EC49-5CC5-A087BC224DD0}"/>
+                  </a:ext>
+                </a:extLst>
+              </p14:cNvPr>
+              <p14:cNvContentPartPr/>
+              <p14:nvPr/>
+            </p14:nvContentPartPr>
+            <p14:xfrm>
+              <a:off x="4565606" y="5496745"/>
+              <a:ext cx="1477080" cy="22320"/>
+            </p14:xfrm>
+          </p:contentPart>
+        </mc:Choice>
+        <mc:Fallback xmlns="">
+          <p:pic>
+            <p:nvPicPr>
+              <p:cNvPr id="11" name="Ink 10">
+                <a:extLst>
+                  <a:ext uri="{FF2B5EF4-FFF2-40B4-BE49-F238E27FC236}">
+                    <a16:creationId xmlns:a16="http://schemas.microsoft.com/office/drawing/2014/main" id="{4C955939-FCBA-EC49-5CC5-A087BC224DD0}"/>
+                  </a:ext>
+                </a:extLst>
+              </p:cNvPr>
+              <p:cNvPicPr/>
+              <p:nvPr/>
+            </p:nvPicPr>
+            <p:blipFill>
+              <a:blip r:embed="rId8"/>
+              <a:stretch>
+                <a:fillRect/>
+              </a:stretch>
+            </p:blipFill>
+            <p:spPr>
+              <a:xfrm>
+                <a:off x="4559486" y="5490625"/>
+                <a:ext cx="1489320" cy="34560"/>
+              </a:xfrm>
+              <a:prstGeom prst="rect">
+                <a:avLst/>
+              </a:prstGeom>
+            </p:spPr>
+          </p:pic>
+        </mc:Fallback>
+      </mc:AlternateContent>
+    </p:spTree>
+    <p:extLst>
+      <p:ext uri="{BB962C8B-B14F-4D97-AF65-F5344CB8AC3E}">
+        <p14:creationId xmlns:p14="http://schemas.microsoft.com/office/powerpoint/2010/main" val="3434693182"/>
+      </p:ext>
+    </p:extLst>
+  </p:cSld>
+  <p:clrMapOvr>
+    <a:masterClrMapping/>
+  </p:clrMapOvr>
+</p:sld>
+</file>
+
+<file path=ppt/slides/slide26.xml><?xml version="1.0" encoding="utf-8"?>
+<p:sld xmlns:a="http://schemas.openxmlformats.org/drawingml/2006/main" xmlns:r="http://schemas.openxmlformats.org/officeDocument/2006/relationships" xmlns:p="http://schemas.openxmlformats.org/presentationml/2006/main">
+  <p:cSld>
+    <p:spTree>
+      <p:nvGrpSpPr>
+        <p:cNvPr id="1" name=""/>
+        <p:cNvGrpSpPr/>
+        <p:nvPr/>
+      </p:nvGrpSpPr>
+      <p:grpSpPr>
+        <a:xfrm>
+          <a:off x="0" y="0"/>
+          <a:ext cx="0" cy="0"/>
+          <a:chOff x="0" y="0"/>
+          <a:chExt cx="0" cy="0"/>
+        </a:xfrm>
+      </p:grpSpPr>
+      <p:sp>
+        <p:nvSpPr>
+          <p:cNvPr id="2" name="Title 1">
+            <a:extLst>
+              <a:ext uri="{FF2B5EF4-FFF2-40B4-BE49-F238E27FC236}">
+                <a16:creationId xmlns:a16="http://schemas.microsoft.com/office/drawing/2014/main" id="{7C9924E2-88D8-024C-77F8-16B113C0F966}"/>
+              </a:ext>
+            </a:extLst>
+          </p:cNvPr>
+          <p:cNvSpPr>
+            <a:spLocks noGrp="1"/>
+          </p:cNvSpPr>
+          <p:nvPr>
+            <p:ph type="title"/>
+          </p:nvPr>
+        </p:nvSpPr>
+        <p:spPr/>
+        <p:txBody>
+          <a:bodyPr/>
+          <a:lstStyle/>
+          <a:p>
+            <a:r>
+              <a:rPr lang="en-US" dirty="0"/>
+              <a:t>Top Regressors</a:t>
+            </a:r>
+          </a:p>
+        </p:txBody>
+      </p:sp>
+      <p:pic>
+        <p:nvPicPr>
+          <p:cNvPr id="6" name="Content Placeholder 5">
+            <a:extLst>
+              <a:ext uri="{FF2B5EF4-FFF2-40B4-BE49-F238E27FC236}">
+                <a16:creationId xmlns:a16="http://schemas.microsoft.com/office/drawing/2014/main" id="{EF2BE5C8-0EDD-575C-E51B-C217CEB4A4C2}"/>
+              </a:ext>
+            </a:extLst>
+          </p:cNvPr>
+          <p:cNvPicPr>
+            <a:picLocks noGrp="1" noChangeAspect="1"/>
+          </p:cNvPicPr>
+          <p:nvPr>
+            <p:ph idx="1"/>
+          </p:nvPr>
+        </p:nvPicPr>
+        <p:blipFill>
+          <a:blip r:embed="rId2"/>
+          <a:stretch>
+            <a:fillRect/>
+          </a:stretch>
+        </p:blipFill>
+        <p:spPr>
+          <a:xfrm>
+            <a:off x="5832475" y="987425"/>
+            <a:ext cx="4873625" cy="4873625"/>
+          </a:xfrm>
+          <a:prstGeom prst="rect">
+            <a:avLst/>
+          </a:prstGeom>
+        </p:spPr>
+      </p:pic>
+      <p:sp>
+        <p:nvSpPr>
+          <p:cNvPr id="5" name="Text Placeholder 4">
+            <a:extLst>
+              <a:ext uri="{FF2B5EF4-FFF2-40B4-BE49-F238E27FC236}">
+                <a16:creationId xmlns:a16="http://schemas.microsoft.com/office/drawing/2014/main" id="{FF17DCE7-1039-A6B8-9ADF-55085A244A9C}"/>
+              </a:ext>
+            </a:extLst>
+          </p:cNvPr>
+          <p:cNvSpPr>
+            <a:spLocks noGrp="1"/>
+          </p:cNvSpPr>
+          <p:nvPr>
+            <p:ph type="body" sz="half" idx="2"/>
+          </p:nvPr>
+        </p:nvSpPr>
+        <p:spPr/>
+        <p:txBody>
+          <a:bodyPr/>
+          <a:lstStyle/>
+          <a:p>
+            <a:pPr marL="285750" indent="-285750">
+              <a:buFont typeface="Arial" panose="020B0604020202020204" pitchFamily="34" charset="0"/>
+              <a:buChar char="•"/>
+            </a:pPr>
+            <a:r>
+              <a:rPr lang="en-US" dirty="0"/>
+              <a:t>One key insights it that GDP per capita was filtered out during this process; however it didn’t hurt model performance</a:t>
+            </a:r>
+          </a:p>
+        </p:txBody>
+      </p:sp>
+    </p:spTree>
+    <p:extLst>
+      <p:ext uri="{BB962C8B-B14F-4D97-AF65-F5344CB8AC3E}">
+        <p14:creationId xmlns:p14="http://schemas.microsoft.com/office/powerpoint/2010/main" val="3155841548"/>
+      </p:ext>
+    </p:extLst>
+  </p:cSld>
+  <p:clrMapOvr>
+    <a:masterClrMapping/>
+  </p:clrMapOvr>
+</p:sld>
+</file>
+
+<file path=ppt/slides/slide27.xml><?xml version="1.0" encoding="utf-8"?>
+<p:sld xmlns:a="http://schemas.openxmlformats.org/drawingml/2006/main" xmlns:r="http://schemas.openxmlformats.org/officeDocument/2006/relationships" xmlns:p="http://schemas.openxmlformats.org/presentationml/2006/main">
+  <p:cSld>
+    <p:spTree>
+      <p:nvGrpSpPr>
+        <p:cNvPr id="1" name="">
+          <a:extLst>
+            <a:ext uri="{FF2B5EF4-FFF2-40B4-BE49-F238E27FC236}">
+              <a16:creationId xmlns:a16="http://schemas.microsoft.com/office/drawing/2014/main" id="{39D88556-73B5-93A3-DA89-DAB98F0E775F}"/>
+            </a:ext>
+          </a:extLst>
+        </p:cNvPr>
+        <p:cNvGrpSpPr/>
+        <p:nvPr/>
+      </p:nvGrpSpPr>
+      <p:grpSpPr>
+        <a:xfrm>
+          <a:off x="0" y="0"/>
+          <a:ext cx="0" cy="0"/>
+          <a:chOff x="0" y="0"/>
+          <a:chExt cx="0" cy="0"/>
+        </a:xfrm>
+      </p:grpSpPr>
+      <p:sp>
+        <p:nvSpPr>
+          <p:cNvPr id="2" name="Title 1">
+            <a:extLst>
+              <a:ext uri="{FF2B5EF4-FFF2-40B4-BE49-F238E27FC236}">
+                <a16:creationId xmlns:a16="http://schemas.microsoft.com/office/drawing/2014/main" id="{00C50877-98F1-549E-6EFA-DD91AC91A551}"/>
+              </a:ext>
+            </a:extLst>
+          </p:cNvPr>
+          <p:cNvSpPr>
+            <a:spLocks noGrp="1"/>
+          </p:cNvSpPr>
+          <p:nvPr>
+            <p:ph type="title"/>
+          </p:nvPr>
+        </p:nvSpPr>
+        <p:spPr/>
+        <p:txBody>
+          <a:bodyPr/>
+          <a:lstStyle/>
+          <a:p>
+            <a:r>
+              <a:rPr lang="en-US" dirty="0"/>
+              <a:t>Update March 2nd</a:t>
+            </a:r>
+          </a:p>
+        </p:txBody>
+      </p:sp>
+      <p:sp>
+        <p:nvSpPr>
+          <p:cNvPr id="3" name="Text Placeholder 2">
+            <a:extLst>
+              <a:ext uri="{FF2B5EF4-FFF2-40B4-BE49-F238E27FC236}">
+                <a16:creationId xmlns:a16="http://schemas.microsoft.com/office/drawing/2014/main" id="{2217B36E-36CB-0488-EF4D-89A465183160}"/>
+              </a:ext>
+            </a:extLst>
+          </p:cNvPr>
+          <p:cNvSpPr>
+            <a:spLocks noGrp="1"/>
+          </p:cNvSpPr>
+          <p:nvPr>
+            <p:ph type="body" idx="1"/>
+          </p:nvPr>
+        </p:nvSpPr>
+        <p:spPr/>
+        <p:txBody>
+          <a:bodyPr/>
+          <a:lstStyle/>
+          <a:p>
+            <a:endParaRPr lang="en-US"/>
+          </a:p>
+        </p:txBody>
+      </p:sp>
+    </p:spTree>
+    <p:extLst>
+      <p:ext uri="{BB962C8B-B14F-4D97-AF65-F5344CB8AC3E}">
+        <p14:creationId xmlns:p14="http://schemas.microsoft.com/office/powerpoint/2010/main" val="3227908158"/>
+      </p:ext>
+    </p:extLst>
+  </p:cSld>
+  <p:clrMapOvr>
+    <a:masterClrMapping/>
+  </p:clrMapOvr>
+</p:sld>
+</file>
+
+<file path=ppt/slides/slide28.xml><?xml version="1.0" encoding="utf-8"?>
+<p:sld xmlns:a="http://schemas.openxmlformats.org/drawingml/2006/main" xmlns:r="http://schemas.openxmlformats.org/officeDocument/2006/relationships" xmlns:p="http://schemas.openxmlformats.org/presentationml/2006/main">
+  <p:cSld>
+    <p:spTree>
+      <p:nvGrpSpPr>
+        <p:cNvPr id="1" name=""/>
+        <p:cNvGrpSpPr/>
+        <p:nvPr/>
+      </p:nvGrpSpPr>
+      <p:grpSpPr>
+        <a:xfrm>
+          <a:off x="0" y="0"/>
+          <a:ext cx="0" cy="0"/>
+          <a:chOff x="0" y="0"/>
+          <a:chExt cx="0" cy="0"/>
+        </a:xfrm>
+      </p:grpSpPr>
+      <p:sp>
+        <p:nvSpPr>
+          <p:cNvPr id="2" name="Title 1">
+            <a:extLst>
+              <a:ext uri="{FF2B5EF4-FFF2-40B4-BE49-F238E27FC236}">
+                <a16:creationId xmlns:a16="http://schemas.microsoft.com/office/drawing/2014/main" id="{C1D52C3D-0621-2923-4756-2732679AA010}"/>
+              </a:ext>
+            </a:extLst>
+          </p:cNvPr>
+          <p:cNvSpPr>
+            <a:spLocks noGrp="1"/>
+          </p:cNvSpPr>
+          <p:nvPr>
+            <p:ph type="title"/>
+          </p:nvPr>
+        </p:nvSpPr>
+        <p:spPr/>
+        <p:txBody>
+          <a:bodyPr/>
+          <a:lstStyle/>
+          <a:p>
+            <a:r>
+              <a:rPr lang="en-US" dirty="0"/>
+              <a:t>Projected Predictors</a:t>
+            </a:r>
+          </a:p>
+        </p:txBody>
+      </p:sp>
+      <p:pic>
+        <p:nvPicPr>
+          <p:cNvPr id="5" name="Content Placeholder 4">
+            <a:extLst>
+              <a:ext uri="{FF2B5EF4-FFF2-40B4-BE49-F238E27FC236}">
+                <a16:creationId xmlns:a16="http://schemas.microsoft.com/office/drawing/2014/main" id="{06C1DB27-B59F-8813-8C1C-FB7CB4BD24E7}"/>
+              </a:ext>
+            </a:extLst>
+          </p:cNvPr>
+          <p:cNvPicPr>
+            <a:picLocks noGrp="1" noChangeAspect="1"/>
+          </p:cNvPicPr>
+          <p:nvPr>
+            <p:ph idx="1"/>
+          </p:nvPr>
+        </p:nvPicPr>
+        <p:blipFill>
+          <a:blip r:embed="rId2"/>
+          <a:stretch>
+            <a:fillRect/>
+          </a:stretch>
+        </p:blipFill>
+        <p:spPr>
+          <a:xfrm>
+            <a:off x="5183188" y="1208462"/>
+            <a:ext cx="6172200" cy="4431550"/>
+          </a:xfrm>
+          <a:prstGeom prst="rect">
+            <a:avLst/>
+          </a:prstGeom>
+        </p:spPr>
+      </p:pic>
+      <p:sp>
+        <p:nvSpPr>
+          <p:cNvPr id="4" name="Text Placeholder 3">
+            <a:extLst>
+              <a:ext uri="{FF2B5EF4-FFF2-40B4-BE49-F238E27FC236}">
+                <a16:creationId xmlns:a16="http://schemas.microsoft.com/office/drawing/2014/main" id="{B4B7DEAA-7B0C-F8E9-16D5-6A66ACA20181}"/>
+              </a:ext>
+            </a:extLst>
+          </p:cNvPr>
+          <p:cNvSpPr>
+            <a:spLocks noGrp="1"/>
+          </p:cNvSpPr>
+          <p:nvPr>
+            <p:ph type="body" sz="half" idx="2"/>
+          </p:nvPr>
+        </p:nvSpPr>
+        <p:spPr/>
+        <p:txBody>
+          <a:bodyPr/>
+          <a:lstStyle/>
+          <a:p>
+            <a:pPr marL="285750" indent="-285750">
+              <a:buFont typeface="Arial" panose="020B0604020202020204" pitchFamily="34" charset="0"/>
+              <a:buChar char="•"/>
+            </a:pPr>
+            <a:r>
+              <a:rPr lang="en-US" dirty="0"/>
+              <a:t>We created the projections using ARIMA</a:t>
+            </a:r>
+          </a:p>
+          <a:p>
+            <a:pPr marL="285750" indent="-285750">
+              <a:buFont typeface="Arial" panose="020B0604020202020204" pitchFamily="34" charset="0"/>
+              <a:buChar char="•"/>
+            </a:pPr>
+            <a:r>
+              <a:rPr lang="en-US" dirty="0"/>
+              <a:t>The different type of variables are treated properly to create realistic projections</a:t>
+            </a:r>
+          </a:p>
+        </p:txBody>
+      </p:sp>
+    </p:spTree>
+    <p:extLst>
+      <p:ext uri="{BB962C8B-B14F-4D97-AF65-F5344CB8AC3E}">
+        <p14:creationId xmlns:p14="http://schemas.microsoft.com/office/powerpoint/2010/main" val="1957023390"/>
+      </p:ext>
+    </p:extLst>
+  </p:cSld>
+  <p:clrMapOvr>
+    <a:masterClrMapping/>
+  </p:clrMapOvr>
+</p:sld>
+</file>
+
+<file path=ppt/slides/slide29.xml><?xml version="1.0" encoding="utf-8"?>
+<p:sld xmlns:a="http://schemas.openxmlformats.org/drawingml/2006/main" xmlns:r="http://schemas.openxmlformats.org/officeDocument/2006/relationships" xmlns:p="http://schemas.openxmlformats.org/presentationml/2006/main">
+  <p:cSld>
+    <p:spTree>
+      <p:nvGrpSpPr>
+        <p:cNvPr id="1" name=""/>
+        <p:cNvGrpSpPr/>
+        <p:nvPr/>
+      </p:nvGrpSpPr>
+      <p:grpSpPr>
+        <a:xfrm>
+          <a:off x="0" y="0"/>
+          <a:ext cx="0" cy="0"/>
+          <a:chOff x="0" y="0"/>
+          <a:chExt cx="0" cy="0"/>
+        </a:xfrm>
+      </p:grpSpPr>
+      <p:sp>
+        <p:nvSpPr>
+          <p:cNvPr id="2" name="Title 1">
+            <a:extLst>
+              <a:ext uri="{FF2B5EF4-FFF2-40B4-BE49-F238E27FC236}">
+                <a16:creationId xmlns:a16="http://schemas.microsoft.com/office/drawing/2014/main" id="{4CC8E6F7-149B-9DCF-EF81-2A8EF1D4C491}"/>
+              </a:ext>
+            </a:extLst>
+          </p:cNvPr>
+          <p:cNvSpPr>
+            <a:spLocks noGrp="1"/>
+          </p:cNvSpPr>
+          <p:nvPr>
+            <p:ph type="title"/>
+          </p:nvPr>
+        </p:nvSpPr>
+        <p:spPr/>
+        <p:txBody>
+          <a:bodyPr/>
+          <a:lstStyle/>
+          <a:p>
+            <a:r>
+              <a:rPr lang="en-US" dirty="0"/>
+              <a:t>Projected Emissions</a:t>
+            </a:r>
+          </a:p>
+        </p:txBody>
+      </p:sp>
+      <p:pic>
+        <p:nvPicPr>
+          <p:cNvPr id="5" name="Content Placeholder 4">
+            <a:extLst>
+              <a:ext uri="{FF2B5EF4-FFF2-40B4-BE49-F238E27FC236}">
+                <a16:creationId xmlns:a16="http://schemas.microsoft.com/office/drawing/2014/main" id="{28762387-AF1C-F834-A3D5-03F9EC9ACC62}"/>
+              </a:ext>
+            </a:extLst>
+          </p:cNvPr>
+          <p:cNvPicPr>
+            <a:picLocks noGrp="1" noChangeAspect="1"/>
+          </p:cNvPicPr>
+          <p:nvPr>
+            <p:ph idx="1"/>
+          </p:nvPr>
+        </p:nvPicPr>
+        <p:blipFill>
+          <a:blip r:embed="rId2"/>
+          <a:stretch>
+            <a:fillRect/>
+          </a:stretch>
+        </p:blipFill>
+        <p:spPr>
+          <a:xfrm>
+            <a:off x="5183188" y="1206867"/>
+            <a:ext cx="6172200" cy="4434741"/>
+          </a:xfrm>
+          <a:prstGeom prst="rect">
+            <a:avLst/>
+          </a:prstGeom>
+        </p:spPr>
+      </p:pic>
+      <p:sp>
+        <p:nvSpPr>
+          <p:cNvPr id="4" name="Text Placeholder 3">
+            <a:extLst>
+              <a:ext uri="{FF2B5EF4-FFF2-40B4-BE49-F238E27FC236}">
+                <a16:creationId xmlns:a16="http://schemas.microsoft.com/office/drawing/2014/main" id="{326D66F3-8875-5A46-7E41-E78B86A6CE28}"/>
+              </a:ext>
+            </a:extLst>
+          </p:cNvPr>
+          <p:cNvSpPr>
+            <a:spLocks noGrp="1"/>
+          </p:cNvSpPr>
+          <p:nvPr>
+            <p:ph type="body" sz="half" idx="2"/>
+          </p:nvPr>
+        </p:nvSpPr>
+        <p:spPr/>
+        <p:txBody>
+          <a:bodyPr/>
+          <a:lstStyle/>
+          <a:p>
+            <a:pPr marL="285750" indent="-285750">
+              <a:buFont typeface="Arial" panose="020B0604020202020204" pitchFamily="34" charset="0"/>
+              <a:buChar char="•"/>
+            </a:pPr>
+            <a:r>
+              <a:rPr lang="en-US" dirty="0"/>
+              <a:t>With the trained model we predicted future emissions using the projected features</a:t>
+            </a:r>
+          </a:p>
+          <a:p>
+            <a:pPr marL="285750" indent="-285750">
+              <a:buFont typeface="Arial" panose="020B0604020202020204" pitchFamily="34" charset="0"/>
+              <a:buChar char="•"/>
+            </a:pPr>
+            <a:r>
+              <a:rPr lang="en-US" dirty="0"/>
+              <a:t>We use the hp filter to clean the trajectories</a:t>
+            </a:r>
+          </a:p>
+        </p:txBody>
+      </p:sp>
+    </p:spTree>
+    <p:extLst>
+      <p:ext uri="{BB962C8B-B14F-4D97-AF65-F5344CB8AC3E}">
+        <p14:creationId xmlns:p14="http://schemas.microsoft.com/office/powerpoint/2010/main" val="1081841949"/>
       </p:ext>
     </p:extLst>
   </p:cSld>
@@ -4483,6 +7407,714 @@
     <p:extLst>
       <p:ext uri="{BB962C8B-B14F-4D97-AF65-F5344CB8AC3E}">
         <p14:creationId xmlns:p14="http://schemas.microsoft.com/office/powerpoint/2010/main" val="1543584040"/>
+      </p:ext>
+    </p:extLst>
+  </p:cSld>
+  <p:clrMapOvr>
+    <a:masterClrMapping/>
+  </p:clrMapOvr>
+</p:sld>
+</file>
+
+<file path=ppt/slides/slide30.xml><?xml version="1.0" encoding="utf-8"?>
+<p:sld xmlns:a="http://schemas.openxmlformats.org/drawingml/2006/main" xmlns:r="http://schemas.openxmlformats.org/officeDocument/2006/relationships" xmlns:p="http://schemas.openxmlformats.org/presentationml/2006/main">
+  <p:cSld>
+    <p:spTree>
+      <p:nvGrpSpPr>
+        <p:cNvPr id="1" name=""/>
+        <p:cNvGrpSpPr/>
+        <p:nvPr/>
+      </p:nvGrpSpPr>
+      <p:grpSpPr>
+        <a:xfrm>
+          <a:off x="0" y="0"/>
+          <a:ext cx="0" cy="0"/>
+          <a:chOff x="0" y="0"/>
+          <a:chExt cx="0" cy="0"/>
+        </a:xfrm>
+      </p:grpSpPr>
+      <p:sp>
+        <p:nvSpPr>
+          <p:cNvPr id="2" name="Title 1">
+            <a:extLst>
+              <a:ext uri="{FF2B5EF4-FFF2-40B4-BE49-F238E27FC236}">
+                <a16:creationId xmlns:a16="http://schemas.microsoft.com/office/drawing/2014/main" id="{4E32873B-C312-4684-E692-9A1C57AD39AC}"/>
+              </a:ext>
+            </a:extLst>
+          </p:cNvPr>
+          <p:cNvSpPr>
+            <a:spLocks noGrp="1"/>
+          </p:cNvSpPr>
+          <p:nvPr>
+            <p:ph type="title"/>
+          </p:nvPr>
+        </p:nvSpPr>
+        <p:spPr/>
+        <p:txBody>
+          <a:bodyPr/>
+          <a:lstStyle/>
+          <a:p>
+            <a:r>
+              <a:rPr lang="en-US" dirty="0"/>
+              <a:t>The following are preliminary results since we’re missing data for key countries</a:t>
+            </a:r>
+          </a:p>
+        </p:txBody>
+      </p:sp>
+      <p:pic>
+        <p:nvPicPr>
+          <p:cNvPr id="4" name="Content Placeholder 3">
+            <a:extLst>
+              <a:ext uri="{FF2B5EF4-FFF2-40B4-BE49-F238E27FC236}">
+                <a16:creationId xmlns:a16="http://schemas.microsoft.com/office/drawing/2014/main" id="{BE1E93A3-AD8A-1470-884D-237FD1A102F6}"/>
+              </a:ext>
+            </a:extLst>
+          </p:cNvPr>
+          <p:cNvPicPr>
+            <a:picLocks noGrp="1" noChangeAspect="1"/>
+          </p:cNvPicPr>
+          <p:nvPr>
+            <p:ph idx="1"/>
+          </p:nvPr>
+        </p:nvPicPr>
+        <p:blipFill>
+          <a:blip r:embed="rId2"/>
+          <a:stretch>
+            <a:fillRect/>
+          </a:stretch>
+        </p:blipFill>
+        <p:spPr>
+          <a:xfrm>
+            <a:off x="4989805" y="1825625"/>
+            <a:ext cx="2212389" cy="4351338"/>
+          </a:xfrm>
+          <a:prstGeom prst="rect">
+            <a:avLst/>
+          </a:prstGeom>
+        </p:spPr>
+      </p:pic>
+    </p:spTree>
+    <p:extLst>
+      <p:ext uri="{BB962C8B-B14F-4D97-AF65-F5344CB8AC3E}">
+        <p14:creationId xmlns:p14="http://schemas.microsoft.com/office/powerpoint/2010/main" val="2940752447"/>
+      </p:ext>
+    </p:extLst>
+  </p:cSld>
+  <p:clrMapOvr>
+    <a:masterClrMapping/>
+  </p:clrMapOvr>
+</p:sld>
+</file>
+
+<file path=ppt/slides/slide31.xml><?xml version="1.0" encoding="utf-8"?>
+<p:sld xmlns:a="http://schemas.openxmlformats.org/drawingml/2006/main" xmlns:r="http://schemas.openxmlformats.org/officeDocument/2006/relationships" xmlns:p="http://schemas.openxmlformats.org/presentationml/2006/main">
+  <p:cSld>
+    <p:spTree>
+      <p:nvGrpSpPr>
+        <p:cNvPr id="1" name="">
+          <a:extLst>
+            <a:ext uri="{FF2B5EF4-FFF2-40B4-BE49-F238E27FC236}">
+              <a16:creationId xmlns:a16="http://schemas.microsoft.com/office/drawing/2014/main" id="{D4C090F7-EE2D-C654-1F4B-FBEDBDF9A5C7}"/>
+            </a:ext>
+          </a:extLst>
+        </p:cNvPr>
+        <p:cNvGrpSpPr/>
+        <p:nvPr/>
+      </p:nvGrpSpPr>
+      <p:grpSpPr>
+        <a:xfrm>
+          <a:off x="0" y="0"/>
+          <a:ext cx="0" cy="0"/>
+          <a:chOff x="0" y="0"/>
+          <a:chExt cx="0" cy="0"/>
+        </a:xfrm>
+      </p:grpSpPr>
+      <p:sp>
+        <p:nvSpPr>
+          <p:cNvPr id="2" name="Title 1">
+            <a:extLst>
+              <a:ext uri="{FF2B5EF4-FFF2-40B4-BE49-F238E27FC236}">
+                <a16:creationId xmlns:a16="http://schemas.microsoft.com/office/drawing/2014/main" id="{B0B601CF-6BE4-C866-E9AF-C8C68B73822A}"/>
+              </a:ext>
+            </a:extLst>
+          </p:cNvPr>
+          <p:cNvSpPr>
+            <a:spLocks noGrp="1"/>
+          </p:cNvSpPr>
+          <p:nvPr>
+            <p:ph type="title"/>
+          </p:nvPr>
+        </p:nvSpPr>
+        <p:spPr/>
+        <p:txBody>
+          <a:bodyPr>
+            <a:normAutofit fontScale="90000"/>
+          </a:bodyPr>
+          <a:lstStyle/>
+          <a:p>
+            <a:r>
+              <a:rPr lang="en-US" dirty="0"/>
+              <a:t>Also… Some important countries have 0 chance of meeting their targets which means that we might need to adjust the ARIMA projections</a:t>
+            </a:r>
+          </a:p>
+        </p:txBody>
+      </p:sp>
+      <p:pic>
+        <p:nvPicPr>
+          <p:cNvPr id="6" name="Content Placeholder 5">
+            <a:extLst>
+              <a:ext uri="{FF2B5EF4-FFF2-40B4-BE49-F238E27FC236}">
+                <a16:creationId xmlns:a16="http://schemas.microsoft.com/office/drawing/2014/main" id="{02BF9E56-5A73-6F21-A565-9CA342F978F2}"/>
+              </a:ext>
+            </a:extLst>
+          </p:cNvPr>
+          <p:cNvPicPr>
+            <a:picLocks noGrp="1" noChangeAspect="1"/>
+          </p:cNvPicPr>
+          <p:nvPr>
+            <p:ph idx="1"/>
+          </p:nvPr>
+        </p:nvPicPr>
+        <p:blipFill>
+          <a:blip r:embed="rId2"/>
+          <a:stretch>
+            <a:fillRect/>
+          </a:stretch>
+        </p:blipFill>
+        <p:spPr>
+          <a:xfrm>
+            <a:off x="838200" y="2544411"/>
+            <a:ext cx="10515600" cy="2913765"/>
+          </a:xfrm>
+          <a:prstGeom prst="rect">
+            <a:avLst/>
+          </a:prstGeom>
+        </p:spPr>
+      </p:pic>
+    </p:spTree>
+    <p:extLst>
+      <p:ext uri="{BB962C8B-B14F-4D97-AF65-F5344CB8AC3E}">
+        <p14:creationId xmlns:p14="http://schemas.microsoft.com/office/powerpoint/2010/main" val="3994820284"/>
+      </p:ext>
+    </p:extLst>
+  </p:cSld>
+  <p:clrMapOvr>
+    <a:masterClrMapping/>
+  </p:clrMapOvr>
+</p:sld>
+</file>
+
+<file path=ppt/slides/slide32.xml><?xml version="1.0" encoding="utf-8"?>
+<p:sld xmlns:a="http://schemas.openxmlformats.org/drawingml/2006/main" xmlns:r="http://schemas.openxmlformats.org/officeDocument/2006/relationships" xmlns:p="http://schemas.openxmlformats.org/presentationml/2006/main">
+  <p:cSld>
+    <p:spTree>
+      <p:nvGrpSpPr>
+        <p:cNvPr id="1" name=""/>
+        <p:cNvGrpSpPr/>
+        <p:nvPr/>
+      </p:nvGrpSpPr>
+      <p:grpSpPr>
+        <a:xfrm>
+          <a:off x="0" y="0"/>
+          <a:ext cx="0" cy="0"/>
+          <a:chOff x="0" y="0"/>
+          <a:chExt cx="0" cy="0"/>
+        </a:xfrm>
+      </p:grpSpPr>
+      <p:sp>
+        <p:nvSpPr>
+          <p:cNvPr id="2" name="Title 1">
+            <a:extLst>
+              <a:ext uri="{FF2B5EF4-FFF2-40B4-BE49-F238E27FC236}">
+                <a16:creationId xmlns:a16="http://schemas.microsoft.com/office/drawing/2014/main" id="{A28942FE-1D96-9096-18AF-30064B2022EA}"/>
+              </a:ext>
+            </a:extLst>
+          </p:cNvPr>
+          <p:cNvSpPr>
+            <a:spLocks noGrp="1"/>
+          </p:cNvSpPr>
+          <p:nvPr>
+            <p:ph type="title"/>
+          </p:nvPr>
+        </p:nvSpPr>
+        <p:spPr/>
+        <p:txBody>
+          <a:bodyPr/>
+          <a:lstStyle/>
+          <a:p>
+            <a:r>
+              <a:rPr lang="en-US" dirty="0"/>
+              <a:t>Distribution of the probability of meeting the NDC target</a:t>
+            </a:r>
+          </a:p>
+        </p:txBody>
+      </p:sp>
+      <p:pic>
+        <p:nvPicPr>
+          <p:cNvPr id="5" name="Content Placeholder 4">
+            <a:extLst>
+              <a:ext uri="{FF2B5EF4-FFF2-40B4-BE49-F238E27FC236}">
+                <a16:creationId xmlns:a16="http://schemas.microsoft.com/office/drawing/2014/main" id="{5BA24438-48D5-E376-CEF4-7A6707C0B3E6}"/>
+              </a:ext>
+            </a:extLst>
+          </p:cNvPr>
+          <p:cNvPicPr>
+            <a:picLocks noGrp="1" noChangeAspect="1"/>
+          </p:cNvPicPr>
+          <p:nvPr>
+            <p:ph idx="1"/>
+          </p:nvPr>
+        </p:nvPicPr>
+        <p:blipFill>
+          <a:blip r:embed="rId2"/>
+          <a:stretch>
+            <a:fillRect/>
+          </a:stretch>
+        </p:blipFill>
+        <p:spPr>
+          <a:xfrm>
+            <a:off x="838200" y="1927945"/>
+            <a:ext cx="10515600" cy="4146697"/>
+          </a:xfrm>
+          <a:prstGeom prst="rect">
+            <a:avLst/>
+          </a:prstGeom>
+        </p:spPr>
+      </p:pic>
+    </p:spTree>
+    <p:extLst>
+      <p:ext uri="{BB962C8B-B14F-4D97-AF65-F5344CB8AC3E}">
+        <p14:creationId xmlns:p14="http://schemas.microsoft.com/office/powerpoint/2010/main" val="2258832268"/>
+      </p:ext>
+    </p:extLst>
+  </p:cSld>
+  <p:clrMapOvr>
+    <a:masterClrMapping/>
+  </p:clrMapOvr>
+</p:sld>
+</file>
+
+<file path=ppt/slides/slide33.xml><?xml version="1.0" encoding="utf-8"?>
+<p:sld xmlns:a="http://schemas.openxmlformats.org/drawingml/2006/main" xmlns:r="http://schemas.openxmlformats.org/officeDocument/2006/relationships" xmlns:p="http://schemas.openxmlformats.org/presentationml/2006/main">
+  <p:cSld>
+    <p:spTree>
+      <p:nvGrpSpPr>
+        <p:cNvPr id="1" name=""/>
+        <p:cNvGrpSpPr/>
+        <p:nvPr/>
+      </p:nvGrpSpPr>
+      <p:grpSpPr>
+        <a:xfrm>
+          <a:off x="0" y="0"/>
+          <a:ext cx="0" cy="0"/>
+          <a:chOff x="0" y="0"/>
+          <a:chExt cx="0" cy="0"/>
+        </a:xfrm>
+      </p:grpSpPr>
+      <p:sp>
+        <p:nvSpPr>
+          <p:cNvPr id="2" name="Title 1">
+            <a:extLst>
+              <a:ext uri="{FF2B5EF4-FFF2-40B4-BE49-F238E27FC236}">
+                <a16:creationId xmlns:a16="http://schemas.microsoft.com/office/drawing/2014/main" id="{73C4029D-DB94-B392-D6E8-7EA8431B82F7}"/>
+              </a:ext>
+            </a:extLst>
+          </p:cNvPr>
+          <p:cNvSpPr>
+            <a:spLocks noGrp="1"/>
+          </p:cNvSpPr>
+          <p:nvPr>
+            <p:ph type="title"/>
+          </p:nvPr>
+        </p:nvSpPr>
+        <p:spPr/>
+        <p:txBody>
+          <a:bodyPr/>
+          <a:lstStyle/>
+          <a:p>
+            <a:r>
+              <a:rPr lang="en-US" dirty="0"/>
+              <a:t>What’s the share of countries that meet certain probability?</a:t>
+            </a:r>
+          </a:p>
+        </p:txBody>
+      </p:sp>
+      <p:pic>
+        <p:nvPicPr>
+          <p:cNvPr id="5" name="Content Placeholder 4">
+            <a:extLst>
+              <a:ext uri="{FF2B5EF4-FFF2-40B4-BE49-F238E27FC236}">
+                <a16:creationId xmlns:a16="http://schemas.microsoft.com/office/drawing/2014/main" id="{CBE7D58C-A315-AEB1-5868-1D037F853F16}"/>
+              </a:ext>
+            </a:extLst>
+          </p:cNvPr>
+          <p:cNvPicPr>
+            <a:picLocks noGrp="1" noChangeAspect="1"/>
+          </p:cNvPicPr>
+          <p:nvPr>
+            <p:ph idx="1"/>
+          </p:nvPr>
+        </p:nvPicPr>
+        <p:blipFill>
+          <a:blip r:embed="rId2"/>
+          <a:stretch>
+            <a:fillRect/>
+          </a:stretch>
+        </p:blipFill>
+        <p:spPr>
+          <a:xfrm>
+            <a:off x="2804603" y="1825625"/>
+            <a:ext cx="6582793" cy="4351338"/>
+          </a:xfrm>
+          <a:prstGeom prst="rect">
+            <a:avLst/>
+          </a:prstGeom>
+        </p:spPr>
+      </p:pic>
+    </p:spTree>
+    <p:extLst>
+      <p:ext uri="{BB962C8B-B14F-4D97-AF65-F5344CB8AC3E}">
+        <p14:creationId xmlns:p14="http://schemas.microsoft.com/office/powerpoint/2010/main" val="3801329524"/>
+      </p:ext>
+    </p:extLst>
+  </p:cSld>
+  <p:clrMapOvr>
+    <a:masterClrMapping/>
+  </p:clrMapOvr>
+</p:sld>
+</file>
+
+<file path=ppt/slides/slide34.xml><?xml version="1.0" encoding="utf-8"?>
+<p:sld xmlns:a="http://schemas.openxmlformats.org/drawingml/2006/main" xmlns:r="http://schemas.openxmlformats.org/officeDocument/2006/relationships" xmlns:p="http://schemas.openxmlformats.org/presentationml/2006/main">
+  <p:cSld>
+    <p:spTree>
+      <p:nvGrpSpPr>
+        <p:cNvPr id="1" name=""/>
+        <p:cNvGrpSpPr/>
+        <p:nvPr/>
+      </p:nvGrpSpPr>
+      <p:grpSpPr>
+        <a:xfrm>
+          <a:off x="0" y="0"/>
+          <a:ext cx="0" cy="0"/>
+          <a:chOff x="0" y="0"/>
+          <a:chExt cx="0" cy="0"/>
+        </a:xfrm>
+      </p:grpSpPr>
+      <p:sp>
+        <p:nvSpPr>
+          <p:cNvPr id="2" name="Title 1">
+            <a:extLst>
+              <a:ext uri="{FF2B5EF4-FFF2-40B4-BE49-F238E27FC236}">
+                <a16:creationId xmlns:a16="http://schemas.microsoft.com/office/drawing/2014/main" id="{EDC72093-C0EE-93E5-DFFA-A166E93B9C9F}"/>
+              </a:ext>
+            </a:extLst>
+          </p:cNvPr>
+          <p:cNvSpPr>
+            <a:spLocks noGrp="1"/>
+          </p:cNvSpPr>
+          <p:nvPr>
+            <p:ph type="title"/>
+          </p:nvPr>
+        </p:nvSpPr>
+        <p:spPr/>
+        <p:txBody>
+          <a:bodyPr/>
+          <a:lstStyle/>
+          <a:p>
+            <a:r>
+              <a:rPr lang="en-US" dirty="0"/>
+              <a:t>Update March 9th</a:t>
+            </a:r>
+          </a:p>
+        </p:txBody>
+      </p:sp>
+      <p:sp>
+        <p:nvSpPr>
+          <p:cNvPr id="3" name="Text Placeholder 2">
+            <a:extLst>
+              <a:ext uri="{FF2B5EF4-FFF2-40B4-BE49-F238E27FC236}">
+                <a16:creationId xmlns:a16="http://schemas.microsoft.com/office/drawing/2014/main" id="{255A3F91-5E4D-C5E6-7245-534CECF34111}"/>
+              </a:ext>
+            </a:extLst>
+          </p:cNvPr>
+          <p:cNvSpPr>
+            <a:spLocks noGrp="1"/>
+          </p:cNvSpPr>
+          <p:nvPr>
+            <p:ph type="body" idx="1"/>
+          </p:nvPr>
+        </p:nvSpPr>
+        <p:spPr/>
+        <p:txBody>
+          <a:bodyPr/>
+          <a:lstStyle/>
+          <a:p>
+            <a:endParaRPr lang="en-US"/>
+          </a:p>
+        </p:txBody>
+      </p:sp>
+    </p:spTree>
+    <p:extLst>
+      <p:ext uri="{BB962C8B-B14F-4D97-AF65-F5344CB8AC3E}">
+        <p14:creationId xmlns:p14="http://schemas.microsoft.com/office/powerpoint/2010/main" val="738790301"/>
+      </p:ext>
+    </p:extLst>
+  </p:cSld>
+  <p:clrMapOvr>
+    <a:masterClrMapping/>
+  </p:clrMapOvr>
+</p:sld>
+</file>
+
+<file path=ppt/slides/slide35.xml><?xml version="1.0" encoding="utf-8"?>
+<p:sld xmlns:a="http://schemas.openxmlformats.org/drawingml/2006/main" xmlns:r="http://schemas.openxmlformats.org/officeDocument/2006/relationships" xmlns:p="http://schemas.openxmlformats.org/presentationml/2006/main">
+  <p:cSld>
+    <p:spTree>
+      <p:nvGrpSpPr>
+        <p:cNvPr id="1" name=""/>
+        <p:cNvGrpSpPr/>
+        <p:nvPr/>
+      </p:nvGrpSpPr>
+      <p:grpSpPr>
+        <a:xfrm>
+          <a:off x="0" y="0"/>
+          <a:ext cx="0" cy="0"/>
+          <a:chOff x="0" y="0"/>
+          <a:chExt cx="0" cy="0"/>
+        </a:xfrm>
+      </p:grpSpPr>
+      <p:sp>
+        <p:nvSpPr>
+          <p:cNvPr id="2" name="Title 1">
+            <a:extLst>
+              <a:ext uri="{FF2B5EF4-FFF2-40B4-BE49-F238E27FC236}">
+                <a16:creationId xmlns:a16="http://schemas.microsoft.com/office/drawing/2014/main" id="{E6FC1957-B5CB-A43F-A479-C75A19E8A354}"/>
+              </a:ext>
+            </a:extLst>
+          </p:cNvPr>
+          <p:cNvSpPr>
+            <a:spLocks noGrp="1"/>
+          </p:cNvSpPr>
+          <p:nvPr>
+            <p:ph type="title"/>
+          </p:nvPr>
+        </p:nvSpPr>
+        <p:spPr/>
+        <p:txBody>
+          <a:bodyPr/>
+          <a:lstStyle/>
+          <a:p>
+            <a:endParaRPr lang="en-US"/>
+          </a:p>
+        </p:txBody>
+      </p:sp>
+      <p:pic>
+        <p:nvPicPr>
+          <p:cNvPr id="4" name="Content Placeholder 3">
+            <a:extLst>
+              <a:ext uri="{FF2B5EF4-FFF2-40B4-BE49-F238E27FC236}">
+                <a16:creationId xmlns:a16="http://schemas.microsoft.com/office/drawing/2014/main" id="{6311DEE5-3B7A-E784-A5CF-533825ACF6CE}"/>
+              </a:ext>
+            </a:extLst>
+          </p:cNvPr>
+          <p:cNvPicPr>
+            <a:picLocks noGrp="1" noChangeAspect="1"/>
+          </p:cNvPicPr>
+          <p:nvPr>
+            <p:ph idx="1"/>
+          </p:nvPr>
+        </p:nvPicPr>
+        <p:blipFill>
+          <a:blip r:embed="rId2"/>
+          <a:stretch>
+            <a:fillRect/>
+          </a:stretch>
+        </p:blipFill>
+        <p:spPr>
+          <a:xfrm>
+            <a:off x="838200" y="1927945"/>
+            <a:ext cx="10515600" cy="4146697"/>
+          </a:xfrm>
+          <a:prstGeom prst="rect">
+            <a:avLst/>
+          </a:prstGeom>
+        </p:spPr>
+      </p:pic>
+    </p:spTree>
+    <p:extLst>
+      <p:ext uri="{BB962C8B-B14F-4D97-AF65-F5344CB8AC3E}">
+        <p14:creationId xmlns:p14="http://schemas.microsoft.com/office/powerpoint/2010/main" val="1947702034"/>
+      </p:ext>
+    </p:extLst>
+  </p:cSld>
+  <p:clrMapOvr>
+    <a:masterClrMapping/>
+  </p:clrMapOvr>
+</p:sld>
+</file>
+
+<file path=ppt/slides/slide36.xml><?xml version="1.0" encoding="utf-8"?>
+<p:sld xmlns:a="http://schemas.openxmlformats.org/drawingml/2006/main" xmlns:r="http://schemas.openxmlformats.org/officeDocument/2006/relationships" xmlns:p="http://schemas.openxmlformats.org/presentationml/2006/main">
+  <p:cSld>
+    <p:spTree>
+      <p:nvGrpSpPr>
+        <p:cNvPr id="1" name=""/>
+        <p:cNvGrpSpPr/>
+        <p:nvPr/>
+      </p:nvGrpSpPr>
+      <p:grpSpPr>
+        <a:xfrm>
+          <a:off x="0" y="0"/>
+          <a:ext cx="0" cy="0"/>
+          <a:chOff x="0" y="0"/>
+          <a:chExt cx="0" cy="0"/>
+        </a:xfrm>
+      </p:grpSpPr>
+      <p:sp>
+        <p:nvSpPr>
+          <p:cNvPr id="2" name="Title 1">
+            <a:extLst>
+              <a:ext uri="{FF2B5EF4-FFF2-40B4-BE49-F238E27FC236}">
+                <a16:creationId xmlns:a16="http://schemas.microsoft.com/office/drawing/2014/main" id="{307535F3-5256-B24D-20B6-3F552AF00561}"/>
+              </a:ext>
+            </a:extLst>
+          </p:cNvPr>
+          <p:cNvSpPr>
+            <a:spLocks noGrp="1"/>
+          </p:cNvSpPr>
+          <p:nvPr>
+            <p:ph type="title"/>
+          </p:nvPr>
+        </p:nvSpPr>
+        <p:spPr/>
+        <p:txBody>
+          <a:bodyPr/>
+          <a:lstStyle/>
+          <a:p>
+            <a:endParaRPr lang="en-US"/>
+          </a:p>
+        </p:txBody>
+      </p:sp>
+      <p:pic>
+        <p:nvPicPr>
+          <p:cNvPr id="4" name="Content Placeholder 3">
+            <a:extLst>
+              <a:ext uri="{FF2B5EF4-FFF2-40B4-BE49-F238E27FC236}">
+                <a16:creationId xmlns:a16="http://schemas.microsoft.com/office/drawing/2014/main" id="{466A7E0F-852C-DC14-B8A1-958241874CD9}"/>
+              </a:ext>
+            </a:extLst>
+          </p:cNvPr>
+          <p:cNvPicPr>
+            <a:picLocks noGrp="1" noChangeAspect="1"/>
+          </p:cNvPicPr>
+          <p:nvPr>
+            <p:ph idx="1"/>
+          </p:nvPr>
+        </p:nvPicPr>
+        <p:blipFill>
+          <a:blip r:embed="rId2"/>
+          <a:stretch>
+            <a:fillRect/>
+          </a:stretch>
+        </p:blipFill>
+        <p:spPr>
+          <a:xfrm>
+            <a:off x="2804603" y="1825625"/>
+            <a:ext cx="6582793" cy="4351338"/>
+          </a:xfrm>
+          <a:prstGeom prst="rect">
+            <a:avLst/>
+          </a:prstGeom>
+        </p:spPr>
+      </p:pic>
+    </p:spTree>
+    <p:extLst>
+      <p:ext uri="{BB962C8B-B14F-4D97-AF65-F5344CB8AC3E}">
+        <p14:creationId xmlns:p14="http://schemas.microsoft.com/office/powerpoint/2010/main" val="1465921985"/>
+      </p:ext>
+    </p:extLst>
+  </p:cSld>
+  <p:clrMapOvr>
+    <a:masterClrMapping/>
+  </p:clrMapOvr>
+</p:sld>
+</file>
+
+<file path=ppt/slides/slide37.xml><?xml version="1.0" encoding="utf-8"?>
+<p:sld xmlns:a="http://schemas.openxmlformats.org/drawingml/2006/main" xmlns:r="http://schemas.openxmlformats.org/officeDocument/2006/relationships" xmlns:p="http://schemas.openxmlformats.org/presentationml/2006/main">
+  <p:cSld>
+    <p:spTree>
+      <p:nvGrpSpPr>
+        <p:cNvPr id="1" name=""/>
+        <p:cNvGrpSpPr/>
+        <p:nvPr/>
+      </p:nvGrpSpPr>
+      <p:grpSpPr>
+        <a:xfrm>
+          <a:off x="0" y="0"/>
+          <a:ext cx="0" cy="0"/>
+          <a:chOff x="0" y="0"/>
+          <a:chExt cx="0" cy="0"/>
+        </a:xfrm>
+      </p:grpSpPr>
+      <p:sp>
+        <p:nvSpPr>
+          <p:cNvPr id="4" name="Title 3">
+            <a:extLst>
+              <a:ext uri="{FF2B5EF4-FFF2-40B4-BE49-F238E27FC236}">
+                <a16:creationId xmlns:a16="http://schemas.microsoft.com/office/drawing/2014/main" id="{DEF8DAE2-D5C9-A10E-C942-68FDB6C878FB}"/>
+              </a:ext>
+            </a:extLst>
+          </p:cNvPr>
+          <p:cNvSpPr>
+            <a:spLocks noGrp="1"/>
+          </p:cNvSpPr>
+          <p:nvPr>
+            <p:ph type="title"/>
+          </p:nvPr>
+        </p:nvSpPr>
+        <p:spPr/>
+        <p:txBody>
+          <a:bodyPr/>
+          <a:lstStyle/>
+          <a:p>
+            <a:r>
+              <a:rPr lang="en-US" dirty="0"/>
+              <a:t>Let’s Check the Projections</a:t>
+            </a:r>
+          </a:p>
+        </p:txBody>
+      </p:sp>
+      <p:sp>
+        <p:nvSpPr>
+          <p:cNvPr id="5" name="Text Placeholder 4">
+            <a:extLst>
+              <a:ext uri="{FF2B5EF4-FFF2-40B4-BE49-F238E27FC236}">
+                <a16:creationId xmlns:a16="http://schemas.microsoft.com/office/drawing/2014/main" id="{29AB6A7B-148E-9E38-F5CA-87B3E8DED32F}"/>
+              </a:ext>
+            </a:extLst>
+          </p:cNvPr>
+          <p:cNvSpPr>
+            <a:spLocks noGrp="1"/>
+          </p:cNvSpPr>
+          <p:nvPr>
+            <p:ph type="body" idx="1"/>
+          </p:nvPr>
+        </p:nvSpPr>
+        <p:spPr/>
+        <p:txBody>
+          <a:bodyPr/>
+          <a:lstStyle/>
+          <a:p>
+            <a:endParaRPr lang="en-US"/>
+          </a:p>
+        </p:txBody>
+      </p:sp>
+    </p:spTree>
+    <p:extLst>
+      <p:ext uri="{BB962C8B-B14F-4D97-AF65-F5344CB8AC3E}">
+        <p14:creationId xmlns:p14="http://schemas.microsoft.com/office/powerpoint/2010/main" val="762224534"/>
       </p:ext>
     </p:extLst>
   </p:cSld>
@@ -5345,4 +8977,319 @@
     </a:ext>
   </a:extLst>
 </a:theme>
+</file>
+
+<file path=ppt/theme/theme2.xml><?xml version="1.0" encoding="utf-8"?>
+<a:theme xmlns:a="http://schemas.openxmlformats.org/drawingml/2006/main" name="Office Theme">
+  <a:themeElements>
+    <a:clrScheme name="Office">
+      <a:dk1>
+        <a:sysClr val="windowText" lastClr="000000"/>
+      </a:dk1>
+      <a:lt1>
+        <a:sysClr val="window" lastClr="FFFFFF"/>
+      </a:lt1>
+      <a:dk2>
+        <a:srgbClr val="0E2841"/>
+      </a:dk2>
+      <a:lt2>
+        <a:srgbClr val="E8E8E8"/>
+      </a:lt2>
+      <a:accent1>
+        <a:srgbClr val="156082"/>
+      </a:accent1>
+      <a:accent2>
+        <a:srgbClr val="E97132"/>
+      </a:accent2>
+      <a:accent3>
+        <a:srgbClr val="196B24"/>
+      </a:accent3>
+      <a:accent4>
+        <a:srgbClr val="0F9ED5"/>
+      </a:accent4>
+      <a:accent5>
+        <a:srgbClr val="A02B93"/>
+      </a:accent5>
+      <a:accent6>
+        <a:srgbClr val="4EA72E"/>
+      </a:accent6>
+      <a:hlink>
+        <a:srgbClr val="467886"/>
+      </a:hlink>
+      <a:folHlink>
+        <a:srgbClr val="96607D"/>
+      </a:folHlink>
+    </a:clrScheme>
+    <a:fontScheme name="Office">
+      <a:majorFont>
+        <a:latin typeface="Aptos Display" panose="02110004020202020204"/>
+        <a:ea typeface=""/>
+        <a:cs typeface=""/>
+        <a:font script="Jpan" typeface="游ゴシック Light"/>
+        <a:font script="Hang" typeface="맑은 고딕"/>
+        <a:font script="Hans" typeface="等线 Light"/>
+        <a:font script="Hant" typeface="新細明體"/>
+        <a:font script="Arab" typeface="Times New Roman"/>
+        <a:font script="Hebr" typeface="Times New Roman"/>
+        <a:font script="Thai" typeface="Angsana New"/>
+        <a:font script="Ethi" typeface="Nyala"/>
+        <a:font script="Beng" typeface="Vrinda"/>
+        <a:font script="Gujr" typeface="Shruti"/>
+        <a:font script="Khmr" typeface="MoolBoran"/>
+        <a:font script="Knda" typeface="Tunga"/>
+        <a:font script="Guru" typeface="Raavi"/>
+        <a:font script="Cans" typeface="Euphemia"/>
+        <a:font script="Cher" typeface="Plantagenet Cherokee"/>
+        <a:font script="Yiii" typeface="Microsoft Yi Baiti"/>
+        <a:font script="Tibt" typeface="Microsoft Himalaya"/>
+        <a:font script="Thaa" typeface="MV Boli"/>
+        <a:font script="Deva" typeface="Mangal"/>
+        <a:font script="Telu" typeface="Gautami"/>
+        <a:font script="Taml" typeface="Latha"/>
+        <a:font script="Syrc" typeface="Estrangelo Edessa"/>
+        <a:font script="Orya" typeface="Kalinga"/>
+        <a:font script="Mlym" typeface="Kartika"/>
+        <a:font script="Laoo" typeface="DokChampa"/>
+        <a:font script="Sinh" typeface="Iskoola Pota"/>
+        <a:font script="Mong" typeface="Mongolian Baiti"/>
+        <a:font script="Viet" typeface="Times New Roman"/>
+        <a:font script="Uigh" typeface="Microsoft Uighur"/>
+        <a:font script="Geor" typeface="Sylfaen"/>
+        <a:font script="Armn" typeface="Arial"/>
+        <a:font script="Bugi" typeface="Leelawadee UI"/>
+        <a:font script="Bopo" typeface="Microsoft JhengHei"/>
+        <a:font script="Java" typeface="Javanese Text"/>
+        <a:font script="Lisu" typeface="Segoe UI"/>
+        <a:font script="Mymr" typeface="Myanmar Text"/>
+        <a:font script="Nkoo" typeface="Ebrima"/>
+        <a:font script="Olck" typeface="Nirmala UI"/>
+        <a:font script="Osma" typeface="Ebrima"/>
+        <a:font script="Phag" typeface="Phagspa"/>
+        <a:font script="Syrn" typeface="Estrangelo Edessa"/>
+        <a:font script="Syrj" typeface="Estrangelo Edessa"/>
+        <a:font script="Syre" typeface="Estrangelo Edessa"/>
+        <a:font script="Sora" typeface="Nirmala UI"/>
+        <a:font script="Tale" typeface="Microsoft Tai Le"/>
+        <a:font script="Talu" typeface="Microsoft New Tai Lue"/>
+        <a:font script="Tfng" typeface="Ebrima"/>
+      </a:majorFont>
+      <a:minorFont>
+        <a:latin typeface="Aptos" panose="02110004020202020204"/>
+        <a:ea typeface=""/>
+        <a:cs typeface=""/>
+        <a:font script="Jpan" typeface="游ゴシック"/>
+        <a:font script="Hang" typeface="맑은 고딕"/>
+        <a:font script="Hans" typeface="等线"/>
+        <a:font script="Hant" typeface="新細明體"/>
+        <a:font script="Arab" typeface="Arial"/>
+        <a:font script="Hebr" typeface="Arial"/>
+        <a:font script="Thai" typeface="Cordia New"/>
+        <a:font script="Ethi" typeface="Nyala"/>
+        <a:font script="Beng" typeface="Vrinda"/>
+        <a:font script="Gujr" typeface="Shruti"/>
+        <a:font script="Khmr" typeface="DaunPenh"/>
+        <a:font script="Knda" typeface="Tunga"/>
+        <a:font script="Guru" typeface="Raavi"/>
+        <a:font script="Cans" typeface="Euphemia"/>
+        <a:font script="Cher" typeface="Plantagenet Cherokee"/>
+        <a:font script="Yiii" typeface="Microsoft Yi Baiti"/>
+        <a:font script="Tibt" typeface="Microsoft Himalaya"/>
+        <a:font script="Thaa" typeface="MV Boli"/>
+        <a:font script="Deva" typeface="Mangal"/>
+        <a:font script="Telu" typeface="Gautami"/>
+        <a:font script="Taml" typeface="Latha"/>
+        <a:font script="Syrc" typeface="Estrangelo Edessa"/>
+        <a:font script="Orya" typeface="Kalinga"/>
+        <a:font script="Mlym" typeface="Kartika"/>
+        <a:font script="Laoo" typeface="DokChampa"/>
+        <a:font script="Sinh" typeface="Iskoola Pota"/>
+        <a:font script="Mong" typeface="Mongolian Baiti"/>
+        <a:font script="Viet" typeface="Arial"/>
+        <a:font script="Uigh" typeface="Microsoft Uighur"/>
+        <a:font script="Geor" typeface="Sylfaen"/>
+        <a:font script="Armn" typeface="Arial"/>
+        <a:font script="Bugi" typeface="Leelawadee UI"/>
+        <a:font script="Bopo" typeface="Microsoft JhengHei"/>
+        <a:font script="Java" typeface="Javanese Text"/>
+        <a:font script="Lisu" typeface="Segoe UI"/>
+        <a:font script="Mymr" typeface="Myanmar Text"/>
+        <a:font script="Nkoo" typeface="Ebrima"/>
+        <a:font script="Olck" typeface="Nirmala UI"/>
+        <a:font script="Osma" typeface="Ebrima"/>
+        <a:font script="Phag" typeface="Phagspa"/>
+        <a:font script="Syrn" typeface="Estrangelo Edessa"/>
+        <a:font script="Syrj" typeface="Estrangelo Edessa"/>
+        <a:font script="Syre" typeface="Estrangelo Edessa"/>
+        <a:font script="Sora" typeface="Nirmala UI"/>
+        <a:font script="Tale" typeface="Microsoft Tai Le"/>
+        <a:font script="Talu" typeface="Microsoft New Tai Lue"/>
+        <a:font script="Tfng" typeface="Ebrima"/>
+      </a:minorFont>
+    </a:fontScheme>
+    <a:fmtScheme name="Office">
+      <a:fillStyleLst>
+        <a:solidFill>
+          <a:schemeClr val="phClr"/>
+        </a:solidFill>
+        <a:gradFill rotWithShape="1">
+          <a:gsLst>
+            <a:gs pos="0">
+              <a:schemeClr val="phClr">
+                <a:lumMod val="110000"/>
+                <a:satMod val="105000"/>
+                <a:tint val="67000"/>
+              </a:schemeClr>
+            </a:gs>
+            <a:gs pos="50000">
+              <a:schemeClr val="phClr">
+                <a:lumMod val="105000"/>
+                <a:satMod val="103000"/>
+                <a:tint val="73000"/>
+              </a:schemeClr>
+            </a:gs>
+            <a:gs pos="100000">
+              <a:schemeClr val="phClr">
+                <a:lumMod val="105000"/>
+                <a:satMod val="109000"/>
+                <a:tint val="81000"/>
+              </a:schemeClr>
+            </a:gs>
+          </a:gsLst>
+          <a:lin ang="5400000" scaled="0"/>
+        </a:gradFill>
+        <a:gradFill rotWithShape="1">
+          <a:gsLst>
+            <a:gs pos="0">
+              <a:schemeClr val="phClr">
+                <a:satMod val="103000"/>
+                <a:lumMod val="102000"/>
+                <a:tint val="94000"/>
+              </a:schemeClr>
+            </a:gs>
+            <a:gs pos="50000">
+              <a:schemeClr val="phClr">
+                <a:satMod val="110000"/>
+                <a:lumMod val="100000"/>
+                <a:shade val="100000"/>
+              </a:schemeClr>
+            </a:gs>
+            <a:gs pos="100000">
+              <a:schemeClr val="phClr">
+                <a:lumMod val="99000"/>
+                <a:satMod val="120000"/>
+                <a:shade val="78000"/>
+              </a:schemeClr>
+            </a:gs>
+          </a:gsLst>
+          <a:lin ang="5400000" scaled="0"/>
+        </a:gradFill>
+      </a:fillStyleLst>
+      <a:lnStyleLst>
+        <a:ln w="12700" cap="flat" cmpd="sng" algn="ctr">
+          <a:solidFill>
+            <a:schemeClr val="phClr"/>
+          </a:solidFill>
+          <a:prstDash val="solid"/>
+          <a:miter lim="800000"/>
+        </a:ln>
+        <a:ln w="19050" cap="flat" cmpd="sng" algn="ctr">
+          <a:solidFill>
+            <a:schemeClr val="phClr"/>
+          </a:solidFill>
+          <a:prstDash val="solid"/>
+          <a:miter lim="800000"/>
+        </a:ln>
+        <a:ln w="25400" cap="flat" cmpd="sng" algn="ctr">
+          <a:solidFill>
+            <a:schemeClr val="phClr"/>
+          </a:solidFill>
+          <a:prstDash val="solid"/>
+          <a:miter lim="800000"/>
+        </a:ln>
+      </a:lnStyleLst>
+      <a:effectStyleLst>
+        <a:effectStyle>
+          <a:effectLst/>
+        </a:effectStyle>
+        <a:effectStyle>
+          <a:effectLst/>
+        </a:effectStyle>
+        <a:effectStyle>
+          <a:effectLst>
+            <a:outerShdw blurRad="57150" dist="19050" dir="5400000" algn="ctr" rotWithShape="0">
+              <a:srgbClr val="000000">
+                <a:alpha val="63000"/>
+              </a:srgbClr>
+            </a:outerShdw>
+          </a:effectLst>
+        </a:effectStyle>
+      </a:effectStyleLst>
+      <a:bgFillStyleLst>
+        <a:solidFill>
+          <a:schemeClr val="phClr"/>
+        </a:solidFill>
+        <a:solidFill>
+          <a:schemeClr val="phClr">
+            <a:tint val="95000"/>
+            <a:satMod val="170000"/>
+          </a:schemeClr>
+        </a:solidFill>
+        <a:gradFill rotWithShape="1">
+          <a:gsLst>
+            <a:gs pos="0">
+              <a:schemeClr val="phClr">
+                <a:tint val="93000"/>
+                <a:satMod val="150000"/>
+                <a:shade val="98000"/>
+                <a:lumMod val="102000"/>
+              </a:schemeClr>
+            </a:gs>
+            <a:gs pos="50000">
+              <a:schemeClr val="phClr">
+                <a:tint val="98000"/>
+                <a:satMod val="130000"/>
+                <a:shade val="90000"/>
+                <a:lumMod val="103000"/>
+              </a:schemeClr>
+            </a:gs>
+            <a:gs pos="100000">
+              <a:schemeClr val="phClr">
+                <a:shade val="63000"/>
+                <a:satMod val="120000"/>
+              </a:schemeClr>
+            </a:gs>
+          </a:gsLst>
+          <a:lin ang="5400000" scaled="0"/>
+        </a:gradFill>
+      </a:bgFillStyleLst>
+    </a:fmtScheme>
+  </a:themeElements>
+  <a:objectDefaults>
+    <a:lnDef>
+      <a:spPr/>
+      <a:bodyPr/>
+      <a:lstStyle/>
+      <a:style>
+        <a:lnRef idx="2">
+          <a:schemeClr val="accent1"/>
+        </a:lnRef>
+        <a:fillRef idx="0">
+          <a:schemeClr val="accent1"/>
+        </a:fillRef>
+        <a:effectRef idx="1">
+          <a:schemeClr val="accent1"/>
+        </a:effectRef>
+        <a:fontRef idx="minor">
+          <a:schemeClr val="tx1"/>
+        </a:fontRef>
+      </a:style>
+    </a:lnDef>
+  </a:objectDefaults>
+  <a:extraClrSchemeLst/>
+  <a:extLst>
+    <a:ext uri="{05A4C25C-085E-4340-85A3-A5531E510DB2}">
+      <thm15:themeFamily xmlns:thm15="http://schemas.microsoft.com/office/thememl/2012/main" name="Office Theme" id="{2E142A2C-CD16-42D6-873A-C26D2A0506FA}" vid="{1BDDFF52-6CD6-40A5-AB3C-68EB2F1E4D0A}"/>
+    </a:ext>
+  </a:extLst>
+</a:theme>
 </file>
</xml_diff>